<commit_message>
Use official figures for ComfyUI overview slides
</commit_message>
<xml_diff>
--- a/pro5000-4gpu/slides/MiniMax_H3_Real_Time_Inference_NVIDIA_Public_v1.0.pptx
+++ b/pro5000-4gpu/slides/MiniMax_H3_Real_Time_Inference_NVIDIA_Public_v1.0.pptx
@@ -590,7 +590,7 @@
           <a:lstStyle/>
           <a:p>
             <a:r>
-              <a:t>vLLM-Omni extends the vLLM serving model along three axes: omni-modality inputs, execution loops beyond autoregression, and heterogeneous outputs. MiniMax H3 maps to Text Encoder, DiT, and VAE Decoder stages.</a:t>
+              <a:t>The two visuals are copied directly from public vLLM-Omni materials. The official architecture figure defines the serving scope; the PR screenshot proves the ComfyUI frontend integration. PR #9194 remains open, so this slide describes a demonstrated integration rather than a released feature.</a:t>
             </a:r>
           </a:p>
         </p:txBody>
@@ -648,7 +648,7 @@
           <a:lstStyle/>
           <a:p>
             <a:r>
-              <a:t>sm_120 denotes CUDA compute capability 12.0, not the number of SMs. The board has 110 SMs, derived from 14,080 CUDA cores divided by 128 FP32 cores per CC 12.0 SM. Communication intensity is classified by tensor ownership changes, remote bytes, and synchronization frequency.</a:t>
+              <a:t>SM120 provides strong local compute and memory throughput; distributed attention changes tensor ownership and puts the fabric on the dependency path. The 26.9× figure compares raw nominal rates and excludes protocol overhead, topology, contention, and overlap.</a:t>
             </a:r>
           </a:p>
         </p:txBody>
@@ -34273,13 +34273,13 @@
               <a:buNone/>
             </a:pPr>
             <a:r>
-              <a:rPr sz="4800" b="0" i="0">
+              <a:rPr sz="3400" b="0" i="0">
                 <a:solidFill>
                   <a:srgbClr val="757575"/>
                 </a:solidFill>
                 <a:latin typeface="NVIDIA Sans"/>
               </a:rPr>
-              <a:t>One serving layer spans omni-modality inputs, multiple execution loops, and heterogeneous outputs</a:t>
+              <a:t>PR #9194 demonstrates MiniMax-H3 character replacement through a visual graph while stage placement, batching, and parallelism remain inside the serving runtime</a:t>
             </a:r>
           </a:p>
         </p:txBody>
@@ -34309,13 +34309,13 @@
               <a:buNone/>
             </a:pPr>
             <a:r>
-              <a:rPr sz="8800" b="1" i="0">
+              <a:rPr sz="6600" b="1" i="0">
                 <a:solidFill>
                   <a:srgbClr val="000000"/>
                 </a:solidFill>
                 <a:latin typeface="NVIDIA Sans Medium"/>
               </a:rPr>
-              <a:t>vLLM-Omni Extends vLLM Beyond Autoregression</a:t>
+              <a:t>vLLM-Omni Connects ComfyUI Workflows to Multi-GPU Serving</a:t>
             </a:r>
           </a:p>
         </p:txBody>
@@ -34358,7 +34358,7 @@
                 </a:solidFill>
                 <a:latin typeface="NVIDIA Sans"/>
               </a:rPr>
-              <a:t>Source: vLLM-Omni v0.26 public deck, slides 4 and 22–24 · architecture overview · arXiv:2602.02204</a:t>
+              <a:t>Sources: vLLM-Omni v0.26 public deck, slides 22–24 · vLLM-Omni PR #9194 (open)</a:t>
             </a:r>
           </a:p>
         </p:txBody>
@@ -34414,8 +34414,8 @@
         </p:nvSpPr>
         <p:spPr>
           <a:xfrm>
-            <a:off x="2057400" y="5074920"/>
-            <a:ext cx="9875520" cy="475488"/>
+            <a:off x="2057400" y="5029200"/>
+            <a:ext cx="13898880" cy="475488"/>
           </a:xfrm>
           <a:prstGeom prst="rect">
             <a:avLst/>
@@ -34444,21 +34444,45 @@
                 </a:solidFill>
                 <a:latin typeface="NVIDIA Sans Medium"/>
               </a:rPr>
-              <a:t>WHAT vLLM-OMNI ADDS</a:t>
-            </a:r>
-          </a:p>
-        </p:txBody>
-      </p:sp>
-      <p:sp>
-        <p:nvSpPr>
-          <p:cNvPr id="7" name="TextBox 6"/>
+              <a:t>SERVING ARCHITECTURE · OFFICIAL v0.26 FIGURE</a:t>
+            </a:r>
+          </a:p>
+        </p:txBody>
+      </p:sp>
+      <p:pic>
+        <p:nvPicPr>
+          <p:cNvPr id="7" name="Picture 6" descr="vllm-omni-architecture-official.jpeg"/>
+          <p:cNvPicPr>
+            <a:picLocks noChangeAspect="1"/>
+          </p:cNvPicPr>
+          <p:nvPr/>
+        </p:nvPicPr>
+        <p:blipFill>
+          <a:blip r:embed="rId3"/>
+          <a:stretch>
+            <a:fillRect/>
+          </a:stretch>
+        </p:blipFill>
+        <p:spPr>
+          <a:xfrm>
+            <a:off x="2057400" y="5672597"/>
+            <a:ext cx="13898880" cy="7079964"/>
+          </a:xfrm>
+          <a:prstGeom prst="rect">
+            <a:avLst/>
+          </a:prstGeom>
+        </p:spPr>
+      </p:pic>
+      <p:sp>
+        <p:nvSpPr>
+          <p:cNvPr id="8" name="TextBox 7"/>
           <p:cNvSpPr txBox="1"/>
           <p:nvPr/>
         </p:nvSpPr>
         <p:spPr>
           <a:xfrm>
-            <a:off x="2057400" y="5989320"/>
-            <a:ext cx="1051560" cy="502920"/>
+            <a:off x="2057400" y="13304520"/>
+            <a:ext cx="13898880" cy="475488"/>
           </a:xfrm>
           <a:prstGeom prst="rect">
             <a:avLst/>
@@ -34481,120 +34505,34 @@
               <a:buNone/>
             </a:pPr>
             <a:r>
-              <a:rPr sz="3100" b="1" i="0">
+              <a:rPr sz="2800" b="1" i="0">
                 <a:solidFill>
-                  <a:srgbClr val="1DBBA4"/>
+                  <a:srgbClr val="757575"/>
                 </a:solidFill>
                 <a:latin typeface="NVIDIA Sans Medium"/>
               </a:rPr>
-              <a:t>01</a:t>
-            </a:r>
-          </a:p>
-        </p:txBody>
-      </p:sp>
-      <p:sp>
-        <p:nvSpPr>
-          <p:cNvPr id="8" name="TextBox 7"/>
-          <p:cNvSpPr txBox="1"/>
-          <p:nvPr/>
-        </p:nvSpPr>
-        <p:spPr>
-          <a:xfrm>
-            <a:off x="3337560" y="5971032"/>
-            <a:ext cx="8458200" cy="594360"/>
-          </a:xfrm>
-          <a:prstGeom prst="rect">
-            <a:avLst/>
-          </a:prstGeom>
-          <a:noFill/>
-        </p:spPr>
-        <p:txBody>
-          <a:bodyPr wrap="square" anchor="t" lIns="0" rIns="0" tIns="0" bIns="0">
-            <a:spAutoFit/>
-          </a:bodyPr>
-          <a:lstStyle/>
-          <a:p>
-            <a:pPr algn="l">
-              <a:spcBef>
-                <a:spcPts val="0"/>
-              </a:spcBef>
-              <a:spcAft>
-                <a:spcPts val="0"/>
-              </a:spcAft>
-              <a:buNone/>
-            </a:pPr>
-            <a:r>
-              <a:rPr sz="3500" b="1" i="0">
-                <a:solidFill>
-                  <a:srgbClr val="313131"/>
-                </a:solidFill>
-                <a:latin typeface="NVIDIA Sans Medium"/>
-              </a:rPr>
-              <a:t>Omni-modality</a:t>
-            </a:r>
-          </a:p>
-        </p:txBody>
-      </p:sp>
-      <p:sp>
-        <p:nvSpPr>
-          <p:cNvPr id="9" name="TextBox 8"/>
-          <p:cNvSpPr txBox="1"/>
-          <p:nvPr/>
-        </p:nvSpPr>
-        <p:spPr>
-          <a:xfrm>
-            <a:off x="3337560" y="6684264"/>
-            <a:ext cx="8458200" cy="1005840"/>
-          </a:xfrm>
-          <a:prstGeom prst="rect">
-            <a:avLst/>
-          </a:prstGeom>
-          <a:noFill/>
-        </p:spPr>
-        <p:txBody>
-          <a:bodyPr wrap="square" anchor="t" lIns="0" rIns="0" tIns="0" bIns="0">
-            <a:spAutoFit/>
-          </a:bodyPr>
-          <a:lstStyle/>
-          <a:p>
-            <a:pPr algn="l">
-              <a:spcBef>
-                <a:spcPts val="0"/>
-              </a:spcBef>
-              <a:spcAft>
-                <a:spcPts val="0"/>
-              </a:spcAft>
-              <a:buNone/>
-            </a:pPr>
-            <a:r>
-              <a:rPr sz="2700" b="0" i="0">
-                <a:solidFill>
-                  <a:srgbClr val="757575"/>
-                </a:solidFill>
-                <a:latin typeface="NVIDIA Sans"/>
-              </a:rPr>
-              <a:t>Text, image, audio, and video enter one serving pipeline</a:t>
+              <a:t>WHAT THE SEPARATION ENABLES</a:t>
             </a:r>
           </a:p>
         </p:txBody>
       </p:sp>
       <p:cxnSp>
         <p:nvCxnSpPr>
-          <p:cNvPr id="10" name="Connector 9"/>
+          <p:cNvPr id="9" name="Connector 8"/>
           <p:cNvCxnSpPr/>
           <p:nvPr/>
         </p:nvCxnSpPr>
         <p:spPr>
           <a:xfrm>
-            <a:off x="3337560" y="8092440"/>
-            <a:ext cx="8458200" cy="0"/>
+            <a:off x="2057400" y="14218920"/>
+            <a:ext cx="0" cy="694944"/>
           </a:xfrm>
           <a:prstGeom prst="line">
             <a:avLst/>
           </a:prstGeom>
-          <a:ln w="10160">
+          <a:ln w="38100">
             <a:solidFill>
-              <a:srgbClr val="D9D9D9"/>
+              <a:srgbClr val="76B900"/>
             </a:solidFill>
           </a:ln>
         </p:spPr>
@@ -34615,14 +34553,14 @@
       </p:cxnSp>
       <p:sp>
         <p:nvSpPr>
-          <p:cNvPr id="11" name="TextBox 10"/>
+          <p:cNvPr id="10" name="TextBox 9"/>
           <p:cNvSpPr txBox="1"/>
           <p:nvPr/>
         </p:nvSpPr>
         <p:spPr>
           <a:xfrm>
-            <a:off x="2057400" y="8961120"/>
-            <a:ext cx="1051560" cy="502920"/>
+            <a:off x="2377440" y="14063472"/>
+            <a:ext cx="4160520" cy="411480"/>
           </a:xfrm>
           <a:prstGeom prst="rect">
             <a:avLst/>
@@ -34645,27 +34583,27 @@
               <a:buNone/>
             </a:pPr>
             <a:r>
-              <a:rPr sz="3100" b="1" i="0">
+              <a:rPr sz="2700" b="1" i="0">
                 <a:solidFill>
-                  <a:srgbClr val="952FC6"/>
+                  <a:srgbClr val="76B900"/>
                 </a:solidFill>
                 <a:latin typeface="NVIDIA Sans Medium"/>
               </a:rPr>
-              <a:t>02</a:t>
-            </a:r>
-          </a:p>
-        </p:txBody>
-      </p:sp>
-      <p:sp>
-        <p:nvSpPr>
-          <p:cNvPr id="12" name="TextBox 11"/>
+              <a:t>Visual authoring</a:t>
+            </a:r>
+          </a:p>
+        </p:txBody>
+      </p:sp>
+      <p:sp>
+        <p:nvSpPr>
+          <p:cNvPr id="11" name="TextBox 10"/>
           <p:cNvSpPr txBox="1"/>
           <p:nvPr/>
         </p:nvSpPr>
         <p:spPr>
           <a:xfrm>
-            <a:off x="3337560" y="8942832"/>
-            <a:ext cx="8458200" cy="594360"/>
+            <a:off x="6537960" y="14063472"/>
+            <a:ext cx="9418320" cy="859536"/>
           </a:xfrm>
           <a:prstGeom prst="rect">
             <a:avLst/>
@@ -34688,77 +34626,34 @@
               <a:buNone/>
             </a:pPr>
             <a:r>
-              <a:rPr sz="3500" b="1" i="0">
+              <a:rPr sz="2500" b="0" i="0">
                 <a:solidFill>
                   <a:srgbClr val="313131"/>
                 </a:solidFill>
-                <a:latin typeface="NVIDIA Sans Medium"/>
-              </a:rPr>
-              <a:t>Multiple execution loops</a:t>
-            </a:r>
-          </a:p>
-        </p:txBody>
-      </p:sp>
-      <p:sp>
-        <p:nvSpPr>
-          <p:cNvPr id="13" name="TextBox 12"/>
-          <p:cNvSpPr txBox="1"/>
-          <p:nvPr/>
-        </p:nvSpPr>
-        <p:spPr>
-          <a:xfrm>
-            <a:off x="3337560" y="9656064"/>
-            <a:ext cx="8458200" cy="1005840"/>
-          </a:xfrm>
-          <a:prstGeom prst="rect">
-            <a:avLst/>
-          </a:prstGeom>
-          <a:noFill/>
-        </p:spPr>
-        <p:txBody>
-          <a:bodyPr wrap="square" anchor="t" lIns="0" rIns="0" tIns="0" bIns="0">
-            <a:spAutoFit/>
-          </a:bodyPr>
-          <a:lstStyle/>
-          <a:p>
-            <a:pPr algn="l">
-              <a:spcBef>
-                <a:spcPts val="0"/>
-              </a:spcBef>
-              <a:spcAft>
-                <a:spcPts val="0"/>
-              </a:spcAft>
-              <a:buNone/>
-            </a:pPr>
-            <a:r>
-              <a:rPr sz="2700" b="0" i="0">
-                <a:solidFill>
-                  <a:srgbClr val="757575"/>
-                </a:solidFill>
                 <a:latin typeface="NVIDIA Sans"/>
               </a:rPr>
-              <a:t>AR decoding and DiT denoising follow different schedules</a:t>
+              <a:t>References, LoRA, sampling, and continuation stay editable in ComfyUI.</a:t>
             </a:r>
           </a:p>
         </p:txBody>
       </p:sp>
       <p:cxnSp>
         <p:nvCxnSpPr>
-          <p:cNvPr id="14" name="Connector 13"/>
+          <p:cNvPr id="12" name="Connector 11"/>
           <p:cNvCxnSpPr/>
           <p:nvPr/>
         </p:nvCxnSpPr>
         <p:spPr>
           <a:xfrm>
-            <a:off x="3337560" y="11064240"/>
-            <a:ext cx="8458200" cy="0"/>
+            <a:off x="2057400" y="15471648"/>
+            <a:ext cx="0" cy="694944"/>
           </a:xfrm>
           <a:prstGeom prst="line">
             <a:avLst/>
           </a:prstGeom>
-          <a:ln w="10160">
+          <a:ln w="38100">
             <a:solidFill>
-              <a:srgbClr val="D9D9D9"/>
+              <a:srgbClr val="313131"/>
             </a:solidFill>
           </a:ln>
         </p:spPr>
@@ -34779,14 +34674,14 @@
       </p:cxnSp>
       <p:sp>
         <p:nvSpPr>
-          <p:cNvPr id="15" name="TextBox 14"/>
+          <p:cNvPr id="13" name="TextBox 12"/>
           <p:cNvSpPr txBox="1"/>
           <p:nvPr/>
         </p:nvSpPr>
         <p:spPr>
           <a:xfrm>
-            <a:off x="2057400" y="11932920"/>
-            <a:ext cx="1051560" cy="502920"/>
+            <a:off x="2377440" y="15316200"/>
+            <a:ext cx="4160520" cy="411480"/>
           </a:xfrm>
           <a:prstGeom prst="rect">
             <a:avLst/>
@@ -34809,27 +34704,27 @@
               <a:buNone/>
             </a:pPr>
             <a:r>
-              <a:rPr sz="3100" b="1" i="0">
+              <a:rPr sz="2700" b="1" i="0">
                 <a:solidFill>
-                  <a:srgbClr val="0074DF"/>
+                  <a:srgbClr val="313131"/>
                 </a:solidFill>
                 <a:latin typeface="NVIDIA Sans Medium"/>
               </a:rPr>
-              <a:t>03</a:t>
-            </a:r>
-          </a:p>
-        </p:txBody>
-      </p:sp>
-      <p:sp>
-        <p:nvSpPr>
-          <p:cNvPr id="16" name="TextBox 15"/>
+              <a:t>Serving boundary</a:t>
+            </a:r>
+          </a:p>
+        </p:txBody>
+      </p:sp>
+      <p:sp>
+        <p:nvSpPr>
+          <p:cNvPr id="14" name="TextBox 13"/>
           <p:cNvSpPr txBox="1"/>
           <p:nvPr/>
         </p:nvSpPr>
         <p:spPr>
           <a:xfrm>
-            <a:off x="3337560" y="11914632"/>
-            <a:ext cx="8458200" cy="594360"/>
+            <a:off x="6537960" y="15316200"/>
+            <a:ext cx="9418320" cy="859536"/>
           </a:xfrm>
           <a:prstGeom prst="rect">
             <a:avLst/>
@@ -34852,77 +34747,34 @@
               <a:buNone/>
             </a:pPr>
             <a:r>
-              <a:rPr sz="3500" b="1" i="0">
+              <a:rPr sz="2500" b="0" i="0">
                 <a:solidFill>
                   <a:srgbClr val="313131"/>
                 </a:solidFill>
-                <a:latin typeface="NVIDIA Sans Medium"/>
-              </a:rPr>
-              <a:t>Heterogeneous outputs</a:t>
-            </a:r>
-          </a:p>
-        </p:txBody>
-      </p:sp>
-      <p:sp>
-        <p:nvSpPr>
-          <p:cNvPr id="17" name="TextBox 16"/>
-          <p:cNvSpPr txBox="1"/>
-          <p:nvPr/>
-        </p:nvSpPr>
-        <p:spPr>
-          <a:xfrm>
-            <a:off x="3337560" y="12627864"/>
-            <a:ext cx="8458200" cy="1005840"/>
-          </a:xfrm>
-          <a:prstGeom prst="rect">
-            <a:avLst/>
-          </a:prstGeom>
-          <a:noFill/>
-        </p:spPr>
-        <p:txBody>
-          <a:bodyPr wrap="square" anchor="t" lIns="0" rIns="0" tIns="0" bIns="0">
-            <a:spAutoFit/>
-          </a:bodyPr>
-          <a:lstStyle/>
-          <a:p>
-            <a:pPr algn="l">
-              <a:spcBef>
-                <a:spcPts val="0"/>
-              </a:spcBef>
-              <a:spcAft>
-                <a:spcPts val="0"/>
-              </a:spcAft>
-              <a:buNone/>
-            </a:pPr>
-            <a:r>
-              <a:rPr sz="2700" b="0" i="0">
-                <a:solidFill>
-                  <a:srgbClr val="757575"/>
-                </a:solidFill>
                 <a:latin typeface="NVIDIA Sans"/>
               </a:rPr>
-              <a:t>One request may emit text, image, audio, video, or actions</a:t>
+              <a:t>The graph calls the vLLM-Omni Generate Video endpoint.</a:t>
             </a:r>
           </a:p>
         </p:txBody>
       </p:sp>
       <p:cxnSp>
         <p:nvCxnSpPr>
-          <p:cNvPr id="18" name="Connector 17"/>
+          <p:cNvPr id="15" name="Connector 14"/>
           <p:cNvCxnSpPr/>
           <p:nvPr/>
         </p:nvCxnSpPr>
         <p:spPr>
           <a:xfrm>
-            <a:off x="13030200" y="5074920"/>
-            <a:ext cx="0" cy="9784080"/>
+            <a:off x="2057400" y="16724376"/>
+            <a:ext cx="0" cy="694944"/>
           </a:xfrm>
           <a:prstGeom prst="line">
             <a:avLst/>
           </a:prstGeom>
-          <a:ln w="12700">
+          <a:ln w="38100">
             <a:solidFill>
-              <a:srgbClr val="D9D9D9"/>
+              <a:srgbClr val="0074DF"/>
             </a:solidFill>
           </a:ln>
         </p:spPr>
@@ -34943,14 +34795,14 @@
       </p:cxnSp>
       <p:sp>
         <p:nvSpPr>
-          <p:cNvPr id="19" name="TextBox 18"/>
+          <p:cNvPr id="16" name="TextBox 15"/>
           <p:cNvSpPr txBox="1"/>
           <p:nvPr/>
         </p:nvSpPr>
         <p:spPr>
           <a:xfrm>
-            <a:off x="14264640" y="5074920"/>
-            <a:ext cx="9144000" cy="475488"/>
+            <a:off x="2377440" y="16568928"/>
+            <a:ext cx="4160520" cy="411480"/>
           </a:xfrm>
           <a:prstGeom prst="rect">
             <a:avLst/>
@@ -34973,27 +34825,27 @@
               <a:buNone/>
             </a:pPr>
             <a:r>
-              <a:rPr sz="2800" b="1" i="0">
+              <a:rPr sz="2700" b="1" i="0">
                 <a:solidFill>
-                  <a:srgbClr val="757575"/>
+                  <a:srgbClr val="0074DF"/>
                 </a:solidFill>
                 <a:latin typeface="NVIDIA Sans Medium"/>
               </a:rPr>
-              <a:t>ONE ARCHITECTURE</a:t>
-            </a:r>
-          </a:p>
-        </p:txBody>
-      </p:sp>
-      <p:sp>
-        <p:nvSpPr>
-          <p:cNvPr id="20" name="TextBox 19"/>
+              <a:t>Multi-GPU execution</a:t>
+            </a:r>
+          </a:p>
+        </p:txBody>
+      </p:sp>
+      <p:sp>
+        <p:nvSpPr>
+          <p:cNvPr id="17" name="TextBox 16"/>
           <p:cNvSpPr txBox="1"/>
           <p:nvPr/>
         </p:nvSpPr>
         <p:spPr>
           <a:xfrm>
-            <a:off x="14264640" y="6748272"/>
-            <a:ext cx="3017520" cy="1645920"/>
+            <a:off x="6537960" y="16568928"/>
+            <a:ext cx="9418320" cy="859536"/>
           </a:xfrm>
           <a:prstGeom prst="rect">
             <a:avLst/>
@@ -35001,12 +34853,12 @@
           <a:noFill/>
         </p:spPr>
         <p:txBody>
-          <a:bodyPr wrap="square" anchor="ctr" lIns="0" rIns="0" tIns="0" bIns="0">
+          <a:bodyPr wrap="square" anchor="t" lIns="0" rIns="0" tIns="0" bIns="0">
             <a:spAutoFit/>
           </a:bodyPr>
           <a:lstStyle/>
           <a:p>
-            <a:pPr algn="ctr">
+            <a:pPr algn="l">
               <a:spcBef>
                 <a:spcPts val="0"/>
               </a:spcBef>
@@ -35016,507 +34868,34 @@
               <a:buNone/>
             </a:pPr>
             <a:r>
-              <a:rPr sz="2300" b="1" i="0">
-                <a:solidFill>
-                  <a:srgbClr val="757575"/>
-                </a:solidFill>
-                <a:latin typeface="NVIDIA Sans Medium"/>
-              </a:rPr>
-              <a:t>TEXT · IMAGE</a:t>
-            </a:r>
-          </a:p>
-          <a:p>
-            <a:pPr algn="ctr">
-              <a:spcBef>
-                <a:spcPts val="0"/>
-              </a:spcBef>
-              <a:spcAft>
-                <a:spcPts val="0"/>
-              </a:spcAft>
-              <a:buNone/>
-            </a:pPr>
-            <a:r>
-              <a:rPr sz="2300" b="1" i="0">
-                <a:solidFill>
-                  <a:srgbClr val="757575"/>
-                </a:solidFill>
-                <a:latin typeface="NVIDIA Sans Medium"/>
-              </a:rPr>
-              <a:t>AUDIO · VIDEO</a:t>
-            </a:r>
-          </a:p>
-          <a:p>
-            <a:pPr algn="ctr">
-              <a:spcBef>
-                <a:spcPts val="0"/>
-              </a:spcBef>
-              <a:spcAft>
-                <a:spcPts val="0"/>
-              </a:spcAft>
-              <a:buNone/>
-            </a:pPr>
-            <a:r>
-              <a:rPr sz="2300" b="1" i="0">
-                <a:solidFill>
-                  <a:srgbClr val="757575"/>
-                </a:solidFill>
-                <a:latin typeface="NVIDIA Sans Medium"/>
-              </a:rPr>
-              <a:t>ACTION</a:t>
-            </a:r>
-          </a:p>
-        </p:txBody>
-      </p:sp>
-      <p:sp>
-        <p:nvSpPr>
-          <p:cNvPr id="21" name="Rounded Rectangle 20"/>
-          <p:cNvSpPr/>
-          <p:nvPr/>
-        </p:nvSpPr>
-        <p:spPr>
-          <a:xfrm>
-            <a:off x="17967960" y="6446520"/>
-            <a:ext cx="3566160" cy="2240280"/>
-          </a:xfrm>
-          <a:prstGeom prst="roundRect">
-            <a:avLst/>
-          </a:prstGeom>
-          <a:solidFill>
-            <a:srgbClr val="E9F8F5"/>
-          </a:solidFill>
-          <a:ln w="19050">
-            <a:solidFill>
-              <a:srgbClr val="1DBBA4"/>
-            </a:solidFill>
-          </a:ln>
-        </p:spPr>
-        <p:style>
-          <a:lnRef idx="1">
-            <a:schemeClr val="accent1"/>
-          </a:lnRef>
-          <a:fillRef idx="3">
-            <a:schemeClr val="accent1"/>
-          </a:fillRef>
-          <a:effectRef idx="2">
-            <a:schemeClr val="accent1"/>
-          </a:effectRef>
-          <a:fontRef idx="minor">
-            <a:schemeClr val="lt1"/>
-          </a:fontRef>
-        </p:style>
-        <p:txBody>
-          <a:bodyPr rtlCol="0" anchor="ctr"/>
-          <a:lstStyle/>
-          <a:p>
-            <a:pPr algn="ctr"/>
-          </a:p>
-        </p:txBody>
-      </p:sp>
-      <p:sp>
-        <p:nvSpPr>
-          <p:cNvPr id="22" name="TextBox 21"/>
-          <p:cNvSpPr txBox="1"/>
-          <p:nvPr/>
-        </p:nvSpPr>
-        <p:spPr>
-          <a:xfrm>
-            <a:off x="18187415" y="6611112"/>
-            <a:ext cx="3127248" cy="475488"/>
-          </a:xfrm>
-          <a:prstGeom prst="rect">
-            <a:avLst/>
-          </a:prstGeom>
-          <a:noFill/>
-        </p:spPr>
-        <p:txBody>
-          <a:bodyPr wrap="square" anchor="t" lIns="0" rIns="0" tIns="0" bIns="0">
-            <a:spAutoFit/>
-          </a:bodyPr>
-          <a:lstStyle/>
-          <a:p>
-            <a:pPr algn="ctr">
-              <a:spcBef>
-                <a:spcPts val="0"/>
-              </a:spcBef>
-              <a:spcAft>
-                <a:spcPts val="0"/>
-              </a:spcAft>
-              <a:buNone/>
-            </a:pPr>
-            <a:r>
-              <a:rPr sz="3100" b="1" i="0">
+              <a:rPr sz="2500" b="0" i="0">
                 <a:solidFill>
                   <a:srgbClr val="313131"/>
                 </a:solidFill>
-                <a:latin typeface="NVIDIA Sans Medium"/>
-              </a:rPr>
-              <a:t>Modality</a:t>
-            </a:r>
-          </a:p>
-          <a:p>
-            <a:pPr algn="ctr">
-              <a:spcBef>
-                <a:spcPts val="0"/>
-              </a:spcBef>
-              <a:spcAft>
-                <a:spcPts val="0"/>
-              </a:spcAft>
-              <a:buNone/>
-            </a:pPr>
-            <a:r>
-              <a:rPr sz="3100" b="1" i="0">
-                <a:solidFill>
-                  <a:srgbClr val="313131"/>
-                </a:solidFill>
-                <a:latin typeface="NVIDIA Sans Medium"/>
-              </a:rPr>
-              <a:t>encoders</a:t>
-            </a:r>
-          </a:p>
-        </p:txBody>
-      </p:sp>
-      <p:sp>
-        <p:nvSpPr>
-          <p:cNvPr id="23" name="TextBox 22"/>
-          <p:cNvSpPr txBox="1"/>
-          <p:nvPr/>
-        </p:nvSpPr>
-        <p:spPr>
-          <a:xfrm>
-            <a:off x="18187415" y="7141464"/>
-            <a:ext cx="3127248" cy="1417320"/>
-          </a:xfrm>
-          <a:prstGeom prst="rect">
-            <a:avLst/>
-          </a:prstGeom>
-          <a:noFill/>
-        </p:spPr>
-        <p:txBody>
-          <a:bodyPr wrap="square" anchor="ctr" lIns="0" rIns="0" tIns="0" bIns="0">
-            <a:spAutoFit/>
-          </a:bodyPr>
-          <a:lstStyle/>
-          <a:p>
-            <a:pPr algn="ctr">
-              <a:spcBef>
-                <a:spcPts val="0"/>
-              </a:spcBef>
-              <a:spcAft>
-                <a:spcPts val="0"/>
-              </a:spcAft>
-              <a:buNone/>
-            </a:pPr>
-            <a:r>
-              <a:rPr sz="2400" b="0" i="0">
-                <a:solidFill>
-                  <a:srgbClr val="757575"/>
-                </a:solidFill>
                 <a:latin typeface="NVIDIA Sans"/>
               </a:rPr>
-              <a:t>Whisper · ViT · …</a:t>
-            </a:r>
-          </a:p>
-        </p:txBody>
-      </p:sp>
-      <p:sp>
-        <p:nvSpPr>
-          <p:cNvPr id="24" name="Rounded Rectangle 23"/>
-          <p:cNvSpPr/>
-          <p:nvPr/>
-        </p:nvSpPr>
-        <p:spPr>
-          <a:xfrm>
-            <a:off x="22265640" y="6446520"/>
-            <a:ext cx="2926080" cy="2240280"/>
-          </a:xfrm>
-          <a:prstGeom prst="roundRect">
-            <a:avLst/>
-          </a:prstGeom>
-          <a:solidFill>
-            <a:srgbClr val="F7F7F7"/>
-          </a:solidFill>
-          <a:ln w="19050">
-            <a:solidFill>
-              <a:srgbClr val="313131"/>
-            </a:solidFill>
-          </a:ln>
-        </p:spPr>
-        <p:style>
-          <a:lnRef idx="1">
-            <a:schemeClr val="accent1"/>
-          </a:lnRef>
-          <a:fillRef idx="3">
-            <a:schemeClr val="accent1"/>
-          </a:fillRef>
-          <a:effectRef idx="2">
-            <a:schemeClr val="accent1"/>
-          </a:effectRef>
-          <a:fontRef idx="minor">
-            <a:schemeClr val="lt1"/>
-          </a:fontRef>
-        </p:style>
-        <p:txBody>
-          <a:bodyPr rtlCol="0" anchor="ctr"/>
-          <a:lstStyle/>
-          <a:p>
-            <a:pPr algn="ctr"/>
-          </a:p>
-        </p:txBody>
-      </p:sp>
-      <p:sp>
-        <p:nvSpPr>
-          <p:cNvPr id="25" name="TextBox 24"/>
-          <p:cNvSpPr txBox="1"/>
-          <p:nvPr/>
-        </p:nvSpPr>
-        <p:spPr>
-          <a:xfrm>
-            <a:off x="22485096" y="6611112"/>
-            <a:ext cx="2487168" cy="475488"/>
-          </a:xfrm>
-          <a:prstGeom prst="rect">
-            <a:avLst/>
-          </a:prstGeom>
-          <a:noFill/>
-        </p:spPr>
-        <p:txBody>
-          <a:bodyPr wrap="square" anchor="t" lIns="0" rIns="0" tIns="0" bIns="0">
-            <a:spAutoFit/>
-          </a:bodyPr>
-          <a:lstStyle/>
-          <a:p>
-            <a:pPr algn="ctr">
-              <a:spcBef>
-                <a:spcPts val="0"/>
-              </a:spcBef>
-              <a:spcAft>
-                <a:spcPts val="0"/>
-              </a:spcAft>
-              <a:buNone/>
-            </a:pPr>
-            <a:r>
-              <a:rPr sz="3100" b="1" i="0">
-                <a:solidFill>
-                  <a:srgbClr val="313131"/>
-                </a:solidFill>
-                <a:latin typeface="NVIDIA Sans Medium"/>
-              </a:rPr>
-              <a:t>LLM</a:t>
-            </a:r>
-          </a:p>
-        </p:txBody>
-      </p:sp>
-      <p:sp>
-        <p:nvSpPr>
-          <p:cNvPr id="26" name="TextBox 25"/>
-          <p:cNvSpPr txBox="1"/>
-          <p:nvPr/>
-        </p:nvSpPr>
-        <p:spPr>
-          <a:xfrm>
-            <a:off x="22485096" y="7141464"/>
-            <a:ext cx="2487168" cy="1417320"/>
-          </a:xfrm>
-          <a:prstGeom prst="rect">
-            <a:avLst/>
-          </a:prstGeom>
-          <a:noFill/>
-        </p:spPr>
-        <p:txBody>
-          <a:bodyPr wrap="square" anchor="ctr" lIns="0" rIns="0" tIns="0" bIns="0">
-            <a:spAutoFit/>
-          </a:bodyPr>
-          <a:lstStyle/>
-          <a:p>
-            <a:pPr algn="ctr">
-              <a:spcBef>
-                <a:spcPts val="0"/>
-              </a:spcBef>
-              <a:spcAft>
-                <a:spcPts val="0"/>
-              </a:spcAft>
-              <a:buNone/>
-            </a:pPr>
-            <a:r>
-              <a:rPr sz="2400" b="0" i="0">
-                <a:solidFill>
-                  <a:srgbClr val="757575"/>
-                </a:solidFill>
-                <a:latin typeface="NVIDIA Sans"/>
-              </a:rPr>
-              <a:t>autoregressive</a:t>
-            </a:r>
-          </a:p>
-        </p:txBody>
-      </p:sp>
-      <p:sp>
-        <p:nvSpPr>
-          <p:cNvPr id="27" name="Rounded Rectangle 26"/>
-          <p:cNvSpPr/>
-          <p:nvPr/>
-        </p:nvSpPr>
-        <p:spPr>
-          <a:xfrm>
-            <a:off x="25923240" y="6446520"/>
-            <a:ext cx="3749039" cy="2240280"/>
-          </a:xfrm>
-          <a:prstGeom prst="roundRect">
-            <a:avLst/>
-          </a:prstGeom>
-          <a:solidFill>
-            <a:srgbClr val="F3EBF8"/>
-          </a:solidFill>
-          <a:ln w="19050">
-            <a:solidFill>
-              <a:srgbClr val="952FC6"/>
-            </a:solidFill>
-          </a:ln>
-        </p:spPr>
-        <p:style>
-          <a:lnRef idx="1">
-            <a:schemeClr val="accent1"/>
-          </a:lnRef>
-          <a:fillRef idx="3">
-            <a:schemeClr val="accent1"/>
-          </a:fillRef>
-          <a:effectRef idx="2">
-            <a:schemeClr val="accent1"/>
-          </a:effectRef>
-          <a:fontRef idx="minor">
-            <a:schemeClr val="lt1"/>
-          </a:fontRef>
-        </p:style>
-        <p:txBody>
-          <a:bodyPr rtlCol="0" anchor="ctr"/>
-          <a:lstStyle/>
-          <a:p>
-            <a:pPr algn="ctr"/>
-          </a:p>
-        </p:txBody>
-      </p:sp>
-      <p:sp>
-        <p:nvSpPr>
-          <p:cNvPr id="28" name="TextBox 27"/>
-          <p:cNvSpPr txBox="1"/>
-          <p:nvPr/>
-        </p:nvSpPr>
-        <p:spPr>
-          <a:xfrm>
-            <a:off x="26142696" y="6611112"/>
-            <a:ext cx="3310127" cy="475488"/>
-          </a:xfrm>
-          <a:prstGeom prst="rect">
-            <a:avLst/>
-          </a:prstGeom>
-          <a:noFill/>
-        </p:spPr>
-        <p:txBody>
-          <a:bodyPr wrap="square" anchor="t" lIns="0" rIns="0" tIns="0" bIns="0">
-            <a:spAutoFit/>
-          </a:bodyPr>
-          <a:lstStyle/>
-          <a:p>
-            <a:pPr algn="ctr">
-              <a:spcBef>
-                <a:spcPts val="0"/>
-              </a:spcBef>
-              <a:spcAft>
-                <a:spcPts val="0"/>
-              </a:spcAft>
-              <a:buNone/>
-            </a:pPr>
-            <a:r>
-              <a:rPr sz="3100" b="1" i="0">
-                <a:solidFill>
-                  <a:srgbClr val="313131"/>
-                </a:solidFill>
-                <a:latin typeface="NVIDIA Sans Medium"/>
-              </a:rPr>
-              <a:t>Modality</a:t>
-            </a:r>
-          </a:p>
-          <a:p>
-            <a:pPr algn="ctr">
-              <a:spcBef>
-                <a:spcPts val="0"/>
-              </a:spcBef>
-              <a:spcAft>
-                <a:spcPts val="0"/>
-              </a:spcAft>
-              <a:buNone/>
-            </a:pPr>
-            <a:r>
-              <a:rPr sz="3100" b="1" i="0">
-                <a:solidFill>
-                  <a:srgbClr val="313131"/>
-                </a:solidFill>
-                <a:latin typeface="NVIDIA Sans Medium"/>
-              </a:rPr>
-              <a:t>generator</a:t>
-            </a:r>
-          </a:p>
-        </p:txBody>
-      </p:sp>
-      <p:sp>
-        <p:nvSpPr>
-          <p:cNvPr id="29" name="TextBox 28"/>
-          <p:cNvSpPr txBox="1"/>
-          <p:nvPr/>
-        </p:nvSpPr>
-        <p:spPr>
-          <a:xfrm>
-            <a:off x="26142696" y="7141464"/>
-            <a:ext cx="3310127" cy="1417320"/>
-          </a:xfrm>
-          <a:prstGeom prst="rect">
-            <a:avLst/>
-          </a:prstGeom>
-          <a:noFill/>
-        </p:spPr>
-        <p:txBody>
-          <a:bodyPr wrap="square" anchor="ctr" lIns="0" rIns="0" tIns="0" bIns="0">
-            <a:spAutoFit/>
-          </a:bodyPr>
-          <a:lstStyle/>
-          <a:p>
-            <a:pPr algn="ctr">
-              <a:spcBef>
-                <a:spcPts val="0"/>
-              </a:spcBef>
-              <a:spcAft>
-                <a:spcPts val="0"/>
-              </a:spcAft>
-              <a:buNone/>
-            </a:pPr>
-            <a:r>
-              <a:rPr sz="2400" b="0" i="0">
-                <a:solidFill>
-                  <a:srgbClr val="757575"/>
-                </a:solidFill>
-                <a:latin typeface="NVIDIA Sans"/>
-              </a:rPr>
-              <a:t>DiT · …</a:t>
+              <a:t>Placement and TP / SP / CFG / EP policy remain stage-local.</a:t>
             </a:r>
           </a:p>
         </p:txBody>
       </p:sp>
       <p:cxnSp>
         <p:nvCxnSpPr>
-          <p:cNvPr id="30" name="Connector 29"/>
+          <p:cNvPr id="18" name="Connector 17"/>
           <p:cNvCxnSpPr/>
           <p:nvPr/>
         </p:nvCxnSpPr>
         <p:spPr>
           <a:xfrm>
-            <a:off x="17282160" y="7571231"/>
-            <a:ext cx="475488" cy="0"/>
+            <a:off x="16779240" y="5029200"/>
+            <a:ext cx="0" cy="13002768"/>
           </a:xfrm>
           <a:prstGeom prst="line">
             <a:avLst/>
           </a:prstGeom>
-          <a:ln w="25400">
+          <a:ln w="12700">
             <a:solidFill>
-              <a:srgbClr val="313131"/>
+              <a:srgbClr val="D9D9D9"/>
             </a:solidFill>
           </a:ln>
         </p:spPr>
@@ -35537,409 +34916,14 @@
       </p:cxnSp>
       <p:sp>
         <p:nvSpPr>
-          <p:cNvPr id="31" name="Isosceles Triangle 30"/>
-          <p:cNvSpPr/>
-          <p:nvPr/>
-        </p:nvSpPr>
-        <p:spPr>
-          <a:xfrm rot="5400000">
-            <a:off x="17666208" y="7479792"/>
-            <a:ext cx="182880" cy="182880"/>
-          </a:xfrm>
-          <a:prstGeom prst="triangle">
-            <a:avLst/>
-          </a:prstGeom>
-          <a:solidFill>
-            <a:srgbClr val="313131"/>
-          </a:solidFill>
-          <a:ln>
-            <a:noFill/>
-          </a:ln>
-        </p:spPr>
-        <p:style>
-          <a:lnRef idx="1">
-            <a:schemeClr val="accent1"/>
-          </a:lnRef>
-          <a:fillRef idx="3">
-            <a:schemeClr val="accent1"/>
-          </a:fillRef>
-          <a:effectRef idx="2">
-            <a:schemeClr val="accent1"/>
-          </a:effectRef>
-          <a:fontRef idx="minor">
-            <a:schemeClr val="lt1"/>
-          </a:fontRef>
-        </p:style>
-        <p:txBody>
-          <a:bodyPr rtlCol="0" anchor="ctr"/>
-          <a:lstStyle/>
-          <a:p>
-            <a:pPr algn="ctr"/>
-          </a:p>
-        </p:txBody>
-      </p:sp>
-      <p:cxnSp>
-        <p:nvCxnSpPr>
-          <p:cNvPr id="32" name="Connector 31"/>
-          <p:cNvCxnSpPr/>
-          <p:nvPr/>
-        </p:nvCxnSpPr>
-        <p:spPr>
-          <a:xfrm>
-            <a:off x="21534120" y="7571231"/>
-            <a:ext cx="521208" cy="0"/>
-          </a:xfrm>
-          <a:prstGeom prst="line">
-            <a:avLst/>
-          </a:prstGeom>
-          <a:ln w="25400">
-            <a:solidFill>
-              <a:srgbClr val="313131"/>
-            </a:solidFill>
-          </a:ln>
-        </p:spPr>
-        <p:style>
-          <a:lnRef idx="2">
-            <a:schemeClr val="accent1"/>
-          </a:lnRef>
-          <a:fillRef idx="0">
-            <a:schemeClr val="accent1"/>
-          </a:fillRef>
-          <a:effectRef idx="1">
-            <a:schemeClr val="accent1"/>
-          </a:effectRef>
-          <a:fontRef idx="minor">
-            <a:schemeClr val="tx1"/>
-          </a:fontRef>
-        </p:style>
-      </p:cxnSp>
-      <p:sp>
-        <p:nvSpPr>
-          <p:cNvPr id="33" name="Isosceles Triangle 32"/>
-          <p:cNvSpPr/>
-          <p:nvPr/>
-        </p:nvSpPr>
-        <p:spPr>
-          <a:xfrm rot="5400000">
-            <a:off x="21963888" y="7479792"/>
-            <a:ext cx="182880" cy="182880"/>
-          </a:xfrm>
-          <a:prstGeom prst="triangle">
-            <a:avLst/>
-          </a:prstGeom>
-          <a:solidFill>
-            <a:srgbClr val="313131"/>
-          </a:solidFill>
-          <a:ln>
-            <a:noFill/>
-          </a:ln>
-        </p:spPr>
-        <p:style>
-          <a:lnRef idx="1">
-            <a:schemeClr val="accent1"/>
-          </a:lnRef>
-          <a:fillRef idx="3">
-            <a:schemeClr val="accent1"/>
-          </a:fillRef>
-          <a:effectRef idx="2">
-            <a:schemeClr val="accent1"/>
-          </a:effectRef>
-          <a:fontRef idx="minor">
-            <a:schemeClr val="lt1"/>
-          </a:fontRef>
-        </p:style>
-        <p:txBody>
-          <a:bodyPr rtlCol="0" anchor="ctr"/>
-          <a:lstStyle/>
-          <a:p>
-            <a:pPr algn="ctr"/>
-          </a:p>
-        </p:txBody>
-      </p:sp>
-      <p:cxnSp>
-        <p:nvCxnSpPr>
-          <p:cNvPr id="34" name="Connector 33"/>
-          <p:cNvCxnSpPr/>
-          <p:nvPr/>
-        </p:nvCxnSpPr>
-        <p:spPr>
-          <a:xfrm>
-            <a:off x="25191720" y="7571231"/>
-            <a:ext cx="521208" cy="0"/>
-          </a:xfrm>
-          <a:prstGeom prst="line">
-            <a:avLst/>
-          </a:prstGeom>
-          <a:ln w="25400">
-            <a:solidFill>
-              <a:srgbClr val="313131"/>
-            </a:solidFill>
-          </a:ln>
-        </p:spPr>
-        <p:style>
-          <a:lnRef idx="2">
-            <a:schemeClr val="accent1"/>
-          </a:lnRef>
-          <a:fillRef idx="0">
-            <a:schemeClr val="accent1"/>
-          </a:fillRef>
-          <a:effectRef idx="1">
-            <a:schemeClr val="accent1"/>
-          </a:effectRef>
-          <a:fontRef idx="minor">
-            <a:schemeClr val="tx1"/>
-          </a:fontRef>
-        </p:style>
-      </p:cxnSp>
-      <p:sp>
-        <p:nvSpPr>
-          <p:cNvPr id="35" name="Isosceles Triangle 34"/>
-          <p:cNvSpPr/>
-          <p:nvPr/>
-        </p:nvSpPr>
-        <p:spPr>
-          <a:xfrm rot="5400000">
-            <a:off x="25621488" y="7479792"/>
-            <a:ext cx="182880" cy="182880"/>
-          </a:xfrm>
-          <a:prstGeom prst="triangle">
-            <a:avLst/>
-          </a:prstGeom>
-          <a:solidFill>
-            <a:srgbClr val="313131"/>
-          </a:solidFill>
-          <a:ln>
-            <a:noFill/>
-          </a:ln>
-        </p:spPr>
-        <p:style>
-          <a:lnRef idx="1">
-            <a:schemeClr val="accent1"/>
-          </a:lnRef>
-          <a:fillRef idx="3">
-            <a:schemeClr val="accent1"/>
-          </a:fillRef>
-          <a:effectRef idx="2">
-            <a:schemeClr val="accent1"/>
-          </a:effectRef>
-          <a:fontRef idx="minor">
-            <a:schemeClr val="lt1"/>
-          </a:fontRef>
-        </p:style>
-        <p:txBody>
-          <a:bodyPr rtlCol="0" anchor="ctr"/>
-          <a:lstStyle/>
-          <a:p>
-            <a:pPr algn="ctr"/>
-          </a:p>
-        </p:txBody>
-      </p:sp>
-      <p:cxnSp>
-        <p:nvCxnSpPr>
-          <p:cNvPr id="36" name="Connector 35"/>
-          <p:cNvCxnSpPr/>
-          <p:nvPr/>
-        </p:nvCxnSpPr>
-        <p:spPr>
-          <a:xfrm>
-            <a:off x="29672280" y="7571231"/>
-            <a:ext cx="521208" cy="0"/>
-          </a:xfrm>
-          <a:prstGeom prst="line">
-            <a:avLst/>
-          </a:prstGeom>
-          <a:ln w="25400">
-            <a:solidFill>
-              <a:srgbClr val="313131"/>
-            </a:solidFill>
-          </a:ln>
-        </p:spPr>
-        <p:style>
-          <a:lnRef idx="2">
-            <a:schemeClr val="accent1"/>
-          </a:lnRef>
-          <a:fillRef idx="0">
-            <a:schemeClr val="accent1"/>
-          </a:fillRef>
-          <a:effectRef idx="1">
-            <a:schemeClr val="accent1"/>
-          </a:effectRef>
-          <a:fontRef idx="minor">
-            <a:schemeClr val="tx1"/>
-          </a:fontRef>
-        </p:style>
-      </p:cxnSp>
-      <p:sp>
-        <p:nvSpPr>
-          <p:cNvPr id="37" name="Isosceles Triangle 36"/>
-          <p:cNvSpPr/>
-          <p:nvPr/>
-        </p:nvSpPr>
-        <p:spPr>
-          <a:xfrm rot="5400000">
-            <a:off x="30102048" y="7479792"/>
-            <a:ext cx="182880" cy="182880"/>
-          </a:xfrm>
-          <a:prstGeom prst="triangle">
-            <a:avLst/>
-          </a:prstGeom>
-          <a:solidFill>
-            <a:srgbClr val="313131"/>
-          </a:solidFill>
-          <a:ln>
-            <a:noFill/>
-          </a:ln>
-        </p:spPr>
-        <p:style>
-          <a:lnRef idx="1">
-            <a:schemeClr val="accent1"/>
-          </a:lnRef>
-          <a:fillRef idx="3">
-            <a:schemeClr val="accent1"/>
-          </a:fillRef>
-          <a:effectRef idx="2">
-            <a:schemeClr val="accent1"/>
-          </a:effectRef>
-          <a:fontRef idx="minor">
-            <a:schemeClr val="lt1"/>
-          </a:fontRef>
-        </p:style>
-        <p:txBody>
-          <a:bodyPr rtlCol="0" anchor="ctr"/>
-          <a:lstStyle/>
-          <a:p>
-            <a:pPr algn="ctr"/>
-          </a:p>
-        </p:txBody>
-      </p:sp>
-      <p:sp>
-        <p:nvSpPr>
-          <p:cNvPr id="38" name="TextBox 37"/>
+          <p:cNvPr id="19" name="TextBox 18"/>
           <p:cNvSpPr txBox="1"/>
           <p:nvPr/>
         </p:nvSpPr>
         <p:spPr>
           <a:xfrm>
-            <a:off x="30403800" y="6748272"/>
-            <a:ext cx="4069080" cy="1645920"/>
-          </a:xfrm>
-          <a:prstGeom prst="rect">
-            <a:avLst/>
-          </a:prstGeom>
-          <a:noFill/>
-        </p:spPr>
-        <p:txBody>
-          <a:bodyPr wrap="square" anchor="ctr" lIns="0" rIns="0" tIns="0" bIns="0">
-            <a:spAutoFit/>
-          </a:bodyPr>
-          <a:lstStyle/>
-          <a:p>
-            <a:pPr algn="ctr">
-              <a:spcBef>
-                <a:spcPts val="0"/>
-              </a:spcBef>
-              <a:spcAft>
-                <a:spcPts val="0"/>
-              </a:spcAft>
-              <a:buNone/>
-            </a:pPr>
-            <a:r>
-              <a:rPr sz="2300" b="1" i="0">
-                <a:solidFill>
-                  <a:srgbClr val="757575"/>
-                </a:solidFill>
-                <a:latin typeface="NVIDIA Sans Medium"/>
-              </a:rPr>
-              <a:t>TEXT · IMAGE</a:t>
-            </a:r>
-          </a:p>
-          <a:p>
-            <a:pPr algn="ctr">
-              <a:spcBef>
-                <a:spcPts val="0"/>
-              </a:spcBef>
-              <a:spcAft>
-                <a:spcPts val="0"/>
-              </a:spcAft>
-              <a:buNone/>
-            </a:pPr>
-            <a:r>
-              <a:rPr sz="2300" b="1" i="0">
-                <a:solidFill>
-                  <a:srgbClr val="757575"/>
-                </a:solidFill>
-                <a:latin typeface="NVIDIA Sans Medium"/>
-              </a:rPr>
-              <a:t>AUDIO · VIDEO</a:t>
-            </a:r>
-          </a:p>
-          <a:p>
-            <a:pPr algn="ctr">
-              <a:spcBef>
-                <a:spcPts val="0"/>
-              </a:spcBef>
-              <a:spcAft>
-                <a:spcPts val="0"/>
-              </a:spcAft>
-              <a:buNone/>
-            </a:pPr>
-            <a:r>
-              <a:rPr sz="2300" b="1" i="0">
-                <a:solidFill>
-                  <a:srgbClr val="757575"/>
-                </a:solidFill>
-                <a:latin typeface="NVIDIA Sans Medium"/>
-              </a:rPr>
-              <a:t>ACTION</a:t>
-            </a:r>
-          </a:p>
-        </p:txBody>
-      </p:sp>
-      <p:cxnSp>
-        <p:nvCxnSpPr>
-          <p:cNvPr id="39" name="Connector 38"/>
-          <p:cNvCxnSpPr/>
-          <p:nvPr/>
-        </p:nvCxnSpPr>
-        <p:spPr>
-          <a:xfrm>
-            <a:off x="14264640" y="10195560"/>
-            <a:ext cx="20208240" cy="0"/>
-          </a:xfrm>
-          <a:prstGeom prst="line">
-            <a:avLst/>
-          </a:prstGeom>
-          <a:ln w="31750">
-            <a:solidFill>
-              <a:srgbClr val="76B900"/>
-            </a:solidFill>
-          </a:ln>
-        </p:spPr>
-        <p:style>
-          <a:lnRef idx="2">
-            <a:schemeClr val="accent1"/>
-          </a:lnRef>
-          <a:fillRef idx="0">
-            <a:schemeClr val="accent1"/>
-          </a:fillRef>
-          <a:effectRef idx="1">
-            <a:schemeClr val="accent1"/>
-          </a:effectRef>
-          <a:fontRef idx="minor">
-            <a:schemeClr val="tx1"/>
-          </a:fontRef>
-        </p:style>
-      </p:cxnSp>
-      <p:sp>
-        <p:nvSpPr>
-          <p:cNvPr id="40" name="TextBox 39"/>
-          <p:cNvSpPr txBox="1"/>
-          <p:nvPr/>
-        </p:nvSpPr>
-        <p:spPr>
-          <a:xfrm>
-            <a:off x="14264640" y="10561320"/>
-            <a:ext cx="3703320" cy="502920"/>
+            <a:off x="17465040" y="5029200"/>
+            <a:ext cx="17053560" cy="475488"/>
           </a:xfrm>
           <a:prstGeom prst="rect">
             <a:avLst/>
@@ -35962,27 +34946,51 @@
               <a:buNone/>
             </a:pPr>
             <a:r>
-              <a:rPr sz="2900" b="1" i="0">
+              <a:rPr sz="2800" b="1" i="0">
                 <a:solidFill>
-                  <a:srgbClr val="76B900"/>
+                  <a:srgbClr val="757575"/>
                 </a:solidFill>
                 <a:latin typeface="NVIDIA Sans Medium"/>
               </a:rPr>
-              <a:t>STAGE GRAPH</a:t>
-            </a:r>
-          </a:p>
-        </p:txBody>
-      </p:sp>
-      <p:sp>
-        <p:nvSpPr>
-          <p:cNvPr id="41" name="TextBox 40"/>
+              <a:t>COMFYUI WORKFLOW · PR #9194</a:t>
+            </a:r>
+          </a:p>
+        </p:txBody>
+      </p:sp>
+      <p:pic>
+        <p:nvPicPr>
+          <p:cNvPr id="20" name="Picture 19" descr="pr9194_comfyui_single_character_workflow.png"/>
+          <p:cNvPicPr>
+            <a:picLocks noChangeAspect="1"/>
+          </p:cNvPicPr>
+          <p:nvPr/>
+        </p:nvPicPr>
+        <p:blipFill>
+          <a:blip r:embed="rId4"/>
+          <a:stretch>
+            <a:fillRect/>
+          </a:stretch>
+        </p:blipFill>
+        <p:spPr>
+          <a:xfrm>
+            <a:off x="17465040" y="5670096"/>
+            <a:ext cx="17053560" cy="10788286"/>
+          </a:xfrm>
+          <a:prstGeom prst="rect">
+            <a:avLst/>
+          </a:prstGeom>
+        </p:spPr>
+      </p:pic>
+      <p:sp>
+        <p:nvSpPr>
+          <p:cNvPr id="21" name="TextBox 20"/>
           <p:cNvSpPr txBox="1"/>
           <p:nvPr/>
         </p:nvSpPr>
         <p:spPr>
           <a:xfrm>
-            <a:off x="18425160" y="10561320"/>
-            <a:ext cx="16047720" cy="502920"/>
+            <a:off x="17465040" y="16779240"/>
+            <a:ext cx="17053560" cy="868680"/>
           </a:xfrm>
           <a:prstGeom prst="rect">
             <a:avLst/>
@@ -36005,27 +35013,27 @@
               <a:buNone/>
             </a:pPr>
             <a:r>
-              <a:rPr sz="2900" b="0" i="0">
+              <a:rPr sz="2500" b="0" i="0">
                 <a:solidFill>
                   <a:srgbClr val="313131"/>
                 </a:solidFill>
                 <a:latin typeface="NVIDIA Sans"/>
               </a:rPr>
-              <a:t>placement  ·  batching  ·  transport  ·  lifecycle</a:t>
-            </a:r>
-          </a:p>
-        </p:txBody>
-      </p:sp>
-      <p:sp>
-        <p:nvSpPr>
-          <p:cNvPr id="42" name="TextBox 41"/>
+              <a:t>MiniMax-H3 single-character replacement: Load Image + Load Video → Video References → vLLM-Omni Generate Video → Save Video</a:t>
+            </a:r>
+          </a:p>
+        </p:txBody>
+      </p:sp>
+      <p:sp>
+        <p:nvSpPr>
+          <p:cNvPr id="22" name="TextBox 21"/>
           <p:cNvSpPr txBox="1"/>
           <p:nvPr/>
         </p:nvSpPr>
         <p:spPr>
           <a:xfrm>
-            <a:off x="14264640" y="11475720"/>
-            <a:ext cx="20208240" cy="502920"/>
+            <a:off x="17465040" y="17721072"/>
+            <a:ext cx="17053560" cy="411480"/>
           </a:xfrm>
           <a:prstGeom prst="rect">
             <a:avLst/>
@@ -36048,419 +35056,13 @@
               <a:buNone/>
             </a:pPr>
             <a:r>
-              <a:rPr sz="2800" b="0" i="0">
+              <a:rPr sz="2200" b="0" i="0">
                 <a:solidFill>
                   <a:srgbClr val="757575"/>
                 </a:solidFill>
                 <a:latin typeface="NVIDIA Sans"/>
               </a:rPr>
-              <a:t>Each stage owns its execution policy</a:t>
-            </a:r>
-          </a:p>
-        </p:txBody>
-      </p:sp>
-      <p:cxnSp>
-        <p:nvCxnSpPr>
-          <p:cNvPr id="43" name="Connector 42"/>
-          <p:cNvCxnSpPr/>
-          <p:nvPr/>
-        </p:nvCxnSpPr>
-        <p:spPr>
-          <a:xfrm>
-            <a:off x="2057400" y="15041880"/>
-            <a:ext cx="32415480" cy="0"/>
-          </a:xfrm>
-          <a:prstGeom prst="line">
-            <a:avLst/>
-          </a:prstGeom>
-          <a:ln w="12700">
-            <a:solidFill>
-              <a:srgbClr val="D9D9D9"/>
-            </a:solidFill>
-          </a:ln>
-        </p:spPr>
-        <p:style>
-          <a:lnRef idx="2">
-            <a:schemeClr val="accent1"/>
-          </a:lnRef>
-          <a:fillRef idx="0">
-            <a:schemeClr val="accent1"/>
-          </a:fillRef>
-          <a:effectRef idx="1">
-            <a:schemeClr val="accent1"/>
-          </a:effectRef>
-          <a:fontRef idx="minor">
-            <a:schemeClr val="tx1"/>
-          </a:fontRef>
-        </p:style>
-      </p:cxnSp>
-      <p:sp>
-        <p:nvSpPr>
-          <p:cNvPr id="44" name="TextBox 43"/>
-          <p:cNvSpPr txBox="1"/>
-          <p:nvPr/>
-        </p:nvSpPr>
-        <p:spPr>
-          <a:xfrm>
-            <a:off x="2057400" y="15654528"/>
-            <a:ext cx="3840480" cy="530352"/>
-          </a:xfrm>
-          <a:prstGeom prst="rect">
-            <a:avLst/>
-          </a:prstGeom>
-          <a:noFill/>
-        </p:spPr>
-        <p:txBody>
-          <a:bodyPr wrap="square" anchor="t" lIns="0" rIns="0" tIns="0" bIns="0">
-            <a:spAutoFit/>
-          </a:bodyPr>
-          <a:lstStyle/>
-          <a:p>
-            <a:pPr algn="l">
-              <a:spcBef>
-                <a:spcPts val="0"/>
-              </a:spcBef>
-              <a:spcAft>
-                <a:spcPts val="0"/>
-              </a:spcAft>
-              <a:buNone/>
-            </a:pPr>
-            <a:r>
-              <a:rPr sz="3100" b="1" i="0">
-                <a:solidFill>
-                  <a:srgbClr val="76B900"/>
-                </a:solidFill>
-                <a:latin typeface="NVIDIA Sans Medium"/>
-              </a:rPr>
-              <a:t>MINIMAX H3</a:t>
-            </a:r>
-          </a:p>
-        </p:txBody>
-      </p:sp>
-      <p:sp>
-        <p:nvSpPr>
-          <p:cNvPr id="45" name="TextBox 44"/>
-          <p:cNvSpPr txBox="1"/>
-          <p:nvPr/>
-        </p:nvSpPr>
-        <p:spPr>
-          <a:xfrm>
-            <a:off x="6675120" y="15480792"/>
-            <a:ext cx="4389120" cy="960120"/>
-          </a:xfrm>
-          <a:prstGeom prst="rect">
-            <a:avLst/>
-          </a:prstGeom>
-          <a:noFill/>
-        </p:spPr>
-        <p:txBody>
-          <a:bodyPr wrap="square" anchor="ctr" lIns="0" rIns="0" tIns="0" bIns="0">
-            <a:spAutoFit/>
-          </a:bodyPr>
-          <a:lstStyle/>
-          <a:p>
-            <a:pPr algn="ctr">
-              <a:spcBef>
-                <a:spcPts val="0"/>
-              </a:spcBef>
-              <a:spcAft>
-                <a:spcPts val="0"/>
-              </a:spcAft>
-              <a:buNone/>
-            </a:pPr>
-            <a:r>
-              <a:rPr sz="3100" b="1" i="0">
-                <a:solidFill>
-                  <a:srgbClr val="313131"/>
-                </a:solidFill>
-                <a:latin typeface="NVIDIA Sans Medium"/>
-              </a:rPr>
-              <a:t>Text Encoder</a:t>
-            </a:r>
-          </a:p>
-        </p:txBody>
-      </p:sp>
-      <p:cxnSp>
-        <p:nvCxnSpPr>
-          <p:cNvPr id="46" name="Connector 45"/>
-          <p:cNvCxnSpPr/>
-          <p:nvPr/>
-        </p:nvCxnSpPr>
-        <p:spPr>
-          <a:xfrm>
-            <a:off x="11292840" y="15956280"/>
-            <a:ext cx="731520" cy="0"/>
-          </a:xfrm>
-          <a:prstGeom prst="line">
-            <a:avLst/>
-          </a:prstGeom>
-          <a:ln w="27940">
-            <a:solidFill>
-              <a:srgbClr val="76B900"/>
-            </a:solidFill>
-          </a:ln>
-        </p:spPr>
-        <p:style>
-          <a:lnRef idx="2">
-            <a:schemeClr val="accent1"/>
-          </a:lnRef>
-          <a:fillRef idx="0">
-            <a:schemeClr val="accent1"/>
-          </a:fillRef>
-          <a:effectRef idx="1">
-            <a:schemeClr val="accent1"/>
-          </a:effectRef>
-          <a:fontRef idx="minor">
-            <a:schemeClr val="tx1"/>
-          </a:fontRef>
-        </p:style>
-      </p:cxnSp>
-      <p:sp>
-        <p:nvSpPr>
-          <p:cNvPr id="47" name="Isosceles Triangle 46"/>
-          <p:cNvSpPr/>
-          <p:nvPr/>
-        </p:nvSpPr>
-        <p:spPr>
-          <a:xfrm rot="5400000">
-            <a:off x="11932920" y="15864839"/>
-            <a:ext cx="182880" cy="182880"/>
-          </a:xfrm>
-          <a:prstGeom prst="triangle">
-            <a:avLst/>
-          </a:prstGeom>
-          <a:solidFill>
-            <a:srgbClr val="76B900"/>
-          </a:solidFill>
-          <a:ln>
-            <a:noFill/>
-          </a:ln>
-        </p:spPr>
-        <p:style>
-          <a:lnRef idx="1">
-            <a:schemeClr val="accent1"/>
-          </a:lnRef>
-          <a:fillRef idx="3">
-            <a:schemeClr val="accent1"/>
-          </a:fillRef>
-          <a:effectRef idx="2">
-            <a:schemeClr val="accent1"/>
-          </a:effectRef>
-          <a:fontRef idx="minor">
-            <a:schemeClr val="lt1"/>
-          </a:fontRef>
-        </p:style>
-        <p:txBody>
-          <a:bodyPr rtlCol="0" anchor="ctr"/>
-          <a:lstStyle/>
-          <a:p>
-            <a:pPr algn="ctr"/>
-          </a:p>
-        </p:txBody>
-      </p:sp>
-      <p:sp>
-        <p:nvSpPr>
-          <p:cNvPr id="48" name="TextBox 47"/>
-          <p:cNvSpPr txBox="1"/>
-          <p:nvPr/>
-        </p:nvSpPr>
-        <p:spPr>
-          <a:xfrm>
-            <a:off x="12252960" y="15480792"/>
-            <a:ext cx="3383280" cy="960120"/>
-          </a:xfrm>
-          <a:prstGeom prst="rect">
-            <a:avLst/>
-          </a:prstGeom>
-          <a:noFill/>
-        </p:spPr>
-        <p:txBody>
-          <a:bodyPr wrap="square" anchor="ctr" lIns="0" rIns="0" tIns="0" bIns="0">
-            <a:spAutoFit/>
-          </a:bodyPr>
-          <a:lstStyle/>
-          <a:p>
-            <a:pPr algn="ctr">
-              <a:spcBef>
-                <a:spcPts val="0"/>
-              </a:spcBef>
-              <a:spcAft>
-                <a:spcPts val="0"/>
-              </a:spcAft>
-              <a:buNone/>
-            </a:pPr>
-            <a:r>
-              <a:rPr sz="3600" b="1" i="0">
-                <a:solidFill>
-                  <a:srgbClr val="952FC6"/>
-                </a:solidFill>
-                <a:latin typeface="NVIDIA Sans Medium"/>
-              </a:rPr>
-              <a:t>DiT</a:t>
-            </a:r>
-          </a:p>
-        </p:txBody>
-      </p:sp>
-      <p:cxnSp>
-        <p:nvCxnSpPr>
-          <p:cNvPr id="49" name="Connector 48"/>
-          <p:cNvCxnSpPr/>
-          <p:nvPr/>
-        </p:nvCxnSpPr>
-        <p:spPr>
-          <a:xfrm>
-            <a:off x="15864840" y="15956280"/>
-            <a:ext cx="731519" cy="0"/>
-          </a:xfrm>
-          <a:prstGeom prst="line">
-            <a:avLst/>
-          </a:prstGeom>
-          <a:ln w="27940">
-            <a:solidFill>
-              <a:srgbClr val="76B900"/>
-            </a:solidFill>
-          </a:ln>
-        </p:spPr>
-        <p:style>
-          <a:lnRef idx="2">
-            <a:schemeClr val="accent1"/>
-          </a:lnRef>
-          <a:fillRef idx="0">
-            <a:schemeClr val="accent1"/>
-          </a:fillRef>
-          <a:effectRef idx="1">
-            <a:schemeClr val="accent1"/>
-          </a:effectRef>
-          <a:fontRef idx="minor">
-            <a:schemeClr val="tx1"/>
-          </a:fontRef>
-        </p:style>
-      </p:cxnSp>
-      <p:sp>
-        <p:nvSpPr>
-          <p:cNvPr id="50" name="Isosceles Triangle 49"/>
-          <p:cNvSpPr/>
-          <p:nvPr/>
-        </p:nvSpPr>
-        <p:spPr>
-          <a:xfrm rot="5400000">
-            <a:off x="16504919" y="15864839"/>
-            <a:ext cx="182880" cy="182880"/>
-          </a:xfrm>
-          <a:prstGeom prst="triangle">
-            <a:avLst/>
-          </a:prstGeom>
-          <a:solidFill>
-            <a:srgbClr val="76B900"/>
-          </a:solidFill>
-          <a:ln>
-            <a:noFill/>
-          </a:ln>
-        </p:spPr>
-        <p:style>
-          <a:lnRef idx="1">
-            <a:schemeClr val="accent1"/>
-          </a:lnRef>
-          <a:fillRef idx="3">
-            <a:schemeClr val="accent1"/>
-          </a:fillRef>
-          <a:effectRef idx="2">
-            <a:schemeClr val="accent1"/>
-          </a:effectRef>
-          <a:fontRef idx="minor">
-            <a:schemeClr val="lt1"/>
-          </a:fontRef>
-        </p:style>
-        <p:txBody>
-          <a:bodyPr rtlCol="0" anchor="ctr"/>
-          <a:lstStyle/>
-          <a:p>
-            <a:pPr algn="ctr"/>
-          </a:p>
-        </p:txBody>
-      </p:sp>
-      <p:sp>
-        <p:nvSpPr>
-          <p:cNvPr id="51" name="TextBox 50"/>
-          <p:cNvSpPr txBox="1"/>
-          <p:nvPr/>
-        </p:nvSpPr>
-        <p:spPr>
-          <a:xfrm>
-            <a:off x="16824960" y="15480792"/>
-            <a:ext cx="4846320" cy="960120"/>
-          </a:xfrm>
-          <a:prstGeom prst="rect">
-            <a:avLst/>
-          </a:prstGeom>
-          <a:noFill/>
-        </p:spPr>
-        <p:txBody>
-          <a:bodyPr wrap="square" anchor="ctr" lIns="0" rIns="0" tIns="0" bIns="0">
-            <a:spAutoFit/>
-          </a:bodyPr>
-          <a:lstStyle/>
-          <a:p>
-            <a:pPr algn="ctr">
-              <a:spcBef>
-                <a:spcPts val="0"/>
-              </a:spcBef>
-              <a:spcAft>
-                <a:spcPts val="0"/>
-              </a:spcAft>
-              <a:buNone/>
-            </a:pPr>
-            <a:r>
-              <a:rPr sz="3100" b="1" i="0">
-                <a:solidFill>
-                  <a:srgbClr val="313131"/>
-                </a:solidFill>
-                <a:latin typeface="NVIDIA Sans Medium"/>
-              </a:rPr>
-              <a:t>VAE Decoder</a:t>
-            </a:r>
-          </a:p>
-        </p:txBody>
-      </p:sp>
-      <p:sp>
-        <p:nvSpPr>
-          <p:cNvPr id="52" name="TextBox 51"/>
-          <p:cNvSpPr txBox="1"/>
-          <p:nvPr/>
-        </p:nvSpPr>
-        <p:spPr>
-          <a:xfrm>
-            <a:off x="23042880" y="15581376"/>
-            <a:ext cx="11430000" cy="786384"/>
-          </a:xfrm>
-          <a:prstGeom prst="rect">
-            <a:avLst/>
-          </a:prstGeom>
-          <a:noFill/>
-        </p:spPr>
-        <p:txBody>
-          <a:bodyPr wrap="square" anchor="ctr" lIns="0" rIns="0" tIns="0" bIns="0">
-            <a:spAutoFit/>
-          </a:bodyPr>
-          <a:lstStyle/>
-          <a:p>
-            <a:pPr algn="r">
-              <a:spcBef>
-                <a:spcPts val="0"/>
-              </a:spcBef>
-              <a:spcAft>
-                <a:spcPts val="0"/>
-              </a:spcAft>
-              <a:buNone/>
-            </a:pPr>
-            <a:r>
-              <a:rPr sz="2600" b="0" i="0">
-                <a:solidFill>
-                  <a:srgbClr val="757575"/>
-                </a:solidFill>
-                <a:latin typeface="NVIDIA Sans"/>
-              </a:rPr>
-              <a:t>Logical components stay co-located inside one diffusion stage</a:t>
+              <a:t>Public PR #9194 · open as of 24 Oct 2026</a:t>
             </a:r>
           </a:p>
         </p:txBody>
@@ -36485,12 +35087,12 @@
       <p:grpSpPr/>
       <p:sp>
         <p:nvSpPr>
-          <p:cNvPr id="4" name="Text Placeholder 3"/>
-          <p:cNvSpPr>
-            <a:spLocks noGrp="1"/>
-          </p:cNvSpPr>
-          <p:nvPr>
-            <p:ph type="body" idx="14" sz="quarter"/>
+          <p:cNvPr id="2" name="Text Placeholder 1"/>
+          <p:cNvSpPr>
+            <a:spLocks noGrp="1"/>
+          </p:cNvSpPr>
+          <p:nvPr>
+            <p:ph type="body" idx="13" sz="quarter"/>
           </p:nvPr>
         </p:nvSpPr>
         <p:spPr/>
@@ -36508,20 +35110,20 @@
               <a:buNone/>
             </a:pPr>
             <a:r>
-              <a:rPr sz="4800" b="0" i="0">
+              <a:rPr sz="3800" b="0" i="0">
                 <a:solidFill>
                   <a:srgbClr val="757575"/>
                 </a:solidFill>
                 <a:latin typeface="NVIDIA Sans"/>
               </a:rPr>
-              <a:t>Baseline: 8× NVIDIA RTX PRO 5000 72GB · compute capability 12.0 · 110 SM per GPU</a:t>
-            </a:r>
-          </a:p>
-        </p:txBody>
-      </p:sp>
-      <p:sp>
-        <p:nvSpPr>
-          <p:cNvPr id="5" name="Title 4"/>
+              <a:t>Ulysses SP8 moves Q/K/V and Gate/O across ranks, placing transfers and barriers on the dependency path</a:t>
+            </a:r>
+          </a:p>
+        </p:txBody>
+      </p:sp>
+      <p:sp>
+        <p:nvSpPr>
+          <p:cNvPr id="3" name="Title 2"/>
           <p:cNvSpPr>
             <a:spLocks noGrp="1"/>
           </p:cNvSpPr>
@@ -36544,20 +35146,20 @@
               <a:buNone/>
             </a:pPr>
             <a:r>
-              <a:rPr sz="8800" b="1" i="0">
+              <a:rPr sz="6000" b="1" i="0">
                 <a:solidFill>
                   <a:srgbClr val="000000"/>
                 </a:solidFill>
                 <a:latin typeface="NVIDIA Sans Medium"/>
               </a:rPr>
-              <a:t>SM120: Compute and Communication Regimes</a:t>
-            </a:r>
-          </a:p>
-        </p:txBody>
-      </p:sp>
-      <p:sp>
-        <p:nvSpPr>
-          <p:cNvPr id="6" name="TextBox 5"/>
+              <a:t>SM120 Is Compute-Rich; Fabric Bandwidth Sets Scale-Out Headroom</a:t>
+            </a:r>
+          </a:p>
+        </p:txBody>
+      </p:sp>
+      <p:sp>
+        <p:nvSpPr>
+          <p:cNvPr id="4" name="TextBox 3"/>
           <p:cNvSpPr txBox="1"/>
           <p:nvPr/>
         </p:nvSpPr>
@@ -36593,14 +35195,14 @@
                 </a:solidFill>
                 <a:latin typeface="NVIDIA Sans"/>
               </a:rPr>
-              <a:t>Sources: NVIDIA RTX PRO 5000 Blackwell datasheet · CUDA GPU Compute Capability · CUDA C Programming Guide · measured system inventory</a:t>
-            </a:r>
-          </a:p>
-        </p:txBody>
-      </p:sp>
-      <p:sp>
-        <p:nvSpPr>
-          <p:cNvPr id="7" name="TextBox 6"/>
+              <a:t>Sources: 72 GB &amp; 1,344 GB/s — NVIDIA RTX PRO 5000 Blackwell datasheet · 110 SM/CC 12.0 &amp; 8×400 Gb/s — measured system inventory</a:t>
+            </a:r>
+          </a:p>
+        </p:txBody>
+      </p:sp>
+      <p:sp>
+        <p:nvSpPr>
+          <p:cNvPr id="5" name="TextBox 4"/>
           <p:cNvSpPr txBox="1"/>
           <p:nvPr/>
         </p:nvSpPr>
@@ -36643,14 +35245,14 @@
       </p:sp>
       <p:sp>
         <p:nvSpPr>
-          <p:cNvPr id="8" name="TextBox 7"/>
+          <p:cNvPr id="6" name="TextBox 5"/>
           <p:cNvSpPr txBox="1"/>
           <p:nvPr/>
         </p:nvSpPr>
         <p:spPr>
           <a:xfrm>
-            <a:off x="2148840" y="5303520"/>
-            <a:ext cx="9784080" cy="1143000"/>
+            <a:off x="2057400" y="4892040"/>
+            <a:ext cx="11887200" cy="475488"/>
           </a:xfrm>
           <a:prstGeom prst="rect">
             <a:avLst/>
@@ -36673,27 +35275,27 @@
               <a:buNone/>
             </a:pPr>
             <a:r>
-              <a:rPr sz="8200" b="1" i="0">
+              <a:rPr sz="2800" b="1" i="0">
                 <a:solidFill>
-                  <a:srgbClr val="76B900"/>
+                  <a:srgbClr val="757575"/>
                 </a:solidFill>
                 <a:latin typeface="NVIDIA Sans Medium"/>
               </a:rPr>
-              <a:t>sm_120</a:t>
-            </a:r>
-          </a:p>
-        </p:txBody>
-      </p:sp>
-      <p:sp>
-        <p:nvSpPr>
-          <p:cNvPr id="9" name="TextBox 8"/>
+              <a:t>PER-GPU BASELINE · EIGHT-GPU SYSTEM</a:t>
+            </a:r>
+          </a:p>
+        </p:txBody>
+      </p:sp>
+      <p:sp>
+        <p:nvSpPr>
+          <p:cNvPr id="7" name="TextBox 6"/>
           <p:cNvSpPr txBox="1"/>
           <p:nvPr/>
         </p:nvSpPr>
         <p:spPr>
           <a:xfrm>
-            <a:off x="2148840" y="6492240"/>
-            <a:ext cx="9784080" cy="457200"/>
+            <a:off x="2057400" y="5715000"/>
+            <a:ext cx="7269480" cy="749808"/>
           </a:xfrm>
           <a:prstGeom prst="rect">
             <a:avLst/>
@@ -36716,32 +35318,75 @@
               <a:buNone/>
             </a:pPr>
             <a:r>
-              <a:rPr sz="3100" b="0" i="0">
+              <a:rPr sz="4900" b="1" i="0">
+                <a:solidFill>
+                  <a:srgbClr val="76B900"/>
+                </a:solidFill>
+                <a:latin typeface="NVIDIA Sans Medium"/>
+              </a:rPr>
+              <a:t>110 SM/GPU</a:t>
+            </a:r>
+          </a:p>
+        </p:txBody>
+      </p:sp>
+      <p:sp>
+        <p:nvSpPr>
+          <p:cNvPr id="8" name="TextBox 7"/>
+          <p:cNvSpPr txBox="1"/>
+          <p:nvPr/>
+        </p:nvSpPr>
+        <p:spPr>
+          <a:xfrm>
+            <a:off x="2057400" y="6565392"/>
+            <a:ext cx="7269480" cy="438912"/>
+          </a:xfrm>
+          <a:prstGeom prst="rect">
+            <a:avLst/>
+          </a:prstGeom>
+          <a:noFill/>
+        </p:spPr>
+        <p:txBody>
+          <a:bodyPr wrap="square" anchor="t" lIns="0" rIns="0" tIns="0" bIns="0">
+            <a:spAutoFit/>
+          </a:bodyPr>
+          <a:lstStyle/>
+          <a:p>
+            <a:pPr algn="l">
+              <a:spcBef>
+                <a:spcPts val="0"/>
+              </a:spcBef>
+              <a:spcAft>
+                <a:spcPts val="0"/>
+              </a:spcAft>
+              <a:buNone/>
+            </a:pPr>
+            <a:r>
+              <a:rPr sz="2500" b="0" i="0">
                 <a:solidFill>
                   <a:srgbClr val="757575"/>
                 </a:solidFill>
                 <a:latin typeface="NVIDIA Sans"/>
               </a:rPr>
-              <a:t>CUDA compute capability 12.0</a:t>
+              <a:t>compute capability 12.0</a:t>
             </a:r>
           </a:p>
         </p:txBody>
       </p:sp>
       <p:cxnSp>
         <p:nvCxnSpPr>
-          <p:cNvPr id="10" name="Connector 9"/>
+          <p:cNvPr id="9" name="Connector 8"/>
           <p:cNvCxnSpPr/>
           <p:nvPr/>
         </p:nvCxnSpPr>
         <p:spPr>
           <a:xfrm>
-            <a:off x="2148840" y="7360920"/>
-            <a:ext cx="9784080" cy="0"/>
+            <a:off x="9692640" y="5687568"/>
+            <a:ext cx="0" cy="1463040"/>
           </a:xfrm>
           <a:prstGeom prst="line">
             <a:avLst/>
           </a:prstGeom>
-          <a:ln w="12700">
+          <a:ln w="10160">
             <a:solidFill>
               <a:srgbClr val="D9D9D9"/>
             </a:solidFill>
@@ -36764,14 +35409,14 @@
       </p:cxnSp>
       <p:sp>
         <p:nvSpPr>
-          <p:cNvPr id="11" name="TextBox 10"/>
+          <p:cNvPr id="10" name="TextBox 9"/>
           <p:cNvSpPr txBox="1"/>
           <p:nvPr/>
         </p:nvSpPr>
         <p:spPr>
           <a:xfrm>
-            <a:off x="2148840" y="7909560"/>
-            <a:ext cx="4617720" cy="640080"/>
+            <a:off x="10195560" y="5715000"/>
+            <a:ext cx="7269480" cy="749808"/>
           </a:xfrm>
           <a:prstGeom prst="rect">
             <a:avLst/>
@@ -36794,27 +35439,27 @@
               <a:buNone/>
             </a:pPr>
             <a:r>
-              <a:rPr sz="4300" b="1" i="0">
+              <a:rPr sz="4900" b="1" i="0">
                 <a:solidFill>
-                  <a:srgbClr val="76B900"/>
+                  <a:srgbClr val="313131"/>
                 </a:solidFill>
                 <a:latin typeface="NVIDIA Sans Medium"/>
               </a:rPr>
-              <a:t>110</a:t>
-            </a:r>
-          </a:p>
-        </p:txBody>
-      </p:sp>
-      <p:sp>
-        <p:nvSpPr>
-          <p:cNvPr id="12" name="TextBox 11"/>
+              <a:t>72 GB/GPU</a:t>
+            </a:r>
+          </a:p>
+        </p:txBody>
+      </p:sp>
+      <p:sp>
+        <p:nvSpPr>
+          <p:cNvPr id="11" name="TextBox 10"/>
           <p:cNvSpPr txBox="1"/>
           <p:nvPr/>
         </p:nvSpPr>
         <p:spPr>
           <a:xfrm>
-            <a:off x="2148840" y="8613648"/>
-            <a:ext cx="4617720" cy="438912"/>
+            <a:off x="10195560" y="6565392"/>
+            <a:ext cx="7269480" cy="438912"/>
           </a:xfrm>
           <a:prstGeom prst="rect">
             <a:avLst/>
@@ -36843,284 +35488,26 @@
                 </a:solidFill>
                 <a:latin typeface="NVIDIA Sans"/>
               </a:rPr>
-              <a:t>SM / GPU*</a:t>
-            </a:r>
-          </a:p>
-        </p:txBody>
-      </p:sp>
-      <p:sp>
-        <p:nvSpPr>
-          <p:cNvPr id="13" name="TextBox 12"/>
-          <p:cNvSpPr txBox="1"/>
-          <p:nvPr/>
-        </p:nvSpPr>
-        <p:spPr>
-          <a:xfrm>
-            <a:off x="7223760" y="7909560"/>
-            <a:ext cx="4617720" cy="640080"/>
-          </a:xfrm>
-          <a:prstGeom prst="rect">
-            <a:avLst/>
-          </a:prstGeom>
-          <a:noFill/>
-        </p:spPr>
-        <p:txBody>
-          <a:bodyPr wrap="square" anchor="t" lIns="0" rIns="0" tIns="0" bIns="0">
-            <a:spAutoFit/>
-          </a:bodyPr>
-          <a:lstStyle/>
-          <a:p>
-            <a:pPr algn="l">
-              <a:spcBef>
-                <a:spcPts val="0"/>
-              </a:spcBef>
-              <a:spcAft>
-                <a:spcPts val="0"/>
-              </a:spcAft>
-              <a:buNone/>
-            </a:pPr>
-            <a:r>
-              <a:rPr sz="4300" b="1" i="0">
-                <a:solidFill>
-                  <a:srgbClr val="313131"/>
-                </a:solidFill>
-                <a:latin typeface="NVIDIA Sans Medium"/>
-              </a:rPr>
-              <a:t>72 GB</a:t>
-            </a:r>
-          </a:p>
-        </p:txBody>
-      </p:sp>
-      <p:sp>
-        <p:nvSpPr>
-          <p:cNvPr id="14" name="TextBox 13"/>
-          <p:cNvSpPr txBox="1"/>
-          <p:nvPr/>
-        </p:nvSpPr>
-        <p:spPr>
-          <a:xfrm>
-            <a:off x="7223760" y="8613648"/>
-            <a:ext cx="4617720" cy="438912"/>
-          </a:xfrm>
-          <a:prstGeom prst="rect">
-            <a:avLst/>
-          </a:prstGeom>
-          <a:noFill/>
-        </p:spPr>
-        <p:txBody>
-          <a:bodyPr wrap="square" anchor="t" lIns="0" rIns="0" tIns="0" bIns="0">
-            <a:spAutoFit/>
-          </a:bodyPr>
-          <a:lstStyle/>
-          <a:p>
-            <a:pPr algn="l">
-              <a:spcBef>
-                <a:spcPts val="0"/>
-              </a:spcBef>
-              <a:spcAft>
-                <a:spcPts val="0"/>
-              </a:spcAft>
-              <a:buNone/>
-            </a:pPr>
-            <a:r>
-              <a:rPr sz="2500" b="0" i="0">
-                <a:solidFill>
-                  <a:srgbClr val="757575"/>
-                </a:solidFill>
-                <a:latin typeface="NVIDIA Sans"/>
-              </a:rPr>
-              <a:t>GDDR7 ECC / GPU</a:t>
-            </a:r>
-          </a:p>
-        </p:txBody>
-      </p:sp>
-      <p:sp>
-        <p:nvSpPr>
-          <p:cNvPr id="15" name="TextBox 14"/>
-          <p:cNvSpPr txBox="1"/>
-          <p:nvPr/>
-        </p:nvSpPr>
-        <p:spPr>
-          <a:xfrm>
-            <a:off x="2148840" y="10332720"/>
-            <a:ext cx="4617720" cy="640080"/>
-          </a:xfrm>
-          <a:prstGeom prst="rect">
-            <a:avLst/>
-          </a:prstGeom>
-          <a:noFill/>
-        </p:spPr>
-        <p:txBody>
-          <a:bodyPr wrap="square" anchor="t" lIns="0" rIns="0" tIns="0" bIns="0">
-            <a:spAutoFit/>
-          </a:bodyPr>
-          <a:lstStyle/>
-          <a:p>
-            <a:pPr algn="l">
-              <a:spcBef>
-                <a:spcPts val="0"/>
-              </a:spcBef>
-              <a:spcAft>
-                <a:spcPts val="0"/>
-              </a:spcAft>
-              <a:buNone/>
-            </a:pPr>
-            <a:r>
-              <a:rPr sz="4300" b="1" i="0">
-                <a:solidFill>
-                  <a:srgbClr val="0074DF"/>
-                </a:solidFill>
-                <a:latin typeface="NVIDIA Sans Medium"/>
-              </a:rPr>
-              <a:t>1,344 GB/s</a:t>
-            </a:r>
-          </a:p>
-        </p:txBody>
-      </p:sp>
-      <p:sp>
-        <p:nvSpPr>
-          <p:cNvPr id="16" name="TextBox 15"/>
-          <p:cNvSpPr txBox="1"/>
-          <p:nvPr/>
-        </p:nvSpPr>
-        <p:spPr>
-          <a:xfrm>
-            <a:off x="2148840" y="11036808"/>
-            <a:ext cx="4617720" cy="438912"/>
-          </a:xfrm>
-          <a:prstGeom prst="rect">
-            <a:avLst/>
-          </a:prstGeom>
-          <a:noFill/>
-        </p:spPr>
-        <p:txBody>
-          <a:bodyPr wrap="square" anchor="t" lIns="0" rIns="0" tIns="0" bIns="0">
-            <a:spAutoFit/>
-          </a:bodyPr>
-          <a:lstStyle/>
-          <a:p>
-            <a:pPr algn="l">
-              <a:spcBef>
-                <a:spcPts val="0"/>
-              </a:spcBef>
-              <a:spcAft>
-                <a:spcPts val="0"/>
-              </a:spcAft>
-              <a:buNone/>
-            </a:pPr>
-            <a:r>
-              <a:rPr sz="2500" b="0" i="0">
-                <a:solidFill>
-                  <a:srgbClr val="757575"/>
-                </a:solidFill>
-                <a:latin typeface="NVIDIA Sans"/>
-              </a:rPr>
-              <a:t>local memory BW / GPU</a:t>
-            </a:r>
-          </a:p>
-        </p:txBody>
-      </p:sp>
-      <p:sp>
-        <p:nvSpPr>
-          <p:cNvPr id="17" name="TextBox 16"/>
-          <p:cNvSpPr txBox="1"/>
-          <p:nvPr/>
-        </p:nvSpPr>
-        <p:spPr>
-          <a:xfrm>
-            <a:off x="7223760" y="10332720"/>
-            <a:ext cx="4617720" cy="640080"/>
-          </a:xfrm>
-          <a:prstGeom prst="rect">
-            <a:avLst/>
-          </a:prstGeom>
-          <a:noFill/>
-        </p:spPr>
-        <p:txBody>
-          <a:bodyPr wrap="square" anchor="t" lIns="0" rIns="0" tIns="0" bIns="0">
-            <a:spAutoFit/>
-          </a:bodyPr>
-          <a:lstStyle/>
-          <a:p>
-            <a:pPr algn="l">
-              <a:spcBef>
-                <a:spcPts val="0"/>
-              </a:spcBef>
-              <a:spcAft>
-                <a:spcPts val="0"/>
-              </a:spcAft>
-              <a:buNone/>
-            </a:pPr>
-            <a:r>
-              <a:rPr sz="4300" b="1" i="0">
-                <a:solidFill>
-                  <a:srgbClr val="313131"/>
-                </a:solidFill>
-                <a:latin typeface="NVIDIA Sans Medium"/>
-              </a:rPr>
-              <a:t>PCIe 5.0 ×16</a:t>
-            </a:r>
-          </a:p>
-        </p:txBody>
-      </p:sp>
-      <p:sp>
-        <p:nvSpPr>
-          <p:cNvPr id="18" name="TextBox 17"/>
-          <p:cNvSpPr txBox="1"/>
-          <p:nvPr/>
-        </p:nvSpPr>
-        <p:spPr>
-          <a:xfrm>
-            <a:off x="7223760" y="11036808"/>
-            <a:ext cx="4617720" cy="438912"/>
-          </a:xfrm>
-          <a:prstGeom prst="rect">
-            <a:avLst/>
-          </a:prstGeom>
-          <a:noFill/>
-        </p:spPr>
-        <p:txBody>
-          <a:bodyPr wrap="square" anchor="t" lIns="0" rIns="0" tIns="0" bIns="0">
-            <a:spAutoFit/>
-          </a:bodyPr>
-          <a:lstStyle/>
-          <a:p>
-            <a:pPr algn="l">
-              <a:spcBef>
-                <a:spcPts val="0"/>
-              </a:spcBef>
-              <a:spcAft>
-                <a:spcPts val="0"/>
-              </a:spcAft>
-              <a:buNone/>
-            </a:pPr>
-            <a:r>
-              <a:rPr sz="2500" b="0" i="0">
-                <a:solidFill>
-                  <a:srgbClr val="757575"/>
-                </a:solidFill>
-                <a:latin typeface="NVIDIA Sans"/>
-              </a:rPr>
-              <a:t>system interface</a:t>
+              <a:t>GDDR7 ECC</a:t>
             </a:r>
           </a:p>
         </p:txBody>
       </p:sp>
       <p:cxnSp>
         <p:nvCxnSpPr>
-          <p:cNvPr id="19" name="Connector 18"/>
+          <p:cNvPr id="12" name="Connector 11"/>
           <p:cNvCxnSpPr/>
           <p:nvPr/>
         </p:nvCxnSpPr>
         <p:spPr>
           <a:xfrm>
-            <a:off x="2148840" y="13121640"/>
-            <a:ext cx="9784080" cy="0"/>
+            <a:off x="17830800" y="5687568"/>
+            <a:ext cx="0" cy="1463040"/>
           </a:xfrm>
           <a:prstGeom prst="line">
             <a:avLst/>
           </a:prstGeom>
-          <a:ln w="12700">
+          <a:ln w="10160">
             <a:solidFill>
               <a:srgbClr val="D9D9D9"/>
             </a:solidFill>
@@ -37143,14 +35530,14 @@
       </p:cxnSp>
       <p:sp>
         <p:nvSpPr>
-          <p:cNvPr id="20" name="TextBox 19"/>
+          <p:cNvPr id="13" name="TextBox 12"/>
           <p:cNvSpPr txBox="1"/>
           <p:nvPr/>
         </p:nvSpPr>
         <p:spPr>
           <a:xfrm>
-            <a:off x="2148840" y="13642848"/>
-            <a:ext cx="3154680" cy="585216"/>
+            <a:off x="18333720" y="5715000"/>
+            <a:ext cx="7269480" cy="749808"/>
           </a:xfrm>
           <a:prstGeom prst="rect">
             <a:avLst/>
@@ -37173,70 +35560,27 @@
               <a:buNone/>
             </a:pPr>
             <a:r>
-              <a:rPr sz="3900" b="1" i="0">
-                <a:solidFill>
-                  <a:srgbClr val="313131"/>
-                </a:solidFill>
-                <a:latin typeface="NVIDIA Sans Medium"/>
-              </a:rPr>
-              <a:t>8 GPUs</a:t>
-            </a:r>
-          </a:p>
-        </p:txBody>
-      </p:sp>
-      <p:sp>
-        <p:nvSpPr>
-          <p:cNvPr id="21" name="TextBox 20"/>
-          <p:cNvSpPr txBox="1"/>
-          <p:nvPr/>
-        </p:nvSpPr>
-        <p:spPr>
-          <a:xfrm>
-            <a:off x="5440680" y="13642848"/>
-            <a:ext cx="6492240" cy="585216"/>
-          </a:xfrm>
-          <a:prstGeom prst="rect">
-            <a:avLst/>
-          </a:prstGeom>
-          <a:noFill/>
-        </p:spPr>
-        <p:txBody>
-          <a:bodyPr wrap="square" anchor="t" lIns="0" rIns="0" tIns="0" bIns="0">
-            <a:spAutoFit/>
-          </a:bodyPr>
-          <a:lstStyle/>
-          <a:p>
-            <a:pPr algn="r">
-              <a:spcBef>
-                <a:spcPts val="0"/>
-              </a:spcBef>
-              <a:spcAft>
-                <a:spcPts val="0"/>
-              </a:spcAft>
-              <a:buNone/>
-            </a:pPr>
-            <a:r>
-              <a:rPr sz="3900" b="1" i="0">
+              <a:rPr sz="4900" b="1" i="0">
                 <a:solidFill>
                   <a:srgbClr val="76B900"/>
                 </a:solidFill>
                 <a:latin typeface="NVIDIA Sans Medium"/>
               </a:rPr>
-              <a:t>880 SM  ·  576 GB</a:t>
-            </a:r>
-          </a:p>
-        </p:txBody>
-      </p:sp>
-      <p:sp>
-        <p:nvSpPr>
-          <p:cNvPr id="22" name="TextBox 21"/>
+              <a:t>1,344 GB/s</a:t>
+            </a:r>
+          </a:p>
+        </p:txBody>
+      </p:sp>
+      <p:sp>
+        <p:nvSpPr>
+          <p:cNvPr id="14" name="TextBox 13"/>
           <p:cNvSpPr txBox="1"/>
           <p:nvPr/>
         </p:nvSpPr>
         <p:spPr>
           <a:xfrm>
-            <a:off x="2148840" y="14401800"/>
-            <a:ext cx="9784080" cy="402336"/>
+            <a:off x="18333720" y="6565392"/>
+            <a:ext cx="7269480" cy="438912"/>
           </a:xfrm>
           <a:prstGeom prst="rect">
             <a:avLst/>
@@ -37259,75 +35603,32 @@
               <a:buNone/>
             </a:pPr>
             <a:r>
-              <a:rPr sz="2400" b="0" i="0">
+              <a:rPr sz="2500" b="0" i="0">
                 <a:solidFill>
                   <a:srgbClr val="757575"/>
                 </a:solidFill>
                 <a:latin typeface="NVIDIA Sans"/>
               </a:rPr>
-              <a:t>aggregate sums · memory is not pooled</a:t>
-            </a:r>
-          </a:p>
-        </p:txBody>
-      </p:sp>
-      <p:sp>
-        <p:nvSpPr>
-          <p:cNvPr id="23" name="TextBox 22"/>
-          <p:cNvSpPr txBox="1"/>
-          <p:nvPr/>
-        </p:nvSpPr>
-        <p:spPr>
-          <a:xfrm>
-            <a:off x="2148840" y="16870680"/>
-            <a:ext cx="9784080" cy="594360"/>
-          </a:xfrm>
-          <a:prstGeom prst="rect">
-            <a:avLst/>
-          </a:prstGeom>
-          <a:noFill/>
-        </p:spPr>
-        <p:txBody>
-          <a:bodyPr wrap="square" anchor="t" lIns="0" rIns="0" tIns="0" bIns="0">
-            <a:spAutoFit/>
-          </a:bodyPr>
-          <a:lstStyle/>
-          <a:p>
-            <a:pPr algn="l">
-              <a:spcBef>
-                <a:spcPts val="0"/>
-              </a:spcBef>
-              <a:spcAft>
-                <a:spcPts val="0"/>
-              </a:spcAft>
-              <a:buNone/>
-            </a:pPr>
-            <a:r>
-              <a:rPr sz="2300" b="0" i="0">
-                <a:solidFill>
-                  <a:srgbClr val="757575"/>
-                </a:solidFill>
-                <a:latin typeface="NVIDIA Sans"/>
-              </a:rPr>
-              <a:t>*14,080 CUDA cores ÷ 128 FP32 cores per CC 12.0 SM</a:t>
+              <a:t>local memory / GPU</a:t>
             </a:r>
           </a:p>
         </p:txBody>
       </p:sp>
       <p:cxnSp>
         <p:nvCxnSpPr>
-          <p:cNvPr id="24" name="Connector 23"/>
+          <p:cNvPr id="15" name="Connector 14"/>
           <p:cNvCxnSpPr/>
           <p:nvPr/>
         </p:nvCxnSpPr>
         <p:spPr>
           <a:xfrm>
-            <a:off x="13304520" y="5120640"/>
-            <a:ext cx="0" cy="12755880"/>
+            <a:off x="25968960" y="5687568"/>
+            <a:ext cx="0" cy="1463040"/>
           </a:xfrm>
           <a:prstGeom prst="line">
             <a:avLst/>
           </a:prstGeom>
-          <a:ln w="12700">
+          <a:ln w="10160">
             <a:solidFill>
               <a:srgbClr val="D9D9D9"/>
             </a:solidFill>
@@ -37350,14 +35651,14 @@
       </p:cxnSp>
       <p:sp>
         <p:nvSpPr>
-          <p:cNvPr id="25" name="TextBox 24"/>
+          <p:cNvPr id="16" name="TextBox 15"/>
           <p:cNvSpPr txBox="1"/>
           <p:nvPr/>
         </p:nvSpPr>
         <p:spPr>
           <a:xfrm>
-            <a:off x="14493240" y="5166360"/>
-            <a:ext cx="10972800" cy="475488"/>
+            <a:off x="26471880" y="5715000"/>
+            <a:ext cx="7269480" cy="749808"/>
           </a:xfrm>
           <a:prstGeom prst="rect">
             <a:avLst/>
@@ -37380,27 +35681,27 @@
               <a:buNone/>
             </a:pPr>
             <a:r>
-              <a:rPr sz="2800" b="1" i="0">
+              <a:rPr sz="4900" b="1" i="0">
                 <a:solidFill>
-                  <a:srgbClr val="757575"/>
+                  <a:srgbClr val="0074DF"/>
                 </a:solidFill>
                 <a:latin typeface="NVIDIA Sans Medium"/>
               </a:rPr>
-              <a:t>CLASSIFY BY TENSOR OWNERSHIP</a:t>
-            </a:r>
-          </a:p>
-        </p:txBody>
-      </p:sp>
-      <p:sp>
-        <p:nvSpPr>
-          <p:cNvPr id="26" name="TextBox 25"/>
+              <a:t>400 Gb/s</a:t>
+            </a:r>
+          </a:p>
+        </p:txBody>
+      </p:sp>
+      <p:sp>
+        <p:nvSpPr>
+          <p:cNvPr id="17" name="TextBox 16"/>
           <p:cNvSpPr txBox="1"/>
           <p:nvPr/>
         </p:nvSpPr>
         <p:spPr>
           <a:xfrm>
-            <a:off x="14493240" y="6126480"/>
-            <a:ext cx="8549640" cy="475488"/>
+            <a:off x="26471880" y="6565392"/>
+            <a:ext cx="7269480" cy="438912"/>
           </a:xfrm>
           <a:prstGeom prst="rect">
             <a:avLst/>
@@ -37423,27 +35724,27 @@
               <a:buNone/>
             </a:pPr>
             <a:r>
-              <a:rPr sz="3100" b="1" i="0">
+              <a:rPr sz="2500" b="0" i="0">
                 <a:solidFill>
-                  <a:srgbClr val="952FC6"/>
+                  <a:srgbClr val="757575"/>
                 </a:solidFill>
-                <a:latin typeface="NVIDIA Sans Medium"/>
+                <a:latin typeface="NVIDIA Sans"/>
               </a:rPr>
-              <a:t>COMMUNICATION-MODEST</a:t>
-            </a:r>
-          </a:p>
-        </p:txBody>
-      </p:sp>
-      <p:sp>
-        <p:nvSpPr>
-          <p:cNvPr id="27" name="TextBox 26"/>
+              <a:t>per active fabric port</a:t>
+            </a:r>
+          </a:p>
+        </p:txBody>
+      </p:sp>
+      <p:sp>
+        <p:nvSpPr>
+          <p:cNvPr id="18" name="TextBox 17"/>
           <p:cNvSpPr txBox="1"/>
           <p:nvPr/>
         </p:nvSpPr>
         <p:spPr>
           <a:xfrm>
-            <a:off x="25420320" y="6126480"/>
-            <a:ext cx="8915400" cy="475488"/>
+            <a:off x="2057400" y="7498079"/>
+            <a:ext cx="32461200" cy="420624"/>
           </a:xfrm>
           <a:prstGeom prst="rect">
             <a:avLst/>
@@ -37456,7 +35757,7 @@
           </a:bodyPr>
           <a:lstStyle/>
           <a:p>
-            <a:pPr algn="r">
+            <a:pPr algn="l">
               <a:spcBef>
                 <a:spcPts val="0"/>
               </a:spcBef>
@@ -37466,27 +35767,27 @@
               <a:buNone/>
             </a:pPr>
             <a:r>
-              <a:rPr sz="3100" b="1" i="0">
+              <a:rPr sz="2300" b="0" i="0">
                 <a:solidFill>
-                  <a:srgbClr val="0074DF"/>
+                  <a:srgbClr val="757575"/>
                 </a:solidFill>
-                <a:latin typeface="NVIDIA Sans Medium"/>
+                <a:latin typeface="NVIDIA Sans"/>
               </a:rPr>
-              <a:t>COMMUNICATION-INTENSIVE</a:t>
+              <a:t>8-GPU system: 880 SM · 576 GB GPU-local memory · 8 active 400 Gb/s fabric ports · memory is not pooled</a:t>
             </a:r>
           </a:p>
         </p:txBody>
       </p:sp>
       <p:cxnSp>
         <p:nvCxnSpPr>
-          <p:cNvPr id="28" name="Connector 27"/>
+          <p:cNvPr id="19" name="Connector 18"/>
           <p:cNvCxnSpPr/>
           <p:nvPr/>
         </p:nvCxnSpPr>
         <p:spPr>
           <a:xfrm>
-            <a:off x="24094440" y="6080760"/>
-            <a:ext cx="0" cy="4983480"/>
+            <a:off x="2057400" y="8275320"/>
+            <a:ext cx="32461200" cy="0"/>
           </a:xfrm>
           <a:prstGeom prst="line">
             <a:avLst/>
@@ -37514,14 +35815,14 @@
       </p:cxnSp>
       <p:sp>
         <p:nvSpPr>
-          <p:cNvPr id="29" name="TextBox 28"/>
+          <p:cNvPr id="20" name="TextBox 19"/>
           <p:cNvSpPr txBox="1"/>
           <p:nvPr/>
         </p:nvSpPr>
         <p:spPr>
           <a:xfrm>
-            <a:off x="14493240" y="7059168"/>
-            <a:ext cx="2148840" cy="384048"/>
+            <a:off x="2057400" y="8823960"/>
+            <a:ext cx="9144000" cy="475488"/>
           </a:xfrm>
           <a:prstGeom prst="rect">
             <a:avLst/>
@@ -37544,27 +35845,293 @@
               <a:buNone/>
             </a:pPr>
             <a:r>
-              <a:rPr sz="2300" b="1" i="0">
+              <a:rPr sz="2800" b="1" i="0">
                 <a:solidFill>
                   <a:srgbClr val="757575"/>
                 </a:solidFill>
                 <a:latin typeface="NVIDIA Sans Medium"/>
               </a:rPr>
-              <a:t>PLACEMENT</a:t>
-            </a:r>
-          </a:p>
-        </p:txBody>
-      </p:sp>
-      <p:sp>
-        <p:nvSpPr>
-          <p:cNvPr id="30" name="TextBox 29"/>
+              <a:t>TWO EXECUTION REGIMES</a:t>
+            </a:r>
+          </a:p>
+        </p:txBody>
+      </p:sp>
+      <p:graphicFrame>
+        <p:nvGraphicFramePr>
+          <p:cNvPr id="21" name="Table 20"/>
+          <p:cNvGraphicFramePr>
+            <a:graphicFrameLocks noGrp="1"/>
+          </p:cNvGraphicFramePr>
+          <p:nvPr/>
+        </p:nvGraphicFramePr>
+        <p:xfrm>
+          <a:off x="2057400" y="9464040"/>
+          <a:ext cx="18333720" cy="5577840"/>
+        </p:xfrm>
+        <a:graphic>
+          <a:graphicData uri="http://schemas.openxmlformats.org/drawingml/2006/table">
+            <a:tbl>
+              <a:tblPr firstRow="1" bandRow="1">
+                <a:tableStyleId>{68D230F3-CF80-4859-8CE7-A43EE81993B5}</a:tableStyleId>
+              </a:tblPr>
+              <a:tblGrid>
+                <a:gridCol w="4983480"/>
+                <a:gridCol w="5120640"/>
+                <a:gridCol w="5074920"/>
+                <a:gridCol w="3154680"/>
+              </a:tblGrid>
+              <a:tr h="1859280">
+                <a:tc>
+                  <a:txBody>
+                    <a:bodyPr wrap="square"/>
+                    <a:lstStyle/>
+                    <a:p>
+                      <a:pPr algn="ctr"/>
+                      <a:r>
+                        <a:rPr sz="3000" b="1" i="0">
+                          <a:solidFill>
+                            <a:srgbClr val="76B900"/>
+                          </a:solidFill>
+                          <a:latin typeface="NVIDIA Sans Medium"/>
+                        </a:rPr>
+                        <a:t>Path</a:t>
+                      </a:r>
+                    </a:p>
+                  </a:txBody>
+                  <a:tcPr marL="365760" marR="182880" marT="91440" marB="91440" anchor="ctr"/>
+                </a:tc>
+                <a:tc>
+                  <a:txBody>
+                    <a:bodyPr wrap="square"/>
+                    <a:lstStyle/>
+                    <a:p>
+                      <a:pPr algn="ctr"/>
+                      <a:r>
+                        <a:rPr sz="3000" b="1" i="0">
+                          <a:solidFill>
+                            <a:srgbClr val="76B900"/>
+                          </a:solidFill>
+                          <a:latin typeface="NVIDIA Sans Medium"/>
+                        </a:rPr>
+                        <a:t>Tensor ownership</a:t>
+                      </a:r>
+                    </a:p>
+                  </a:txBody>
+                  <a:tcPr marL="182880" marR="182880" marT="91440" marB="91440" anchor="ctr"/>
+                </a:tc>
+                <a:tc>
+                  <a:txBody>
+                    <a:bodyPr wrap="square"/>
+                    <a:lstStyle/>
+                    <a:p>
+                      <a:pPr algn="ctr"/>
+                      <a:r>
+                        <a:rPr sz="3000" b="1" i="0">
+                          <a:solidFill>
+                            <a:srgbClr val="76B900"/>
+                          </a:solidFill>
+                          <a:latin typeface="NVIDIA Sans Medium"/>
+                        </a:rPr>
+                        <a:t>Synchronization</a:t>
+                      </a:r>
+                    </a:p>
+                  </a:txBody>
+                  <a:tcPr marL="182880" marR="182880" marT="91440" marB="91440" anchor="ctr"/>
+                </a:tc>
+                <a:tc>
+                  <a:txBody>
+                    <a:bodyPr wrap="square"/>
+                    <a:lstStyle/>
+                    <a:p>
+                      <a:pPr algn="ctr"/>
+                      <a:r>
+                        <a:rPr sz="3000" b="1" i="0">
+                          <a:solidFill>
+                            <a:srgbClr val="76B900"/>
+                          </a:solidFill>
+                          <a:latin typeface="NVIDIA Sans Medium"/>
+                        </a:rPr>
+                        <a:t>Fabric pressure</a:t>
+                      </a:r>
+                    </a:p>
+                  </a:txBody>
+                  <a:tcPr marL="182880" marR="182880" marT="91440" marB="91440" anchor="ctr"/>
+                </a:tc>
+              </a:tr>
+              <a:tr h="1859280">
+                <a:tc>
+                  <a:txBody>
+                    <a:bodyPr wrap="square"/>
+                    <a:lstStyle/>
+                    <a:p>
+                      <a:pPr algn="l"/>
+                      <a:r>
+                        <a:rPr sz="2700" b="1" i="0">
+                          <a:solidFill>
+                            <a:srgbClr val="313131"/>
+                          </a:solidFill>
+                          <a:latin typeface="NVIDIA Sans Medium"/>
+                        </a:rPr>
+                        <a:t>Projection / MLP /
+local VSA tiles</a:t>
+                      </a:r>
+                    </a:p>
+                  </a:txBody>
+                  <a:tcPr marL="365760" marR="182880" marT="91440" marB="91440" anchor="ctr"/>
+                </a:tc>
+                <a:tc>
+                  <a:txBody>
+                    <a:bodyPr wrap="square"/>
+                    <a:lstStyle/>
+                    <a:p>
+                      <a:pPr algn="l"/>
+                      <a:r>
+                        <a:rPr sz="2700" b="0" i="0">
+                          <a:solidFill>
+                            <a:srgbClr val="313131"/>
+                          </a:solidFill>
+                          <a:latin typeface="NVIDIA Sans"/>
+                        </a:rPr>
+                        <a:t>Stays on one GPU</a:t>
+                      </a:r>
+                    </a:p>
+                  </a:txBody>
+                  <a:tcPr marL="182880" marR="182880" marT="91440" marB="91440" anchor="ctr"/>
+                </a:tc>
+                <a:tc>
+                  <a:txBody>
+                    <a:bodyPr wrap="square"/>
+                    <a:lstStyle/>
+                    <a:p>
+                      <a:pPr algn="l"/>
+                      <a:r>
+                        <a:rPr sz="2700" b="0" i="0">
+                          <a:solidFill>
+                            <a:srgbClr val="313131"/>
+                          </a:solidFill>
+                          <a:latin typeface="NVIDIA Sans"/>
+                        </a:rPr>
+                        <a:t>Few readiness fences</a:t>
+                      </a:r>
+                    </a:p>
+                  </a:txBody>
+                  <a:tcPr marL="182880" marR="182880" marT="91440" marB="91440" anchor="ctr"/>
+                </a:tc>
+                <a:tc>
+                  <a:txBody>
+                    <a:bodyPr wrap="square"/>
+                    <a:lstStyle/>
+                    <a:p>
+                      <a:pPr algn="ctr"/>
+                      <a:r>
+                        <a:rPr sz="2700" b="1" i="0">
+                          <a:solidFill>
+                            <a:srgbClr val="757575"/>
+                          </a:solidFill>
+                          <a:latin typeface="NVIDIA Sans Medium"/>
+                        </a:rPr>
+                        <a:t>Modest</a:t>
+                      </a:r>
+                    </a:p>
+                  </a:txBody>
+                  <a:tcPr marL="182880" marR="182880" marT="91440" marB="91440" anchor="ctr"/>
+                </a:tc>
+              </a:tr>
+              <a:tr h="1859280">
+                <a:tc>
+                  <a:txBody>
+                    <a:bodyPr wrap="square"/>
+                    <a:lstStyle/>
+                    <a:p>
+                      <a:pPr algn="l"/>
+                      <a:r>
+                        <a:rPr sz="2700" b="1" i="0">
+                          <a:solidFill>
+                            <a:srgbClr val="313131"/>
+                          </a:solidFill>
+                          <a:latin typeface="NVIDIA Sans Medium"/>
+                        </a:rPr>
+                        <a:t>Ulysses SP8
+attention</a:t>
+                      </a:r>
+                    </a:p>
+                  </a:txBody>
+                  <a:tcPr marL="365760" marR="182880" marT="91440" marB="91440" anchor="ctr"/>
+                </a:tc>
+                <a:tc>
+                  <a:txBody>
+                    <a:bodyPr wrap="square"/>
+                    <a:lstStyle/>
+                    <a:p>
+                      <a:pPr algn="l"/>
+                      <a:r>
+                        <a:rPr sz="2700" b="0" i="0">
+                          <a:solidFill>
+                            <a:srgbClr val="313131"/>
+                          </a:solidFill>
+                          <a:latin typeface="NVIDIA Sans"/>
+                        </a:rPr>
+                        <a:t>Q/K/V + Gate/O
+move across ranks</a:t>
+                      </a:r>
+                    </a:p>
+                  </a:txBody>
+                  <a:tcPr marL="182880" marR="182880" marT="91440" marB="91440" anchor="ctr"/>
+                </a:tc>
+                <a:tc>
+                  <a:txBody>
+                    <a:bodyPr wrap="square"/>
+                    <a:lstStyle/>
+                    <a:p>
+                      <a:pPr algn="l"/>
+                      <a:r>
+                        <a:rPr sz="2700" b="0" i="0">
+                          <a:solidFill>
+                            <a:srgbClr val="313131"/>
+                          </a:solidFill>
+                          <a:latin typeface="NVIDIA Sans"/>
+                        </a:rPr>
+                        <a:t>Transfers + barriers
+on dependency path</a:t>
+                      </a:r>
+                    </a:p>
+                  </a:txBody>
+                  <a:tcPr marL="182880" marR="182880" marT="91440" marB="91440" anchor="ctr"/>
+                </a:tc>
+                <a:tc>
+                  <a:txBody>
+                    <a:bodyPr wrap="square"/>
+                    <a:lstStyle/>
+                    <a:p>
+                      <a:pPr algn="ctr"/>
+                      <a:r>
+                        <a:rPr sz="2700" b="1" i="0">
+                          <a:solidFill>
+                            <a:srgbClr val="0074DF"/>
+                          </a:solidFill>
+                          <a:latin typeface="NVIDIA Sans Medium"/>
+                        </a:rPr>
+                        <a:t>High</a:t>
+                      </a:r>
+                    </a:p>
+                  </a:txBody>
+                  <a:tcPr marL="182880" marR="182880" marT="91440" marB="91440" anchor="ctr"/>
+                </a:tc>
+              </a:tr>
+            </a:tbl>
+          </a:graphicData>
+        </a:graphic>
+      </p:graphicFrame>
+      <p:sp>
+        <p:nvSpPr>
+          <p:cNvPr id="22" name="TextBox 21"/>
           <p:cNvSpPr txBox="1"/>
           <p:nvPr/>
         </p:nvSpPr>
         <p:spPr>
           <a:xfrm>
-            <a:off x="16687800" y="7013448"/>
-            <a:ext cx="6949440" cy="530352"/>
+            <a:off x="2057400" y="15681959"/>
+            <a:ext cx="18333720" cy="868680"/>
           </a:xfrm>
           <a:prstGeom prst="rect">
             <a:avLst/>
@@ -37587,464 +36154,34 @@
               <a:buNone/>
             </a:pPr>
             <a:r>
-              <a:rPr sz="2700" b="0" i="0">
+              <a:rPr sz="2900" b="1" i="0">
                 <a:solidFill>
                   <a:srgbClr val="313131"/>
                 </a:solidFill>
-                <a:latin typeface="NVIDIA Sans"/>
-              </a:rPr>
-              <a:t>tensors remain local</a:t>
-            </a:r>
-          </a:p>
-        </p:txBody>
-      </p:sp>
-      <p:sp>
-        <p:nvSpPr>
-          <p:cNvPr id="31" name="TextBox 30"/>
-          <p:cNvSpPr txBox="1"/>
-          <p:nvPr/>
-        </p:nvSpPr>
-        <p:spPr>
-          <a:xfrm>
-            <a:off x="24734520" y="7059168"/>
-            <a:ext cx="2148840" cy="384048"/>
-          </a:xfrm>
-          <a:prstGeom prst="rect">
-            <a:avLst/>
-          </a:prstGeom>
-          <a:noFill/>
-        </p:spPr>
-        <p:txBody>
-          <a:bodyPr wrap="square" anchor="t" lIns="0" rIns="0" tIns="0" bIns="0">
-            <a:spAutoFit/>
-          </a:bodyPr>
-          <a:lstStyle/>
-          <a:p>
-            <a:pPr algn="l">
-              <a:spcBef>
-                <a:spcPts val="0"/>
-              </a:spcBef>
-              <a:spcAft>
-                <a:spcPts val="0"/>
-              </a:spcAft>
-              <a:buNone/>
-            </a:pPr>
-            <a:r>
-              <a:rPr sz="2300" b="1" i="0">
-                <a:solidFill>
-                  <a:srgbClr val="757575"/>
-                </a:solidFill>
                 <a:latin typeface="NVIDIA Sans Medium"/>
               </a:rPr>
-              <a:t>PLACEMENT</a:t>
-            </a:r>
-          </a:p>
-        </p:txBody>
-      </p:sp>
-      <p:sp>
-        <p:nvSpPr>
-          <p:cNvPr id="32" name="TextBox 31"/>
-          <p:cNvSpPr txBox="1"/>
-          <p:nvPr/>
-        </p:nvSpPr>
-        <p:spPr>
-          <a:xfrm>
-            <a:off x="26929080" y="7013448"/>
-            <a:ext cx="7406640" cy="530352"/>
-          </a:xfrm>
-          <a:prstGeom prst="rect">
-            <a:avLst/>
-          </a:prstGeom>
-          <a:noFill/>
-        </p:spPr>
-        <p:txBody>
-          <a:bodyPr wrap="square" anchor="t" lIns="0" rIns="0" tIns="0" bIns="0">
-            <a:spAutoFit/>
-          </a:bodyPr>
-          <a:lstStyle/>
-          <a:p>
-            <a:pPr algn="l">
-              <a:spcBef>
-                <a:spcPts val="0"/>
-              </a:spcBef>
-              <a:spcAft>
-                <a:spcPts val="0"/>
-              </a:spcAft>
-              <a:buNone/>
-            </a:pPr>
-            <a:r>
-              <a:rPr sz="2700" b="0" i="0">
-                <a:solidFill>
-                  <a:srgbClr val="313131"/>
-                </a:solidFill>
-                <a:latin typeface="NVIDIA Sans"/>
-              </a:rPr>
-              <a:t>Q / K / V / Gate / O change rank</a:t>
-            </a:r>
-          </a:p>
-        </p:txBody>
-      </p:sp>
-      <p:sp>
-        <p:nvSpPr>
-          <p:cNvPr id="33" name="TextBox 32"/>
-          <p:cNvSpPr txBox="1"/>
-          <p:nvPr/>
-        </p:nvSpPr>
-        <p:spPr>
-          <a:xfrm>
-            <a:off x="14493240" y="8412480"/>
-            <a:ext cx="2148840" cy="384048"/>
-          </a:xfrm>
-          <a:prstGeom prst="rect">
-            <a:avLst/>
-          </a:prstGeom>
-          <a:noFill/>
-        </p:spPr>
-        <p:txBody>
-          <a:bodyPr wrap="square" anchor="t" lIns="0" rIns="0" tIns="0" bIns="0">
-            <a:spAutoFit/>
-          </a:bodyPr>
-          <a:lstStyle/>
-          <a:p>
-            <a:pPr algn="l">
-              <a:spcBef>
-                <a:spcPts val="0"/>
-              </a:spcBef>
-              <a:spcAft>
-                <a:spcPts val="0"/>
-              </a:spcAft>
-              <a:buNone/>
-            </a:pPr>
-            <a:r>
-              <a:rPr sz="2300" b="1" i="0">
-                <a:solidFill>
-                  <a:srgbClr val="757575"/>
-                </a:solidFill>
-                <a:latin typeface="NVIDIA Sans Medium"/>
-              </a:rPr>
-              <a:t>SYNC</a:t>
-            </a:r>
-          </a:p>
-        </p:txBody>
-      </p:sp>
-      <p:sp>
-        <p:nvSpPr>
-          <p:cNvPr id="34" name="TextBox 33"/>
-          <p:cNvSpPr txBox="1"/>
-          <p:nvPr/>
-        </p:nvSpPr>
-        <p:spPr>
-          <a:xfrm>
-            <a:off x="16687800" y="8366759"/>
-            <a:ext cx="6949440" cy="530352"/>
-          </a:xfrm>
-          <a:prstGeom prst="rect">
-            <a:avLst/>
-          </a:prstGeom>
-          <a:noFill/>
-        </p:spPr>
-        <p:txBody>
-          <a:bodyPr wrap="square" anchor="t" lIns="0" rIns="0" tIns="0" bIns="0">
-            <a:spAutoFit/>
-          </a:bodyPr>
-          <a:lstStyle/>
-          <a:p>
-            <a:pPr algn="l">
-              <a:spcBef>
-                <a:spcPts val="0"/>
-              </a:spcBef>
-              <a:spcAft>
-                <a:spcPts val="0"/>
-              </a:spcAft>
-              <a:buNone/>
-            </a:pPr>
-            <a:r>
-              <a:rPr sz="2700" b="0" i="0">
-                <a:solidFill>
-                  <a:srgbClr val="313131"/>
-                </a:solidFill>
-                <a:latin typeface="NVIDIA Sans"/>
-              </a:rPr>
-              <a:t>few readiness fences</a:t>
-            </a:r>
-          </a:p>
-        </p:txBody>
-      </p:sp>
-      <p:sp>
-        <p:nvSpPr>
-          <p:cNvPr id="35" name="TextBox 34"/>
-          <p:cNvSpPr txBox="1"/>
-          <p:nvPr/>
-        </p:nvSpPr>
-        <p:spPr>
-          <a:xfrm>
-            <a:off x="24734520" y="8412480"/>
-            <a:ext cx="2148840" cy="384048"/>
-          </a:xfrm>
-          <a:prstGeom prst="rect">
-            <a:avLst/>
-          </a:prstGeom>
-          <a:noFill/>
-        </p:spPr>
-        <p:txBody>
-          <a:bodyPr wrap="square" anchor="t" lIns="0" rIns="0" tIns="0" bIns="0">
-            <a:spAutoFit/>
-          </a:bodyPr>
-          <a:lstStyle/>
-          <a:p>
-            <a:pPr algn="l">
-              <a:spcBef>
-                <a:spcPts val="0"/>
-              </a:spcBef>
-              <a:spcAft>
-                <a:spcPts val="0"/>
-              </a:spcAft>
-              <a:buNone/>
-            </a:pPr>
-            <a:r>
-              <a:rPr sz="2300" b="1" i="0">
-                <a:solidFill>
-                  <a:srgbClr val="757575"/>
-                </a:solidFill>
-                <a:latin typeface="NVIDIA Sans Medium"/>
-              </a:rPr>
-              <a:t>SYNC</a:t>
-            </a:r>
-          </a:p>
-        </p:txBody>
-      </p:sp>
-      <p:sp>
-        <p:nvSpPr>
-          <p:cNvPr id="36" name="TextBox 35"/>
-          <p:cNvSpPr txBox="1"/>
-          <p:nvPr/>
-        </p:nvSpPr>
-        <p:spPr>
-          <a:xfrm>
-            <a:off x="26929080" y="8366759"/>
-            <a:ext cx="7406640" cy="530352"/>
-          </a:xfrm>
-          <a:prstGeom prst="rect">
-            <a:avLst/>
-          </a:prstGeom>
-          <a:noFill/>
-        </p:spPr>
-        <p:txBody>
-          <a:bodyPr wrap="square" anchor="t" lIns="0" rIns="0" tIns="0" bIns="0">
-            <a:spAutoFit/>
-          </a:bodyPr>
-          <a:lstStyle/>
-          <a:p>
-            <a:pPr algn="l">
-              <a:spcBef>
-                <a:spcPts val="0"/>
-              </a:spcBef>
-              <a:spcAft>
-                <a:spcPts val="0"/>
-              </a:spcAft>
-              <a:buNone/>
-            </a:pPr>
-            <a:r>
-              <a:rPr sz="2700" b="0" i="0">
-                <a:solidFill>
-                  <a:srgbClr val="313131"/>
-                </a:solidFill>
-                <a:latin typeface="NVIDIA Sans"/>
-              </a:rPr>
-              <a:t>barriers sit on the dependency path</a:t>
-            </a:r>
-          </a:p>
-        </p:txBody>
-      </p:sp>
-      <p:sp>
-        <p:nvSpPr>
-          <p:cNvPr id="37" name="TextBox 36"/>
-          <p:cNvSpPr txBox="1"/>
-          <p:nvPr/>
-        </p:nvSpPr>
-        <p:spPr>
-          <a:xfrm>
-            <a:off x="14493240" y="9765792"/>
-            <a:ext cx="2148840" cy="384048"/>
-          </a:xfrm>
-          <a:prstGeom prst="rect">
-            <a:avLst/>
-          </a:prstGeom>
-          <a:noFill/>
-        </p:spPr>
-        <p:txBody>
-          <a:bodyPr wrap="square" anchor="t" lIns="0" rIns="0" tIns="0" bIns="0">
-            <a:spAutoFit/>
-          </a:bodyPr>
-          <a:lstStyle/>
-          <a:p>
-            <a:pPr algn="l">
-              <a:spcBef>
-                <a:spcPts val="0"/>
-              </a:spcBef>
-              <a:spcAft>
-                <a:spcPts val="0"/>
-              </a:spcAft>
-              <a:buNone/>
-            </a:pPr>
-            <a:r>
-              <a:rPr sz="2300" b="1" i="0">
-                <a:solidFill>
-                  <a:srgbClr val="757575"/>
-                </a:solidFill>
-                <a:latin typeface="NVIDIA Sans Medium"/>
-              </a:rPr>
-              <a:t>EXAMPLES</a:t>
-            </a:r>
-          </a:p>
-        </p:txBody>
-      </p:sp>
-      <p:sp>
-        <p:nvSpPr>
-          <p:cNvPr id="38" name="TextBox 37"/>
-          <p:cNvSpPr txBox="1"/>
-          <p:nvPr/>
-        </p:nvSpPr>
-        <p:spPr>
-          <a:xfrm>
-            <a:off x="16687800" y="9720072"/>
-            <a:ext cx="6949440" cy="530352"/>
-          </a:xfrm>
-          <a:prstGeom prst="rect">
-            <a:avLst/>
-          </a:prstGeom>
-          <a:noFill/>
-        </p:spPr>
-        <p:txBody>
-          <a:bodyPr wrap="square" anchor="t" lIns="0" rIns="0" tIns="0" bIns="0">
-            <a:spAutoFit/>
-          </a:bodyPr>
-          <a:lstStyle/>
-          <a:p>
-            <a:pPr algn="l">
-              <a:spcBef>
-                <a:spcPts val="0"/>
-              </a:spcBef>
-              <a:spcAft>
-                <a:spcPts val="0"/>
-              </a:spcAft>
-              <a:buNone/>
-            </a:pPr>
-            <a:r>
-              <a:rPr sz="2700" b="0" i="0">
-                <a:solidFill>
-                  <a:srgbClr val="313131"/>
-                </a:solidFill>
-                <a:latin typeface="NVIDIA Sans"/>
-              </a:rPr>
-              <a:t>projection · MLP · local VSA tiles</a:t>
-            </a:r>
-          </a:p>
-        </p:txBody>
-      </p:sp>
-      <p:sp>
-        <p:nvSpPr>
-          <p:cNvPr id="39" name="TextBox 38"/>
-          <p:cNvSpPr txBox="1"/>
-          <p:nvPr/>
-        </p:nvSpPr>
-        <p:spPr>
-          <a:xfrm>
-            <a:off x="24734520" y="9765792"/>
-            <a:ext cx="2148840" cy="384048"/>
-          </a:xfrm>
-          <a:prstGeom prst="rect">
-            <a:avLst/>
-          </a:prstGeom>
-          <a:noFill/>
-        </p:spPr>
-        <p:txBody>
-          <a:bodyPr wrap="square" anchor="t" lIns="0" rIns="0" tIns="0" bIns="0">
-            <a:spAutoFit/>
-          </a:bodyPr>
-          <a:lstStyle/>
-          <a:p>
-            <a:pPr algn="l">
-              <a:spcBef>
-                <a:spcPts val="0"/>
-              </a:spcBef>
-              <a:spcAft>
-                <a:spcPts val="0"/>
-              </a:spcAft>
-              <a:buNone/>
-            </a:pPr>
-            <a:r>
-              <a:rPr sz="2300" b="1" i="0">
-                <a:solidFill>
-                  <a:srgbClr val="757575"/>
-                </a:solidFill>
-                <a:latin typeface="NVIDIA Sans Medium"/>
-              </a:rPr>
-              <a:t>EXAMPLE</a:t>
-            </a:r>
-          </a:p>
-        </p:txBody>
-      </p:sp>
-      <p:sp>
-        <p:nvSpPr>
-          <p:cNvPr id="40" name="TextBox 39"/>
-          <p:cNvSpPr txBox="1"/>
-          <p:nvPr/>
-        </p:nvSpPr>
-        <p:spPr>
-          <a:xfrm>
-            <a:off x="26929080" y="9720072"/>
-            <a:ext cx="7406640" cy="530352"/>
-          </a:xfrm>
-          <a:prstGeom prst="rect">
-            <a:avLst/>
-          </a:prstGeom>
-          <a:noFill/>
-        </p:spPr>
-        <p:txBody>
-          <a:bodyPr wrap="square" anchor="t" lIns="0" rIns="0" tIns="0" bIns="0">
-            <a:spAutoFit/>
-          </a:bodyPr>
-          <a:lstStyle/>
-          <a:p>
-            <a:pPr algn="l">
-              <a:spcBef>
-                <a:spcPts val="0"/>
-              </a:spcBef>
-              <a:spcAft>
-                <a:spcPts val="0"/>
-              </a:spcAft>
-              <a:buNone/>
-            </a:pPr>
-            <a:r>
-              <a:rPr sz="2700" b="0" i="0">
-                <a:solidFill>
-                  <a:srgbClr val="313131"/>
-                </a:solidFill>
-                <a:latin typeface="NVIDIA Sans"/>
-              </a:rPr>
-              <a:t>Ulysses SP8 attention</a:t>
+              <a:t>Communication pressure is determined by where tensors must move, not by operator FLOPs alone.</a:t>
             </a:r>
           </a:p>
         </p:txBody>
       </p:sp>
       <p:cxnSp>
         <p:nvCxnSpPr>
-          <p:cNvPr id="41" name="Connector 40"/>
+          <p:cNvPr id="23" name="Connector 22"/>
           <p:cNvCxnSpPr/>
           <p:nvPr/>
         </p:nvCxnSpPr>
         <p:spPr>
           <a:xfrm>
-            <a:off x="14721840" y="12161520"/>
-            <a:ext cx="19202400" cy="0"/>
+            <a:off x="21442680" y="8778240"/>
+            <a:ext cx="0" cy="8732520"/>
           </a:xfrm>
           <a:prstGeom prst="line">
             <a:avLst/>
           </a:prstGeom>
-          <a:ln w="25400">
+          <a:ln w="12700">
             <a:solidFill>
-              <a:srgbClr val="757575"/>
+              <a:srgbClr val="D9D9D9"/>
             </a:solidFill>
           </a:ln>
         </p:spPr>
@@ -38065,100 +36202,186 @@
       </p:cxnSp>
       <p:sp>
         <p:nvSpPr>
-          <p:cNvPr id="42" name="Isosceles Triangle 41"/>
-          <p:cNvSpPr/>
+          <p:cNvPr id="24" name="TextBox 23"/>
+          <p:cNvSpPr txBox="1"/>
           <p:nvPr/>
         </p:nvSpPr>
         <p:spPr>
-          <a:xfrm rot="5400000">
-            <a:off x="33768792" y="12006072"/>
-            <a:ext cx="310896" cy="310896"/>
-          </a:xfrm>
-          <a:prstGeom prst="triangle">
+          <a:xfrm>
+            <a:off x="22539960" y="8823960"/>
+            <a:ext cx="9144000" cy="475488"/>
+          </a:xfrm>
+          <a:prstGeom prst="rect">
             <a:avLst/>
           </a:prstGeom>
-          <a:solidFill>
-            <a:srgbClr val="757575"/>
-          </a:solidFill>
-          <a:ln>
-            <a:noFill/>
-          </a:ln>
-        </p:spPr>
-        <p:style>
-          <a:lnRef idx="1">
-            <a:schemeClr val="accent1"/>
-          </a:lnRef>
-          <a:fillRef idx="3">
-            <a:schemeClr val="accent1"/>
-          </a:fillRef>
-          <a:effectRef idx="2">
-            <a:schemeClr val="accent1"/>
-          </a:effectRef>
-          <a:fontRef idx="minor">
-            <a:schemeClr val="lt1"/>
-          </a:fontRef>
-        </p:style>
-        <p:txBody>
-          <a:bodyPr rtlCol="0" anchor="ctr"/>
+          <a:noFill/>
+        </p:spPr>
+        <p:txBody>
+          <a:bodyPr wrap="square" anchor="t" lIns="0" rIns="0" tIns="0" bIns="0">
+            <a:spAutoFit/>
+          </a:bodyPr>
           <a:lstStyle/>
           <a:p>
-            <a:pPr algn="ctr"/>
-          </a:p>
-        </p:txBody>
-      </p:sp>
-      <p:sp>
-        <p:nvSpPr>
-          <p:cNvPr id="43" name="Oval 42"/>
-          <p:cNvSpPr/>
+            <a:pPr algn="l">
+              <a:spcBef>
+                <a:spcPts val="0"/>
+              </a:spcBef>
+              <a:spcAft>
+                <a:spcPts val="0"/>
+              </a:spcAft>
+              <a:buNone/>
+            </a:pPr>
+            <a:r>
+              <a:rPr sz="2800" b="1" i="0">
+                <a:solidFill>
+                  <a:srgbClr val="757575"/>
+                </a:solidFill>
+                <a:latin typeface="NVIDIA Sans Medium"/>
+              </a:rPr>
+              <a:t>WHY BANDWIDTH MATTERS</a:t>
+            </a:r>
+          </a:p>
+        </p:txBody>
+      </p:sp>
+      <p:sp>
+        <p:nvSpPr>
+          <p:cNvPr id="25" name="TextBox 24"/>
+          <p:cNvSpPr txBox="1"/>
           <p:nvPr/>
         </p:nvSpPr>
         <p:spPr>
           <a:xfrm>
-            <a:off x="16532352" y="11960352"/>
-            <a:ext cx="402336" cy="402336"/>
-          </a:xfrm>
-          <a:prstGeom prst="ellipse">
+            <a:off x="22539960" y="9582912"/>
+            <a:ext cx="11978640" cy="548640"/>
+          </a:xfrm>
+          <a:prstGeom prst="rect">
             <a:avLst/>
           </a:prstGeom>
-          <a:solidFill>
-            <a:srgbClr val="952FC6"/>
-          </a:solidFill>
-          <a:ln>
-            <a:noFill/>
-          </a:ln>
-        </p:spPr>
-        <p:style>
-          <a:lnRef idx="1">
-            <a:schemeClr val="accent1"/>
-          </a:lnRef>
-          <a:fillRef idx="3">
-            <a:schemeClr val="accent1"/>
-          </a:fillRef>
-          <a:effectRef idx="2">
-            <a:schemeClr val="accent1"/>
-          </a:effectRef>
-          <a:fontRef idx="minor">
-            <a:schemeClr val="lt1"/>
-          </a:fontRef>
-        </p:style>
-        <p:txBody>
-          <a:bodyPr rtlCol="0" anchor="ctr"/>
+          <a:noFill/>
+        </p:spPr>
+        <p:txBody>
+          <a:bodyPr wrap="square" anchor="t" lIns="0" rIns="0" tIns="0" bIns="0">
+            <a:spAutoFit/>
+          </a:bodyPr>
           <a:lstStyle/>
           <a:p>
-            <a:pPr algn="ctr"/>
-          </a:p>
-        </p:txBody>
-      </p:sp>
-      <p:sp>
-        <p:nvSpPr>
-          <p:cNvPr id="44" name="TextBox 43"/>
+            <a:pPr algn="l">
+              <a:spcBef>
+                <a:spcPts val="0"/>
+              </a:spcBef>
+              <a:spcAft>
+                <a:spcPts val="0"/>
+              </a:spcAft>
+              <a:buNone/>
+            </a:pPr>
+            <a:r>
+              <a:rPr sz="2800" b="1" i="0">
+                <a:solidFill>
+                  <a:srgbClr val="0074DF"/>
+                </a:solidFill>
+                <a:latin typeface="NVIDIA Sans Medium"/>
+              </a:rPr>
+              <a:t>400 Gb/s ÷ 8 = 50 GB/s</a:t>
+            </a:r>
+          </a:p>
+        </p:txBody>
+      </p:sp>
+      <p:sp>
+        <p:nvSpPr>
+          <p:cNvPr id="26" name="TextBox 25"/>
           <p:cNvSpPr txBox="1"/>
           <p:nvPr/>
         </p:nvSpPr>
         <p:spPr>
           <a:xfrm>
-            <a:off x="14721840" y="12573000"/>
-            <a:ext cx="4023360" cy="868680"/>
+            <a:off x="22539960" y="10149840"/>
+            <a:ext cx="11978640" cy="384048"/>
+          </a:xfrm>
+          <a:prstGeom prst="rect">
+            <a:avLst/>
+          </a:prstGeom>
+          <a:noFill/>
+        </p:spPr>
+        <p:txBody>
+          <a:bodyPr wrap="square" anchor="t" lIns="0" rIns="0" tIns="0" bIns="0">
+            <a:spAutoFit/>
+          </a:bodyPr>
+          <a:lstStyle/>
+          <a:p>
+            <a:pPr algn="l">
+              <a:spcBef>
+                <a:spcPts val="0"/>
+              </a:spcBef>
+              <a:spcAft>
+                <a:spcPts val="0"/>
+              </a:spcAft>
+              <a:buNone/>
+            </a:pPr>
+            <a:r>
+              <a:rPr sz="2100" b="0" i="0">
+                <a:solidFill>
+                  <a:srgbClr val="757575"/>
+                </a:solidFill>
+                <a:latin typeface="NVIDIA Sans"/>
+              </a:rPr>
+              <a:t>port line rate converted to bytes</a:t>
+            </a:r>
+          </a:p>
+        </p:txBody>
+      </p:sp>
+      <p:sp>
+        <p:nvSpPr>
+          <p:cNvPr id="27" name="TextBox 26"/>
+          <p:cNvSpPr txBox="1"/>
+          <p:nvPr/>
+        </p:nvSpPr>
+        <p:spPr>
+          <a:xfrm>
+            <a:off x="22539960" y="10844784"/>
+            <a:ext cx="4526280" cy="658368"/>
+          </a:xfrm>
+          <a:prstGeom prst="rect">
+            <a:avLst/>
+          </a:prstGeom>
+          <a:noFill/>
+        </p:spPr>
+        <p:txBody>
+          <a:bodyPr wrap="square" anchor="t" lIns="0" rIns="0" tIns="0" bIns="0">
+            <a:spAutoFit/>
+          </a:bodyPr>
+          <a:lstStyle/>
+          <a:p>
+            <a:pPr algn="l">
+              <a:spcBef>
+                <a:spcPts val="0"/>
+              </a:spcBef>
+              <a:spcAft>
+                <a:spcPts val="0"/>
+              </a:spcAft>
+              <a:buNone/>
+            </a:pPr>
+            <a:r>
+              <a:rPr sz="4100" b="1" i="0">
+                <a:solidFill>
+                  <a:srgbClr val="76B900"/>
+                </a:solidFill>
+                <a:latin typeface="NVIDIA Sans Medium"/>
+              </a:rPr>
+              <a:t>1,344 GB/s</a:t>
+            </a:r>
+          </a:p>
+        </p:txBody>
+      </p:sp>
+      <p:sp>
+        <p:nvSpPr>
+          <p:cNvPr id="28" name="TextBox 27"/>
+          <p:cNvSpPr txBox="1"/>
+          <p:nvPr/>
+        </p:nvSpPr>
+        <p:spPr>
+          <a:xfrm>
+            <a:off x="27020520" y="10872216"/>
+            <a:ext cx="914400" cy="594360"/>
           </a:xfrm>
           <a:prstGeom prst="rect">
             <a:avLst/>
@@ -38181,15 +36404,81 @@
               <a:buNone/>
             </a:pPr>
             <a:r>
-              <a:rPr sz="2400" b="1" i="0">
+              <a:rPr sz="3400" b="1" i="0">
                 <a:solidFill>
-                  <a:srgbClr val="952FC6"/>
+                  <a:srgbClr val="757575"/>
                 </a:solidFill>
                 <a:latin typeface="NVIDIA Sans Medium"/>
               </a:rPr>
-              <a:t>LOCAL</a:t>
-            </a:r>
-          </a:p>
+              <a:t>÷</a:t>
+            </a:r>
+          </a:p>
+        </p:txBody>
+      </p:sp>
+      <p:sp>
+        <p:nvSpPr>
+          <p:cNvPr id="29" name="TextBox 28"/>
+          <p:cNvSpPr txBox="1"/>
+          <p:nvPr/>
+        </p:nvSpPr>
+        <p:spPr>
+          <a:xfrm>
+            <a:off x="27980640" y="10844784"/>
+            <a:ext cx="3429000" cy="658368"/>
+          </a:xfrm>
+          <a:prstGeom prst="rect">
+            <a:avLst/>
+          </a:prstGeom>
+          <a:noFill/>
+        </p:spPr>
+        <p:txBody>
+          <a:bodyPr wrap="square" anchor="t" lIns="0" rIns="0" tIns="0" bIns="0">
+            <a:spAutoFit/>
+          </a:bodyPr>
+          <a:lstStyle/>
+          <a:p>
+            <a:pPr algn="l">
+              <a:spcBef>
+                <a:spcPts val="0"/>
+              </a:spcBef>
+              <a:spcAft>
+                <a:spcPts val="0"/>
+              </a:spcAft>
+              <a:buNone/>
+            </a:pPr>
+            <a:r>
+              <a:rPr sz="4100" b="1" i="0">
+                <a:solidFill>
+                  <a:srgbClr val="0074DF"/>
+                </a:solidFill>
+                <a:latin typeface="NVIDIA Sans Medium"/>
+              </a:rPr>
+              <a:t>50 GB/s</a:t>
+            </a:r>
+          </a:p>
+        </p:txBody>
+      </p:sp>
+      <p:sp>
+        <p:nvSpPr>
+          <p:cNvPr id="30" name="TextBox 29"/>
+          <p:cNvSpPr txBox="1"/>
+          <p:nvPr/>
+        </p:nvSpPr>
+        <p:spPr>
+          <a:xfrm>
+            <a:off x="31409640" y="10872216"/>
+            <a:ext cx="731520" cy="594360"/>
+          </a:xfrm>
+          <a:prstGeom prst="rect">
+            <a:avLst/>
+          </a:prstGeom>
+          <a:noFill/>
+        </p:spPr>
+        <p:txBody>
+          <a:bodyPr wrap="square" anchor="t" lIns="0" rIns="0" tIns="0" bIns="0">
+            <a:spAutoFit/>
+          </a:bodyPr>
+          <a:lstStyle/>
           <a:p>
             <a:pPr algn="ctr">
               <a:spcBef>
@@ -38201,70 +36490,27 @@
               <a:buNone/>
             </a:pPr>
             <a:r>
-              <a:rPr sz="2400" b="1" i="0">
+              <a:rPr sz="3400" b="1" i="0">
                 <a:solidFill>
-                  <a:srgbClr val="952FC6"/>
+                  <a:srgbClr val="757575"/>
                 </a:solidFill>
                 <a:latin typeface="NVIDIA Sans Medium"/>
               </a:rPr>
-              <a:t>KERNELS</a:t>
-            </a:r>
-          </a:p>
-        </p:txBody>
-      </p:sp>
-      <p:sp>
-        <p:nvSpPr>
-          <p:cNvPr id="45" name="Oval 44"/>
-          <p:cNvSpPr/>
-          <p:nvPr/>
-        </p:nvSpPr>
-        <p:spPr>
-          <a:xfrm>
-            <a:off x="23436072" y="11960352"/>
-            <a:ext cx="402336" cy="402336"/>
-          </a:xfrm>
-          <a:prstGeom prst="ellipse">
-            <a:avLst/>
-          </a:prstGeom>
-          <a:solidFill>
-            <a:srgbClr val="1DBBA4"/>
-          </a:solidFill>
-          <a:ln>
-            <a:noFill/>
-          </a:ln>
-        </p:spPr>
-        <p:style>
-          <a:lnRef idx="1">
-            <a:schemeClr val="accent1"/>
-          </a:lnRef>
-          <a:fillRef idx="3">
-            <a:schemeClr val="accent1"/>
-          </a:fillRef>
-          <a:effectRef idx="2">
-            <a:schemeClr val="accent1"/>
-          </a:effectRef>
-          <a:fontRef idx="minor">
-            <a:schemeClr val="lt1"/>
-          </a:fontRef>
-        </p:style>
-        <p:txBody>
-          <a:bodyPr rtlCol="0" anchor="ctr"/>
-          <a:lstStyle/>
-          <a:p>
-            <a:pPr algn="ctr"/>
-          </a:p>
-        </p:txBody>
-      </p:sp>
-      <p:sp>
-        <p:nvSpPr>
-          <p:cNvPr id="46" name="TextBox 45"/>
+              <a:t>=</a:t>
+            </a:r>
+          </a:p>
+        </p:txBody>
+      </p:sp>
+      <p:sp>
+        <p:nvSpPr>
+          <p:cNvPr id="31" name="TextBox 30"/>
           <p:cNvSpPr txBox="1"/>
           <p:nvPr/>
         </p:nvSpPr>
         <p:spPr>
           <a:xfrm>
-            <a:off x="21625560" y="12573000"/>
-            <a:ext cx="4023360" cy="868680"/>
+            <a:off x="32186880" y="10844784"/>
+            <a:ext cx="2331720" cy="658368"/>
           </a:xfrm>
           <a:prstGeom prst="rect">
             <a:avLst/>
@@ -38277,7 +36523,7 @@
           </a:bodyPr>
           <a:lstStyle/>
           <a:p>
-            <a:pPr algn="ctr">
+            <a:pPr algn="r">
               <a:spcBef>
                 <a:spcPts val="0"/>
               </a:spcBef>
@@ -38287,196 +36533,27 @@
               <a:buNone/>
             </a:pPr>
             <a:r>
-              <a:rPr sz="2400" b="1" i="0">
+              <a:rPr sz="4100" b="1" i="0">
                 <a:solidFill>
-                  <a:srgbClr val="1DBBA4"/>
+                  <a:srgbClr val="313131"/>
                 </a:solidFill>
                 <a:latin typeface="NVIDIA Sans Medium"/>
               </a:rPr>
-              <a:t>VSA FINE</a:t>
-            </a:r>
-          </a:p>
-          <a:p>
-            <a:pPr algn="ctr">
-              <a:spcBef>
-                <a:spcPts val="0"/>
-              </a:spcBef>
-              <a:spcAft>
-                <a:spcPts val="0"/>
-              </a:spcAft>
-              <a:buNone/>
-            </a:pPr>
-            <a:r>
-              <a:rPr sz="2400" b="1" i="0">
-                <a:solidFill>
-                  <a:srgbClr val="1DBBA4"/>
-                </a:solidFill>
-                <a:latin typeface="NVIDIA Sans Medium"/>
-              </a:rPr>
-              <a:t>COMPUTE</a:t>
-            </a:r>
-          </a:p>
-        </p:txBody>
-      </p:sp>
-      <p:sp>
-        <p:nvSpPr>
-          <p:cNvPr id="47" name="Oval 46"/>
-          <p:cNvSpPr/>
-          <p:nvPr/>
-        </p:nvSpPr>
-        <p:spPr>
-          <a:xfrm>
-            <a:off x="31437072" y="11960352"/>
-            <a:ext cx="402336" cy="402336"/>
-          </a:xfrm>
-          <a:prstGeom prst="ellipse">
-            <a:avLst/>
-          </a:prstGeom>
-          <a:solidFill>
-            <a:srgbClr val="0074DF"/>
-          </a:solidFill>
-          <a:ln>
-            <a:noFill/>
-          </a:ln>
-        </p:spPr>
-        <p:style>
-          <a:lnRef idx="1">
-            <a:schemeClr val="accent1"/>
-          </a:lnRef>
-          <a:fillRef idx="3">
-            <a:schemeClr val="accent1"/>
-          </a:fillRef>
-          <a:effectRef idx="2">
-            <a:schemeClr val="accent1"/>
-          </a:effectRef>
-          <a:fontRef idx="minor">
-            <a:schemeClr val="lt1"/>
-          </a:fontRef>
-        </p:style>
-        <p:txBody>
-          <a:bodyPr rtlCol="0" anchor="ctr"/>
-          <a:lstStyle/>
-          <a:p>
-            <a:pPr algn="ctr"/>
-          </a:p>
-        </p:txBody>
-      </p:sp>
-      <p:sp>
-        <p:nvSpPr>
-          <p:cNvPr id="48" name="TextBox 47"/>
-          <p:cNvSpPr txBox="1"/>
-          <p:nvPr/>
-        </p:nvSpPr>
-        <p:spPr>
-          <a:xfrm>
-            <a:off x="29626560" y="12573000"/>
-            <a:ext cx="4023360" cy="868680"/>
-          </a:xfrm>
-          <a:prstGeom prst="rect">
-            <a:avLst/>
-          </a:prstGeom>
-          <a:noFill/>
-        </p:spPr>
-        <p:txBody>
-          <a:bodyPr wrap="square" anchor="t" lIns="0" rIns="0" tIns="0" bIns="0">
-            <a:spAutoFit/>
-          </a:bodyPr>
-          <a:lstStyle/>
-          <a:p>
-            <a:pPr algn="ctr">
-              <a:spcBef>
-                <a:spcPts val="0"/>
-              </a:spcBef>
-              <a:spcAft>
-                <a:spcPts val="0"/>
-              </a:spcAft>
-              <a:buNone/>
-            </a:pPr>
-            <a:r>
-              <a:rPr sz="2400" b="1" i="0">
-                <a:solidFill>
-                  <a:srgbClr val="0074DF"/>
-                </a:solidFill>
-                <a:latin typeface="NVIDIA Sans Medium"/>
-              </a:rPr>
-              <a:t>H3 BASELINE</a:t>
-            </a:r>
-          </a:p>
-          <a:p>
-            <a:pPr algn="ctr">
-              <a:spcBef>
-                <a:spcPts val="0"/>
-              </a:spcBef>
-              <a:spcAft>
-                <a:spcPts val="0"/>
-              </a:spcAft>
-              <a:buNone/>
-            </a:pPr>
-            <a:r>
-              <a:rPr sz="2400" b="1" i="0">
-                <a:solidFill>
-                  <a:srgbClr val="0074DF"/>
-                </a:solidFill>
-                <a:latin typeface="NVIDIA Sans Medium"/>
-              </a:rPr>
-              <a:t>ULYSSES SP8</a:t>
-            </a:r>
-          </a:p>
-        </p:txBody>
-      </p:sp>
-      <p:sp>
-        <p:nvSpPr>
-          <p:cNvPr id="49" name="TextBox 48"/>
-          <p:cNvSpPr txBox="1"/>
-          <p:nvPr/>
-        </p:nvSpPr>
-        <p:spPr>
-          <a:xfrm>
-            <a:off x="14721840" y="13716000"/>
-            <a:ext cx="19202400" cy="411480"/>
-          </a:xfrm>
-          <a:prstGeom prst="rect">
-            <a:avLst/>
-          </a:prstGeom>
-          <a:noFill/>
-        </p:spPr>
-        <p:txBody>
-          <a:bodyPr wrap="square" anchor="t" lIns="0" rIns="0" tIns="0" bIns="0">
-            <a:spAutoFit/>
-          </a:bodyPr>
-          <a:lstStyle/>
-          <a:p>
-            <a:pPr algn="ctr">
-              <a:spcBef>
-                <a:spcPts val="0"/>
-              </a:spcBef>
-              <a:spcAft>
-                <a:spcPts val="0"/>
-              </a:spcAft>
-              <a:buNone/>
-            </a:pPr>
-            <a:r>
-              <a:rPr sz="2400" b="0" i="0">
-                <a:solidFill>
-                  <a:srgbClr val="757575"/>
-                </a:solidFill>
-                <a:latin typeface="NVIDIA Sans"/>
-              </a:rPr>
-              <a:t>increasing remote bytes + synchronization frequency</a:t>
+              <a:t>26.9×</a:t>
             </a:r>
           </a:p>
         </p:txBody>
       </p:sp>
       <p:cxnSp>
         <p:nvCxnSpPr>
-          <p:cNvPr id="50" name="Connector 49"/>
+          <p:cNvPr id="32" name="Connector 31"/>
           <p:cNvCxnSpPr/>
           <p:nvPr/>
         </p:nvCxnSpPr>
         <p:spPr>
           <a:xfrm>
-            <a:off x="14493240" y="14676120"/>
-            <a:ext cx="19842480" cy="0"/>
+            <a:off x="22539960" y="11814048"/>
+            <a:ext cx="11978640" cy="0"/>
           </a:xfrm>
           <a:prstGeom prst="line">
             <a:avLst/>
@@ -38504,14 +36581,14 @@
       </p:cxnSp>
       <p:sp>
         <p:nvSpPr>
-          <p:cNvPr id="51" name="TextBox 50"/>
+          <p:cNvPr id="33" name="TextBox 32"/>
           <p:cNvSpPr txBox="1"/>
           <p:nvPr/>
         </p:nvSpPr>
         <p:spPr>
           <a:xfrm>
-            <a:off x="14493240" y="15288767"/>
-            <a:ext cx="4709160" cy="566928"/>
+            <a:off x="22539960" y="12435840"/>
+            <a:ext cx="11978640" cy="3063240"/>
           </a:xfrm>
           <a:prstGeom prst="rect">
             <a:avLst/>
@@ -38534,27 +36611,27 @@
               <a:buNone/>
             </a:pPr>
             <a:r>
-              <a:rPr sz="3800" b="1" i="0">
+              <a:rPr sz="3000" b="1" i="0">
                 <a:solidFill>
-                  <a:srgbClr val="76B900"/>
+                  <a:srgbClr val="313131"/>
                 </a:solidFill>
                 <a:latin typeface="NVIDIA Sans Medium"/>
               </a:rPr>
-              <a:t>1,344 GB/s</a:t>
-            </a:r>
-          </a:p>
-        </p:txBody>
-      </p:sp>
-      <p:sp>
-        <p:nvSpPr>
-          <p:cNvPr id="52" name="TextBox 51"/>
+              <a:t>The nominal local-memory rate is 26.9× one 400 Gb/s port’s line rate; effective payload bandwidth and exposed communication therefore set the remaining scale-out headroom.</a:t>
+            </a:r>
+          </a:p>
+        </p:txBody>
+      </p:sp>
+      <p:sp>
+        <p:nvSpPr>
+          <p:cNvPr id="34" name="TextBox 33"/>
           <p:cNvSpPr txBox="1"/>
           <p:nvPr/>
         </p:nvSpPr>
         <p:spPr>
           <a:xfrm>
-            <a:off x="14493240" y="15910559"/>
-            <a:ext cx="4709160" cy="393192"/>
+            <a:off x="22539960" y="16504920"/>
+            <a:ext cx="11978640" cy="685800"/>
           </a:xfrm>
           <a:prstGeom prst="rect">
             <a:avLst/>
@@ -38577,228 +36654,13 @@
               <a:buNone/>
             </a:pPr>
             <a:r>
-              <a:rPr sz="2400" b="0" i="0">
+              <a:rPr sz="2200" b="0" i="0">
                 <a:solidFill>
                   <a:srgbClr val="757575"/>
                 </a:solidFill>
                 <a:latin typeface="NVIDIA Sans"/>
               </a:rPr>
-              <a:t>local GDDR7</a:t>
-            </a:r>
-          </a:p>
-        </p:txBody>
-      </p:sp>
-      <p:sp>
-        <p:nvSpPr>
-          <p:cNvPr id="53" name="TextBox 52"/>
-          <p:cNvSpPr txBox="1"/>
-          <p:nvPr/>
-        </p:nvSpPr>
-        <p:spPr>
-          <a:xfrm>
-            <a:off x="19431000" y="15316200"/>
-            <a:ext cx="1234440" cy="502920"/>
-          </a:xfrm>
-          <a:prstGeom prst="rect">
-            <a:avLst/>
-          </a:prstGeom>
-          <a:noFill/>
-        </p:spPr>
-        <p:txBody>
-          <a:bodyPr wrap="square" anchor="t" lIns="0" rIns="0" tIns="0" bIns="0">
-            <a:spAutoFit/>
-          </a:bodyPr>
-          <a:lstStyle/>
-          <a:p>
-            <a:pPr algn="ctr">
-              <a:spcBef>
-                <a:spcPts val="0"/>
-              </a:spcBef>
-              <a:spcAft>
-                <a:spcPts val="0"/>
-              </a:spcAft>
-              <a:buNone/>
-            </a:pPr>
-            <a:r>
-              <a:rPr sz="2800" b="1" i="0">
-                <a:solidFill>
-                  <a:srgbClr val="757575"/>
-                </a:solidFill>
-                <a:latin typeface="NVIDIA Sans Medium"/>
-              </a:rPr>
-              <a:t>vs</a:t>
-            </a:r>
-          </a:p>
-        </p:txBody>
-      </p:sp>
-      <p:sp>
-        <p:nvSpPr>
-          <p:cNvPr id="54" name="TextBox 53"/>
-          <p:cNvSpPr txBox="1"/>
-          <p:nvPr/>
-        </p:nvSpPr>
-        <p:spPr>
-          <a:xfrm>
-            <a:off x="20848320" y="15288767"/>
-            <a:ext cx="4251960" cy="566928"/>
-          </a:xfrm>
-          <a:prstGeom prst="rect">
-            <a:avLst/>
-          </a:prstGeom>
-          <a:noFill/>
-        </p:spPr>
-        <p:txBody>
-          <a:bodyPr wrap="square" anchor="t" lIns="0" rIns="0" tIns="0" bIns="0">
-            <a:spAutoFit/>
-          </a:bodyPr>
-          <a:lstStyle/>
-          <a:p>
-            <a:pPr algn="l">
-              <a:spcBef>
-                <a:spcPts val="0"/>
-              </a:spcBef>
-              <a:spcAft>
-                <a:spcPts val="0"/>
-              </a:spcAft>
-              <a:buNone/>
-            </a:pPr>
-            <a:r>
-              <a:rPr sz="3800" b="1" i="0">
-                <a:solidFill>
-                  <a:srgbClr val="0074DF"/>
-                </a:solidFill>
-                <a:latin typeface="NVIDIA Sans Medium"/>
-              </a:rPr>
-              <a:t>50 GB/s</a:t>
-            </a:r>
-          </a:p>
-        </p:txBody>
-      </p:sp>
-      <p:sp>
-        <p:nvSpPr>
-          <p:cNvPr id="55" name="TextBox 54"/>
-          <p:cNvSpPr txBox="1"/>
-          <p:nvPr/>
-        </p:nvSpPr>
-        <p:spPr>
-          <a:xfrm>
-            <a:off x="20848320" y="15910559"/>
-            <a:ext cx="5669280" cy="393192"/>
-          </a:xfrm>
-          <a:prstGeom prst="rect">
-            <a:avLst/>
-          </a:prstGeom>
-          <a:noFill/>
-        </p:spPr>
-        <p:txBody>
-          <a:bodyPr wrap="square" anchor="t" lIns="0" rIns="0" tIns="0" bIns="0">
-            <a:spAutoFit/>
-          </a:bodyPr>
-          <a:lstStyle/>
-          <a:p>
-            <a:pPr algn="l">
-              <a:spcBef>
-                <a:spcPts val="0"/>
-              </a:spcBef>
-              <a:spcAft>
-                <a:spcPts val="0"/>
-              </a:spcAft>
-              <a:buNone/>
-            </a:pPr>
-            <a:r>
-              <a:rPr sz="2400" b="0" i="0">
-                <a:solidFill>
-                  <a:srgbClr val="757575"/>
-                </a:solidFill>
-                <a:latin typeface="NVIDIA Sans"/>
-              </a:rPr>
-              <a:t>nominal 400 Gb/s port</a:t>
-            </a:r>
-          </a:p>
-        </p:txBody>
-      </p:sp>
-      <p:sp>
-        <p:nvSpPr>
-          <p:cNvPr id="56" name="TextBox 55"/>
-          <p:cNvSpPr txBox="1"/>
-          <p:nvPr/>
-        </p:nvSpPr>
-        <p:spPr>
-          <a:xfrm>
-            <a:off x="26837640" y="15343632"/>
-            <a:ext cx="7498079" cy="502920"/>
-          </a:xfrm>
-          <a:prstGeom prst="rect">
-            <a:avLst/>
-          </a:prstGeom>
-          <a:noFill/>
-        </p:spPr>
-        <p:txBody>
-          <a:bodyPr wrap="square" anchor="t" lIns="0" rIns="0" tIns="0" bIns="0">
-            <a:spAutoFit/>
-          </a:bodyPr>
-          <a:lstStyle/>
-          <a:p>
-            <a:pPr algn="r">
-              <a:spcBef>
-                <a:spcPts val="0"/>
-              </a:spcBef>
-              <a:spcAft>
-                <a:spcPts val="0"/>
-              </a:spcAft>
-              <a:buNone/>
-            </a:pPr>
-            <a:r>
-              <a:rPr sz="3000" b="1" i="0">
-                <a:solidFill>
-                  <a:srgbClr val="313131"/>
-                </a:solidFill>
-                <a:latin typeface="NVIDIA Sans Medium"/>
-              </a:rPr>
-              <a:t>26.9× raw-rate ratio*</a:t>
-            </a:r>
-          </a:p>
-        </p:txBody>
-      </p:sp>
-      <p:sp>
-        <p:nvSpPr>
-          <p:cNvPr id="57" name="TextBox 56"/>
-          <p:cNvSpPr txBox="1"/>
-          <p:nvPr/>
-        </p:nvSpPr>
-        <p:spPr>
-          <a:xfrm>
-            <a:off x="14493240" y="16843248"/>
-            <a:ext cx="19842480" cy="530352"/>
-          </a:xfrm>
-          <a:prstGeom prst="rect">
-            <a:avLst/>
-          </a:prstGeom>
-          <a:noFill/>
-        </p:spPr>
-        <p:txBody>
-          <a:bodyPr wrap="square" anchor="t" lIns="0" rIns="0" tIns="0" bIns="0">
-            <a:spAutoFit/>
-          </a:bodyPr>
-          <a:lstStyle/>
-          <a:p>
-            <a:pPr algn="r">
-              <a:spcBef>
-                <a:spcPts val="0"/>
-              </a:spcBef>
-              <a:spcAft>
-                <a:spcPts val="0"/>
-              </a:spcAft>
-              <a:buNone/>
-            </a:pPr>
-            <a:r>
-              <a:rPr sz="2100" b="0" i="0">
-                <a:solidFill>
-                  <a:srgbClr val="757575"/>
-                </a:solidFill>
-                <a:latin typeface="NVIDIA Sans"/>
-              </a:rPr>
-              <a:t>8 active 400 Gb/s ports · *local memory bandwidth ÷ nominal NIC line rate; not end-to-end payload throughput</a:t>
+              <a:t>*Raw-rate comparison; excludes protocol overhead, topology, contention, and overlap</a:t>
             </a:r>
           </a:p>
         </p:txBody>

</xml_diff>

<commit_message>
Add real-time video generation motivation slide
</commit_message>
<xml_diff>
--- a/pro5000-4gpu/slides/MiniMax_H3_Real_Time_Inference_NVIDIA_Public_v1.0.pptx
+++ b/pro5000-4gpu/slides/MiniMax_H3_Real_Time_Inference_NVIDIA_Public_v1.0.pptx
@@ -14,6 +14,7 @@
     <p:sldId id="340" r:id="rId82"/>
     <p:sldId id="341" r:id="rId83"/>
     <p:sldId id="342" r:id="rId84"/>
+    <p:sldId id="343" r:id="rId85"/>
   </p:sldIdLst>
   <p:sldSz cx="36576000" cy="20574000"/>
   <p:notesSz cx="6858000" cy="9144000"/>
@@ -487,6 +488,64 @@
 </p:notesMaster>
 </file>
 
+<file path=ppt/notesSlides/notesSlide10.xml><?xml version="1.0" encoding="utf-8"?>
+<p:notes xmlns:a="http://schemas.openxmlformats.org/drawingml/2006/main" xmlns:p="http://schemas.openxmlformats.org/presentationml/2006/main" xmlns:r="http://schemas.openxmlformats.org/officeDocument/2006/relationships">
+  <p:cSld>
+    <p:spTree>
+      <p:nvGrpSpPr>
+        <p:cNvPr id="1" name=""/>
+        <p:cNvGrpSpPr/>
+        <p:nvPr/>
+      </p:nvGrpSpPr>
+      <p:grpSpPr>
+        <a:xfrm>
+          <a:off x="0" y="0"/>
+          <a:ext cx="0" cy="0"/>
+          <a:chOff x="0" y="0"/>
+          <a:chExt cx="0" cy="0"/>
+        </a:xfrm>
+      </p:grpSpPr>
+      <p:sp>
+        <p:nvSpPr>
+          <p:cNvPr id="2" name="Slide Image Placeholder 1"/>
+          <p:cNvSpPr>
+            <a:spLocks noGrp="1"/>
+          </p:cNvSpPr>
+          <p:nvPr>
+            <p:ph type="sldImg" idx="2"/>
+          </p:nvPr>
+        </p:nvSpPr>
+        <p:spPr/>
+      </p:sp>
+      <p:sp>
+        <p:nvSpPr>
+          <p:cNvPr id="3" name="Notes Placeholder 2"/>
+          <p:cNvSpPr>
+            <a:spLocks noGrp="1"/>
+          </p:cNvSpPr>
+          <p:nvPr>
+            <p:ph type="body" idx="3" sz="quarter"/>
+          </p:nvPr>
+        </p:nvSpPr>
+        <p:spPr/>
+        <p:txBody>
+          <a:bodyPr/>
+          <a:lstStyle/>
+          <a:p>
+            <a:r>
+              <a:t>The template's native Table Example is reused directly. NVIDIA publicly specifies 300 W TBP for RTX PRO 5000; the local eight-GPU system reports a 350 W configured/enforced power limit, so both values are labeled rather than conflated. SwPowerCap is reported as the share of valid NVML samples, not exact time under cap.</a:t>
+            </a:r>
+          </a:p>
+        </p:txBody>
+      </p:sp>
+    </p:spTree>
+  </p:cSld>
+  <p:clrMapOvr>
+    <a:masterClrMapping/>
+  </p:clrMapOvr>
+</p:notes>
+</file>
+
 <file path=ppt/notesSlides/notesSlide7.xml><?xml version="1.0" encoding="utf-8"?>
 <p:notes xmlns:a="http://schemas.openxmlformats.org/drawingml/2006/main" xmlns:p="http://schemas.openxmlformats.org/presentationml/2006/main" xmlns:r="http://schemas.openxmlformats.org/officeDocument/2006/relationships">
   <p:cSld>
@@ -590,7 +649,7 @@
           <a:lstStyle/>
           <a:p>
             <a:r>
-              <a:t>This slide uses the template's standard 2-up Image 16:9 layout. Both visuals are copied directly from public vLLM-Omni materials: the official architecture figure and the PR #9194 ComfyUI workflow screenshot.</a:t>
+              <a:t>Motivation and challenge for real-time video generation. The public MiniMax H3 system overview is retained as the primary visual. The 60K–1M range and 8-step × 50-block path describe the evaluated workload, not every possible MiniMax H3 request. Reference equivalence is the optimization requirement; full eight-GPU model validation remains to be rerun.</a:t>
             </a:r>
           </a:p>
         </p:txBody>
@@ -648,7 +707,7 @@
           <a:lstStyle/>
           <a:p>
             <a:r>
-              <a:t>The template's native Table Example is reused directly. NVIDIA publicly specifies 300 W TBP for RTX PRO 5000; the local eight-GPU system reports a 350 W configured/enforced power limit, so both values are labeled rather than conflated. SwPowerCap is reported as the share of valid NVML samples, not exact time under cap.</a:t>
+              <a:t>This slide uses the template's standard 2-up Image 16:9 layout. Both visuals are copied directly from public vLLM-Omni materials: the official architecture figure and the PR #9194 ComfyUI workflow screenshot.</a:t>
             </a:r>
           </a:p>
         </p:txBody>
@@ -34273,13 +34332,13 @@
               <a:buNone/>
             </a:pPr>
             <a:r>
-              <a:rPr sz="3600" b="0" i="0">
+              <a:rPr sz="3200" b="0" i="0">
                 <a:solidFill>
                   <a:srgbClr val="757575"/>
                 </a:solidFill>
                 <a:latin typeface="NVIDIA Sans"/>
               </a:rPr>
-              <a:t>ComfyUI remains the authoring surface; vLLM-Omni owns serving, stage placement, batching, and multi-GPU execution</a:t>
+              <a:t>For each request, end-to-end latency must stay within the generated clip’s playback window while the evaluated 60K–1M-token workload reshapes memory, kernels, communication volume, and graph reuse.</a:t>
             </a:r>
           </a:p>
         </p:txBody>
@@ -34309,13 +34368,13 @@
               <a:buNone/>
             </a:pPr>
             <a:r>
-              <a:rPr sz="6600" b="1" i="0">
+              <a:rPr sz="6800" b="1" i="0">
                 <a:solidFill>
                   <a:srgbClr val="000000"/>
                 </a:solidFill>
                 <a:latin typeface="NVIDIA Sans Medium"/>
               </a:rPr>
-              <a:t>vLLM-Omni Connects Visual Workflows to Multi-GPU Serving</a:t>
+              <a:t>Real-Time Video Generation Is a Distributed-Systems Problem</a:t>
             </a:r>
           </a:p>
         </p:txBody>
@@ -34330,7 +34389,12 @@
             <p:ph type="body" idx="52" sz="quarter"/>
           </p:nvPr>
         </p:nvSpPr>
-        <p:spPr/>
+        <p:spPr>
+          <a:xfrm>
+            <a:off x="2377440" y="17300448"/>
+            <a:ext cx="31821119" cy="1261872"/>
+          </a:xfrm>
+        </p:spPr>
         <p:txBody>
           <a:bodyPr wrap="square" anchor="t"/>
           <a:lstStyle/>
@@ -34345,13 +34409,13 @@
               <a:buNone/>
             </a:pPr>
             <a:r>
-              <a:rPr sz="2500" b="0" i="0">
+              <a:rPr sz="2700" b="0" i="0">
                 <a:solidFill>
                   <a:srgbClr val="313131"/>
                 </a:solidFill>
                 <a:latin typeface="NVIDIA Sans"/>
               </a:rPr>
-              <a:t>One serving layer spans omni-modal inputs, autoregressive reasoning, and DiT generation.</a:t>
+              <a:t>Across SP8, the evaluated path repeatedly couples compute with Q/K/V and Gate/O exchange; launch gaps, transport fences, rank imbalance, and the decoder tail accumulate on the critical path, while the optimized system must preserve the reference output contract.</a:t>
             </a:r>
           </a:p>
         </p:txBody>
@@ -34366,9 +34430,14 @@
             <p:ph type="body" idx="51" sz="quarter"/>
           </p:nvPr>
         </p:nvSpPr>
-        <p:spPr/>
-        <p:txBody>
-          <a:bodyPr wrap="square" anchor="t"/>
+        <p:spPr>
+          <a:xfrm>
+            <a:off x="2377440" y="16687800"/>
+            <a:ext cx="31821119" cy="512064"/>
+          </a:xfrm>
+        </p:spPr>
+        <p:txBody>
+          <a:bodyPr wrap="square" anchor="ctr"/>
           <a:lstStyle/>
           <a:p>
             <a:pPr algn="l">
@@ -34381,30 +34450,80 @@
               <a:buNone/>
             </a:pPr>
             <a:r>
-              <a:rPr sz="2700" b="1" i="0">
+              <a:rPr sz="2600" b="1" i="0">
                 <a:solidFill>
                   <a:srgbClr val="76B900"/>
                 </a:solidFill>
                 <a:latin typeface="NVIDIA Sans Medium"/>
               </a:rPr>
-              <a:t>OFFICIAL vLLM-OMNI ARCHITECTURE</a:t>
-            </a:r>
-          </a:p>
-        </p:txBody>
-      </p:sp>
-      <p:sp>
-        <p:nvSpPr>
-          <p:cNvPr id="7" name="Text Placeholder 6"/>
-          <p:cNvSpPr>
-            <a:spLocks noGrp="1"/>
-          </p:cNvSpPr>
-          <p:nvPr>
-            <p:ph type="body" idx="54" sz="quarter"/>
-          </p:nvPr>
-        </p:nvSpPr>
-        <p:spPr/>
-        <p:txBody>
-          <a:bodyPr wrap="square" anchor="t"/>
+              <a:t>EVALUATED PATH · 8 DIT STEPS × 50 BLOCKS = 400 REPEATED BLOCK EXECUTIONS</a:t>
+            </a:r>
+          </a:p>
+        </p:txBody>
+      </p:sp>
+      <p:sp>
+        <p:nvSpPr>
+          <p:cNvPr id="7" name="TextBox 6"/>
+          <p:cNvSpPr txBox="1"/>
+          <p:nvPr/>
+        </p:nvSpPr>
+        <p:spPr>
+          <a:xfrm>
+            <a:off x="7543800" y="19431000"/>
+            <a:ext cx="21488400" cy="365760"/>
+          </a:xfrm>
+          <a:prstGeom prst="rect">
+            <a:avLst/>
+          </a:prstGeom>
+          <a:noFill/>
+        </p:spPr>
+        <p:txBody>
+          <a:bodyPr wrap="square" anchor="ctr">
+            <a:spAutoFit/>
+          </a:bodyPr>
+          <a:lstStyle/>
+          <a:p>
+            <a:pPr algn="ctr">
+              <a:spcBef>
+                <a:spcPts val="0"/>
+              </a:spcBef>
+              <a:spcAft>
+                <a:spcPts val="0"/>
+              </a:spcAft>
+              <a:buNone/>
+            </a:pPr>
+            <a:r>
+              <a:rPr sz="2000" b="0" i="0">
+                <a:solidFill>
+                  <a:srgbClr val="757575"/>
+                </a:solidFill>
+                <a:latin typeface="NVIDIA Sans"/>
+              </a:rPr>
+              <a:t>Sources: vLLM-Omni v0.26 public deck, slide 23 · author evaluated workload envelope and eight-GPU execution path</a:t>
+            </a:r>
+          </a:p>
+        </p:txBody>
+      </p:sp>
+      <p:sp>
+        <p:nvSpPr>
+          <p:cNvPr id="8" name="TextBox 7"/>
+          <p:cNvSpPr txBox="1"/>
+          <p:nvPr/>
+        </p:nvSpPr>
+        <p:spPr>
+          <a:xfrm>
+            <a:off x="914400" y="19431000"/>
+            <a:ext cx="640080" cy="365760"/>
+          </a:xfrm>
+          <a:prstGeom prst="rect">
+            <a:avLst/>
+          </a:prstGeom>
+          <a:noFill/>
+        </p:spPr>
+        <p:txBody>
+          <a:bodyPr wrap="square" anchor="ctr">
+            <a:spAutoFit/>
+          </a:bodyPr>
           <a:lstStyle/>
           <a:p>
             <a:pPr algn="l">
@@ -34417,30 +34536,72 @@
               <a:buNone/>
             </a:pPr>
             <a:r>
-              <a:rPr sz="2500" b="0" i="0">
+              <a:rPr sz="2000" b="0" i="0">
                 <a:solidFill>
-                  <a:srgbClr val="313131"/>
+                  <a:srgbClr val="757575"/>
                 </a:solidFill>
                 <a:latin typeface="NVIDIA Sans"/>
               </a:rPr>
-              <a:t>MiniMax-H3 character replacement calls the vLLM-Omni Generate Video endpoint; PR #9194 remains open.</a:t>
-            </a:r>
-          </a:p>
-        </p:txBody>
-      </p:sp>
-      <p:sp>
-        <p:nvSpPr>
-          <p:cNvPr id="8" name="Text Placeholder 7"/>
+              <a:t>2</a:t>
+            </a:r>
+          </a:p>
+        </p:txBody>
+      </p:sp>
+      <p:pic>
+        <p:nvPicPr>
+          <p:cNvPr id="9" name="Picture 8" descr="minimax-h3-system-overview-official.jpeg"/>
+          <p:cNvPicPr>
+            <a:picLocks noChangeAspect="1"/>
+          </p:cNvPicPr>
+          <p:nvPr/>
+        </p:nvPicPr>
+        <p:blipFill>
+          <a:blip r:embed="rId3"/>
+          <a:stretch>
+            <a:fillRect/>
+          </a:stretch>
+        </p:blipFill>
+        <p:spPr>
+          <a:xfrm>
+            <a:off x="2393626" y="4709160"/>
+            <a:ext cx="31788747" cy="11750040"/>
+          </a:xfrm>
+          <a:prstGeom prst="rect">
+            <a:avLst/>
+          </a:prstGeom>
+        </p:spPr>
+      </p:pic>
+    </p:spTree>
+  </p:cSld>
+  <p:clrMapOvr>
+    <a:masterClrMapping/>
+  </p:clrMapOvr>
+</p:sld>
+</file>
+
+<file path=ppt/slides/slide61.xml><?xml version="1.0" encoding="utf-8"?>
+<p:sld xmlns:a="http://schemas.openxmlformats.org/drawingml/2006/main" xmlns:p="http://schemas.openxmlformats.org/presentationml/2006/main" xmlns:r="http://schemas.openxmlformats.org/officeDocument/2006/relationships">
+  <p:cSld>
+    <p:spTree>
+      <p:nvGrpSpPr>
+        <p:cNvPr id="1" name=""/>
+        <p:cNvGrpSpPr/>
+        <p:nvPr/>
+      </p:nvGrpSpPr>
+      <p:grpSpPr/>
+      <p:sp>
+        <p:nvSpPr>
+          <p:cNvPr id="2" name="Text Placeholder 1"/>
           <p:cNvSpPr>
             <a:spLocks noGrp="1"/>
           </p:cNvSpPr>
           <p:nvPr>
-            <p:ph type="body" idx="55" sz="quarter"/>
+            <p:ph type="body" idx="14" sz="quarter"/>
           </p:nvPr>
         </p:nvSpPr>
         <p:spPr/>
         <p:txBody>
-          <a:bodyPr wrap="square" anchor="t"/>
+          <a:bodyPr wrap="square" anchor="ctr"/>
           <a:lstStyle/>
           <a:p>
             <a:pPr algn="l">
@@ -34453,6 +34614,186 @@
               <a:buNone/>
             </a:pPr>
             <a:r>
+              <a:rPr sz="3600" b="0" i="0">
+                <a:solidFill>
+                  <a:srgbClr val="757575"/>
+                </a:solidFill>
+                <a:latin typeface="NVIDIA Sans"/>
+              </a:rPr>
+              <a:t>ComfyUI remains the authoring surface; vLLM-Omni owns serving, stage placement, batching, and multi-GPU execution</a:t>
+            </a:r>
+          </a:p>
+        </p:txBody>
+      </p:sp>
+      <p:sp>
+        <p:nvSpPr>
+          <p:cNvPr id="3" name="Title 2"/>
+          <p:cNvSpPr>
+            <a:spLocks noGrp="1"/>
+          </p:cNvSpPr>
+          <p:nvPr>
+            <p:ph type="title"/>
+          </p:nvPr>
+        </p:nvSpPr>
+        <p:spPr/>
+        <p:txBody>
+          <a:bodyPr wrap="square" anchor="ctr"/>
+          <a:lstStyle/>
+          <a:p>
+            <a:pPr algn="l">
+              <a:spcBef>
+                <a:spcPts val="0"/>
+              </a:spcBef>
+              <a:spcAft>
+                <a:spcPts val="0"/>
+              </a:spcAft>
+              <a:buNone/>
+            </a:pPr>
+            <a:r>
+              <a:rPr sz="6600" b="1" i="0">
+                <a:solidFill>
+                  <a:srgbClr val="000000"/>
+                </a:solidFill>
+                <a:latin typeface="NVIDIA Sans Medium"/>
+              </a:rPr>
+              <a:t>vLLM-Omni Connects Visual Workflows to Multi-GPU Serving</a:t>
+            </a:r>
+          </a:p>
+        </p:txBody>
+      </p:sp>
+      <p:sp>
+        <p:nvSpPr>
+          <p:cNvPr id="4" name="Text Placeholder 3"/>
+          <p:cNvSpPr>
+            <a:spLocks noGrp="1"/>
+          </p:cNvSpPr>
+          <p:nvPr>
+            <p:ph type="body" idx="52" sz="quarter"/>
+          </p:nvPr>
+        </p:nvSpPr>
+        <p:spPr/>
+        <p:txBody>
+          <a:bodyPr wrap="square" anchor="t"/>
+          <a:lstStyle/>
+          <a:p>
+            <a:pPr algn="l">
+              <a:spcBef>
+                <a:spcPts val="0"/>
+              </a:spcBef>
+              <a:spcAft>
+                <a:spcPts val="0"/>
+              </a:spcAft>
+              <a:buNone/>
+            </a:pPr>
+            <a:r>
+              <a:rPr sz="2500" b="0" i="0">
+                <a:solidFill>
+                  <a:srgbClr val="313131"/>
+                </a:solidFill>
+                <a:latin typeface="NVIDIA Sans"/>
+              </a:rPr>
+              <a:t>One serving layer spans omni-modal inputs, autoregressive reasoning, and DiT generation.</a:t>
+            </a:r>
+          </a:p>
+        </p:txBody>
+      </p:sp>
+      <p:sp>
+        <p:nvSpPr>
+          <p:cNvPr id="5" name="Text Placeholder 4"/>
+          <p:cNvSpPr>
+            <a:spLocks noGrp="1"/>
+          </p:cNvSpPr>
+          <p:nvPr>
+            <p:ph type="body" idx="51" sz="quarter"/>
+          </p:nvPr>
+        </p:nvSpPr>
+        <p:spPr/>
+        <p:txBody>
+          <a:bodyPr wrap="square" anchor="t"/>
+          <a:lstStyle/>
+          <a:p>
+            <a:pPr algn="l">
+              <a:spcBef>
+                <a:spcPts val="0"/>
+              </a:spcBef>
+              <a:spcAft>
+                <a:spcPts val="0"/>
+              </a:spcAft>
+              <a:buNone/>
+            </a:pPr>
+            <a:r>
+              <a:rPr sz="2700" b="1" i="0">
+                <a:solidFill>
+                  <a:srgbClr val="76B900"/>
+                </a:solidFill>
+                <a:latin typeface="NVIDIA Sans Medium"/>
+              </a:rPr>
+              <a:t>OFFICIAL vLLM-OMNI ARCHITECTURE</a:t>
+            </a:r>
+          </a:p>
+        </p:txBody>
+      </p:sp>
+      <p:sp>
+        <p:nvSpPr>
+          <p:cNvPr id="7" name="Text Placeholder 6"/>
+          <p:cNvSpPr>
+            <a:spLocks noGrp="1"/>
+          </p:cNvSpPr>
+          <p:nvPr>
+            <p:ph type="body" idx="54" sz="quarter"/>
+          </p:nvPr>
+        </p:nvSpPr>
+        <p:spPr/>
+        <p:txBody>
+          <a:bodyPr wrap="square" anchor="t"/>
+          <a:lstStyle/>
+          <a:p>
+            <a:pPr algn="l">
+              <a:spcBef>
+                <a:spcPts val="0"/>
+              </a:spcBef>
+              <a:spcAft>
+                <a:spcPts val="0"/>
+              </a:spcAft>
+              <a:buNone/>
+            </a:pPr>
+            <a:r>
+              <a:rPr sz="2500" b="0" i="0">
+                <a:solidFill>
+                  <a:srgbClr val="313131"/>
+                </a:solidFill>
+                <a:latin typeface="NVIDIA Sans"/>
+              </a:rPr>
+              <a:t>MiniMax-H3 character replacement calls the vLLM-Omni Generate Video endpoint; PR #9194 remains open.</a:t>
+            </a:r>
+          </a:p>
+        </p:txBody>
+      </p:sp>
+      <p:sp>
+        <p:nvSpPr>
+          <p:cNvPr id="8" name="Text Placeholder 7"/>
+          <p:cNvSpPr>
+            <a:spLocks noGrp="1"/>
+          </p:cNvSpPr>
+          <p:nvPr>
+            <p:ph type="body" idx="55" sz="quarter"/>
+          </p:nvPr>
+        </p:nvSpPr>
+        <p:spPr/>
+        <p:txBody>
+          <a:bodyPr wrap="square" anchor="t"/>
+          <a:lstStyle/>
+          <a:p>
+            <a:pPr algn="l">
+              <a:spcBef>
+                <a:spcPts val="0"/>
+              </a:spcBef>
+              <a:spcAft>
+                <a:spcPts val="0"/>
+              </a:spcAft>
+              <a:buNone/>
+            </a:pPr>
+            <a:r>
               <a:rPr sz="2700" b="1" i="0">
                 <a:solidFill>
                   <a:srgbClr val="0074DF"/>
@@ -34545,7 +34886,7 @@
                 </a:solidFill>
                 <a:latin typeface="NVIDIA Sans"/>
               </a:rPr>
-              <a:t>2</a:t>
+              <a:t>3</a:t>
             </a:r>
           </a:p>
         </p:txBody>
@@ -34606,7 +34947,7 @@
 </p:sld>
 </file>
 
-<file path=ppt/slides/slide61.xml><?xml version="1.0" encoding="utf-8"?>
+<file path=ppt/slides/slide62.xml><?xml version="1.0" encoding="utf-8"?>
 <p:sld xmlns:a="http://schemas.openxmlformats.org/drawingml/2006/main" xmlns:p="http://schemas.openxmlformats.org/presentationml/2006/main" xmlns:r="http://schemas.openxmlformats.org/officeDocument/2006/relationships">
   <p:cSld>
     <p:spTree>
@@ -37538,7 +37879,7 @@
                 </a:solidFill>
                 <a:latin typeface="NVIDIA Sans"/>
               </a:rPr>
-              <a:t>3</a:t>
+              <a:t>4</a:t>
             </a:r>
           </a:p>
         </p:txBody>

</xml_diff>

<commit_message>
Refine real-time workload framing
</commit_message>
<xml_diff>
--- a/pro5000-4gpu/slides/MiniMax_H3_Real_Time_Inference_NVIDIA_Public_v1.0.pptx
+++ b/pro5000-4gpu/slides/MiniMax_H3_Real_Time_Inference_NVIDIA_Public_v1.0.pptx
@@ -34338,7 +34338,7 @@
                 </a:solidFill>
                 <a:latin typeface="NVIDIA Sans"/>
               </a:rPr>
-              <a:t>For each request, end-to-end latency must stay within the generated clip’s playback window while the evaluated 60K–1M-token workload reshapes memory, kernels, communication volume, and graph reuse.</a:t>
+              <a:t>For each request, the real-time target is end-to-end latency within the clip’s playback window; across the evaluated 60K–1M-token range, shape changes alter memory demand, kernel geometry, communication volume, and CUDA Graph reuse.</a:t>
             </a:r>
           </a:p>
         </p:txBody>
@@ -34409,13 +34409,13 @@
               <a:buNone/>
             </a:pPr>
             <a:r>
-              <a:rPr sz="2700" b="0" i="0">
+              <a:rPr sz="2600" b="0" i="0">
                 <a:solidFill>
                   <a:srgbClr val="313131"/>
                 </a:solidFill>
                 <a:latin typeface="NVIDIA Sans"/>
               </a:rPr>
-              <a:t>Across SP8, the evaluated path repeatedly couples compute with Q/K/V and Gate/O exchange; launch gaps, transport fences, rank imbalance, and the decoder tail accumulate on the critical path, while the optimized system must preserve the reference output contract.</a:t>
+              <a:t>Under SP8, the evaluated path repeatedly couples compute with Q/K/V and Gate/O exchange; launch gaps, transport fences, rank skew, and the decoder tail accumulate on the critical path, while the optimized system must preserve numerical equivalence to the reference path under the defined tolerance.</a:t>
             </a:r>
           </a:p>
         </p:txBody>
@@ -34456,7 +34456,7 @@
                 </a:solidFill>
                 <a:latin typeface="NVIDIA Sans Medium"/>
               </a:rPr>
-              <a:t>EVALUATED PATH · 8 DIT STEPS × 50 BLOCKS = 400 REPEATED BLOCK EXECUTIONS</a:t>
+              <a:t>EVALUATED PATH · 8 DiT STEPS × 50 BLOCKS = 400 REPEATED BLOCK EXECUTIONS</a:t>
             </a:r>
           </a:p>
         </p:txBody>

</xml_diff>

<commit_message>
Reframe real-time 768p motivation and model scale
</commit_message>
<xml_diff>
--- a/pro5000-4gpu/slides/MiniMax_H3_Real_Time_Inference_NVIDIA_Public_v1.0.pptx
+++ b/pro5000-4gpu/slides/MiniMax_H3_Real_Time_Inference_NVIDIA_Public_v1.0.pptx
@@ -649,7 +649,7 @@
           <a:lstStyle/>
           <a:p>
             <a:r>
-              <a:t>Motivation and challenge for real-time video generation. The public MiniMax H3 system overview is retained as the primary visual. The 60K–1M range and 8-step × 50-block path describe the evaluated workload, not every possible MiniMax H3 request. Reference equivalence is the optimization requirement; full eight-GPU model validation remains to be rerun.</a:t>
+              <a:t>Real-time is defined as RTF = end-to-end generation latency divided by finished-media duration, with RTF &lt;= 1.0. The 15.08 s example is 362 frames at 24 FPS. Parameter bars compare published video-generation transformer sizes, not full serving stacks or measured FLOPs. H3 is 33B dense with about 13B in AdaLN branches whose outputs can be precomputed and cached for inference-only deployment. Wan2.2 A14B is 27B total and 14B active per denoising step. LTX-2.5 uses its official 22B checkpoint designation. Sources: https://huggingface.co/MiniMaxAI/MiniMax-H3 ; https://huggingface.co/Lightricks/LTX-2.5 ; https://github.com/Wan-Video/Wan2.2 ; https://github.com/Tencent-Hunyuan/HunyuanVideo</a:t>
             </a:r>
           </a:p>
         </p:txBody>
@@ -34309,7 +34309,7 @@
       <p:grpSpPr/>
       <p:sp>
         <p:nvSpPr>
-          <p:cNvPr id="2" name="Text Placeholder 1"/>
+          <p:cNvPr id="4" name="Text Placeholder 3"/>
           <p:cNvSpPr>
             <a:spLocks noGrp="1"/>
           </p:cNvSpPr>
@@ -34332,20 +34332,20 @@
               <a:buNone/>
             </a:pPr>
             <a:r>
-              <a:rPr sz="3200" b="0" i="0">
+              <a:rPr sz="3000" b="0" i="0">
                 <a:solidFill>
                   <a:srgbClr val="757575"/>
                 </a:solidFill>
                 <a:latin typeface="NVIDIA Sans"/>
               </a:rPr>
-              <a:t>For each request, the real-time target is end-to-end latency within the clip’s playback window; across the evaluated 60K–1M-token range, shape changes alter memory demand, kernel geometry, communication volume, and CUDA Graph reuse.</a:t>
-            </a:r>
-          </a:p>
-        </p:txBody>
-      </p:sp>
-      <p:sp>
-        <p:nvSpPr>
-          <p:cNvPr id="3" name="Title 2"/>
+              <a:t>For 362 frames at 24 FPS, the encoder, eight DiT steps, communication, and VAE decode share one 15.08 s end-to-end budget.</a:t>
+            </a:r>
+          </a:p>
+        </p:txBody>
+      </p:sp>
+      <p:sp>
+        <p:nvSpPr>
+          <p:cNvPr id="5" name="Title 4"/>
           <p:cNvSpPr>
             <a:spLocks noGrp="1"/>
           </p:cNvSpPr>
@@ -34368,35 +34368,80 @@
               <a:buNone/>
             </a:pPr>
             <a:r>
-              <a:rPr sz="6800" b="1" i="0">
+              <a:rPr sz="5800" b="1" i="0">
                 <a:solidFill>
                   <a:srgbClr val="000000"/>
                 </a:solidFill>
                 <a:latin typeface="NVIDIA Sans Medium"/>
               </a:rPr>
-              <a:t>Real-Time Video Generation Is a Distributed-Systems Problem</a:t>
-            </a:r>
-          </a:p>
-        </p:txBody>
-      </p:sp>
-      <p:sp>
-        <p:nvSpPr>
-          <p:cNvPr id="4" name="Text Placeholder 3"/>
-          <p:cNvSpPr>
-            <a:spLocks noGrp="1"/>
-          </p:cNvSpPr>
-          <p:nvPr>
-            <p:ph type="body" idx="52" sz="quarter"/>
-          </p:nvPr>
-        </p:nvSpPr>
-        <p:spPr>
-          <a:xfrm>
-            <a:off x="2377440" y="17300448"/>
-            <a:ext cx="31821119" cy="1261872"/>
-          </a:xfrm>
-        </p:spPr>
-        <p:txBody>
-          <a:bodyPr wrap="square" anchor="t"/>
+              <a:t>Real-Time 768p: The Full Pipeline Must Fit Within the Clip Duration</a:t>
+            </a:r>
+          </a:p>
+        </p:txBody>
+      </p:sp>
+      <p:sp>
+        <p:nvSpPr>
+          <p:cNvPr id="6" name="TextBox 5"/>
+          <p:cNvSpPr txBox="1"/>
+          <p:nvPr/>
+        </p:nvSpPr>
+        <p:spPr>
+          <a:xfrm>
+            <a:off x="7543800" y="19431000"/>
+            <a:ext cx="21488400" cy="365760"/>
+          </a:xfrm>
+          <a:prstGeom prst="rect">
+            <a:avLst/>
+          </a:prstGeom>
+          <a:noFill/>
+        </p:spPr>
+        <p:txBody>
+          <a:bodyPr wrap="square" anchor="ctr">
+            <a:spAutoFit/>
+          </a:bodyPr>
+          <a:lstStyle/>
+          <a:p>
+            <a:pPr algn="ctr">
+              <a:spcBef>
+                <a:spcPts val="0"/>
+              </a:spcBef>
+              <a:spcAft>
+                <a:spcPts val="0"/>
+              </a:spcAft>
+              <a:buNone/>
+            </a:pPr>
+            <a:r>
+              <a:rPr sz="2000" b="0" i="0">
+                <a:solidFill>
+                  <a:srgbClr val="757575"/>
+                </a:solidFill>
+                <a:latin typeface="NVIDIA Sans"/>
+              </a:rPr>
+              <a:t>Sources: official MiniMax H3, LTX-2.5, HunyuanVideo and Wan2.2 repositories · author 362-frame workload</a:t>
+            </a:r>
+          </a:p>
+        </p:txBody>
+      </p:sp>
+      <p:sp>
+        <p:nvSpPr>
+          <p:cNvPr id="7" name="TextBox 6"/>
+          <p:cNvSpPr txBox="1"/>
+          <p:nvPr/>
+        </p:nvSpPr>
+        <p:spPr>
+          <a:xfrm>
+            <a:off x="914400" y="19431000"/>
+            <a:ext cx="640080" cy="365760"/>
+          </a:xfrm>
+          <a:prstGeom prst="rect">
+            <a:avLst/>
+          </a:prstGeom>
+          <a:noFill/>
+        </p:spPr>
+        <p:txBody>
+          <a:bodyPr wrap="square" anchor="ctr">
+            <a:spAutoFit/>
+          </a:bodyPr>
           <a:lstStyle/>
           <a:p>
             <a:pPr algn="l">
@@ -34409,35 +34454,37 @@
               <a:buNone/>
             </a:pPr>
             <a:r>
-              <a:rPr sz="2600" b="0" i="0">
+              <a:rPr sz="2000" b="0" i="0">
                 <a:solidFill>
-                  <a:srgbClr val="313131"/>
+                  <a:srgbClr val="757575"/>
                 </a:solidFill>
                 <a:latin typeface="NVIDIA Sans"/>
               </a:rPr>
-              <a:t>Under SP8, the evaluated path repeatedly couples compute with Q/K/V and Gate/O exchange; launch gaps, transport fences, rank skew, and the decoder tail accumulate on the critical path, while the optimized system must preserve numerical equivalence to the reference path under the defined tolerance.</a:t>
-            </a:r>
-          </a:p>
-        </p:txBody>
-      </p:sp>
-      <p:sp>
-        <p:nvSpPr>
-          <p:cNvPr id="5" name="Text Placeholder 4"/>
-          <p:cNvSpPr>
-            <a:spLocks noGrp="1"/>
-          </p:cNvSpPr>
-          <p:nvPr>
-            <p:ph type="body" idx="51" sz="quarter"/>
-          </p:nvPr>
-        </p:nvSpPr>
-        <p:spPr>
-          <a:xfrm>
-            <a:off x="2377440" y="16687800"/>
-            <a:ext cx="31821119" cy="512064"/>
-          </a:xfrm>
-        </p:spPr>
-        <p:txBody>
-          <a:bodyPr wrap="square" anchor="ctr"/>
+              <a:t>2</a:t>
+            </a:r>
+          </a:p>
+        </p:txBody>
+      </p:sp>
+      <p:sp>
+        <p:nvSpPr>
+          <p:cNvPr id="8" name="TextBox 7"/>
+          <p:cNvSpPr txBox="1"/>
+          <p:nvPr/>
+        </p:nvSpPr>
+        <p:spPr>
+          <a:xfrm>
+            <a:off x="1828800" y="5532120"/>
+            <a:ext cx="6400800" cy="475488"/>
+          </a:xfrm>
+          <a:prstGeom prst="rect">
+            <a:avLst/>
+          </a:prstGeom>
+          <a:noFill/>
+        </p:spPr>
+        <p:txBody>
+          <a:bodyPr wrap="square" anchor="t" lIns="0" rIns="0" tIns="0" bIns="0">
+            <a:spAutoFit/>
+          </a:bodyPr>
           <a:lstStyle/>
           <a:p>
             <a:pPr algn="l">
@@ -34450,27 +34497,27 @@
               <a:buNone/>
             </a:pPr>
             <a:r>
-              <a:rPr sz="2600" b="1" i="0">
+              <a:rPr sz="2800" b="1" i="0">
                 <a:solidFill>
                   <a:srgbClr val="76B900"/>
                 </a:solidFill>
                 <a:latin typeface="NVIDIA Sans Medium"/>
               </a:rPr>
-              <a:t>EVALUATED PATH · 8 DiT STEPS × 50 BLOCKS = 400 REPEATED BLOCK EXECUTIONS</a:t>
-            </a:r>
-          </a:p>
-        </p:txBody>
-      </p:sp>
-      <p:sp>
-        <p:nvSpPr>
-          <p:cNvPr id="7" name="TextBox 6"/>
+              <a:t>REAL-TIME DEFINITION</a:t>
+            </a:r>
+          </a:p>
+        </p:txBody>
+      </p:sp>
+      <p:sp>
+        <p:nvSpPr>
+          <p:cNvPr id="9" name="TextBox 8"/>
           <p:cNvSpPr txBox="1"/>
           <p:nvPr/>
         </p:nvSpPr>
         <p:spPr>
           <a:xfrm>
-            <a:off x="7543800" y="19431000"/>
-            <a:ext cx="21488400" cy="365760"/>
+            <a:off x="1828800" y="6126480"/>
+            <a:ext cx="15361920" cy="822960"/>
           </a:xfrm>
           <a:prstGeom prst="rect">
             <a:avLst/>
@@ -34478,7 +34525,206 @@
           <a:noFill/>
         </p:spPr>
         <p:txBody>
-          <a:bodyPr wrap="square" anchor="ctr">
+          <a:bodyPr wrap="square" anchor="t" lIns="0" rIns="0" tIns="0" bIns="0">
+            <a:spAutoFit/>
+          </a:bodyPr>
+          <a:lstStyle/>
+          <a:p>
+            <a:pPr algn="l">
+              <a:spcBef>
+                <a:spcPts val="0"/>
+              </a:spcBef>
+              <a:spcAft>
+                <a:spcPts val="0"/>
+              </a:spcAft>
+              <a:buNone/>
+            </a:pPr>
+            <a:r>
+              <a:rPr sz="3600" b="1" i="0">
+                <a:solidFill>
+                  <a:srgbClr val="313131"/>
+                </a:solidFill>
+                <a:latin typeface="NVIDIA Sans Medium"/>
+              </a:rPr>
+              <a:t>RTF = end-to-end latency ÷ media duration ≤ 1.0</a:t>
+            </a:r>
+          </a:p>
+        </p:txBody>
+      </p:sp>
+      <p:sp>
+        <p:nvSpPr>
+          <p:cNvPr id="10" name="TextBox 9"/>
+          <p:cNvSpPr txBox="1"/>
+          <p:nvPr/>
+        </p:nvSpPr>
+        <p:spPr>
+          <a:xfrm>
+            <a:off x="1828800" y="7022592"/>
+            <a:ext cx="15361920" cy="548640"/>
+          </a:xfrm>
+          <a:prstGeom prst="rect">
+            <a:avLst/>
+          </a:prstGeom>
+          <a:noFill/>
+        </p:spPr>
+        <p:txBody>
+          <a:bodyPr wrap="square" anchor="t" lIns="0" rIns="0" tIns="0" bIns="0">
+            <a:spAutoFit/>
+          </a:bodyPr>
+          <a:lstStyle/>
+          <a:p>
+            <a:pPr algn="l">
+              <a:spcBef>
+                <a:spcPts val="0"/>
+              </a:spcBef>
+              <a:spcAft>
+                <a:spcPts val="0"/>
+              </a:spcAft>
+              <a:buNone/>
+            </a:pPr>
+            <a:r>
+              <a:rPr sz="2700" b="0" i="0">
+                <a:solidFill>
+                  <a:srgbClr val="757575"/>
+                </a:solidFill>
+                <a:latin typeface="NVIDIA Sans"/>
+              </a:rPr>
+              <a:t>768p · 362 frames @ 24 FPS · 15.08 s media  →  ≤ 15.08 s end to end</a:t>
+            </a:r>
+          </a:p>
+        </p:txBody>
+      </p:sp>
+      <p:cxnSp>
+        <p:nvCxnSpPr>
+          <p:cNvPr id="11" name="Connector 10"/>
+          <p:cNvCxnSpPr/>
+          <p:nvPr/>
+        </p:nvCxnSpPr>
+        <p:spPr>
+          <a:xfrm>
+            <a:off x="1828800" y="7882127"/>
+            <a:ext cx="15316200" cy="0"/>
+          </a:xfrm>
+          <a:prstGeom prst="line">
+            <a:avLst/>
+          </a:prstGeom>
+          <a:ln w="12700">
+            <a:solidFill>
+              <a:srgbClr val="D9D9D9"/>
+            </a:solidFill>
+          </a:ln>
+        </p:spPr>
+        <p:style>
+          <a:lnRef idx="2">
+            <a:schemeClr val="accent1"/>
+          </a:lnRef>
+          <a:fillRef idx="0">
+            <a:schemeClr val="accent1"/>
+          </a:fillRef>
+          <a:effectRef idx="1">
+            <a:schemeClr val="accent1"/>
+          </a:effectRef>
+          <a:fontRef idx="minor">
+            <a:schemeClr val="tx1"/>
+          </a:fontRef>
+        </p:style>
+      </p:cxnSp>
+      <p:sp>
+        <p:nvSpPr>
+          <p:cNvPr id="12" name="TextBox 11"/>
+          <p:cNvSpPr txBox="1"/>
+          <p:nvPr/>
+        </p:nvSpPr>
+        <p:spPr>
+          <a:xfrm>
+            <a:off x="1828800" y="8247888"/>
+            <a:ext cx="15270480" cy="475488"/>
+          </a:xfrm>
+          <a:prstGeom prst="rect">
+            <a:avLst/>
+          </a:prstGeom>
+          <a:noFill/>
+        </p:spPr>
+        <p:txBody>
+          <a:bodyPr wrap="square" anchor="t" lIns="0" rIns="0" tIns="0" bIns="0">
+            <a:spAutoFit/>
+          </a:bodyPr>
+          <a:lstStyle/>
+          <a:p>
+            <a:pPr algn="l">
+              <a:spcBef>
+                <a:spcPts val="0"/>
+              </a:spcBef>
+              <a:spcAft>
+                <a:spcPts val="0"/>
+              </a:spcAft>
+              <a:buNone/>
+            </a:pPr>
+            <a:r>
+              <a:rPr sz="2800" b="1" i="0">
+                <a:solidFill>
+                  <a:srgbClr val="313131"/>
+                </a:solidFill>
+                <a:latin typeface="NVIDIA Sans Medium"/>
+              </a:rPr>
+              <a:t>PUBLISHED VIDEO DENOISER SCALE · BILLION PARAMETERS</a:t>
+            </a:r>
+          </a:p>
+        </p:txBody>
+      </p:sp>
+      <p:cxnSp>
+        <p:nvCxnSpPr>
+          <p:cNvPr id="13" name="Connector 12"/>
+          <p:cNvCxnSpPr/>
+          <p:nvPr/>
+        </p:nvCxnSpPr>
+        <p:spPr>
+          <a:xfrm>
+            <a:off x="6537960" y="9272016"/>
+            <a:ext cx="0" cy="5742432"/>
+          </a:xfrm>
+          <a:prstGeom prst="line">
+            <a:avLst/>
+          </a:prstGeom>
+          <a:ln w="9525">
+            <a:solidFill>
+              <a:srgbClr val="D9D9D9"/>
+            </a:solidFill>
+          </a:ln>
+        </p:spPr>
+        <p:style>
+          <a:lnRef idx="2">
+            <a:schemeClr val="accent1"/>
+          </a:lnRef>
+          <a:fillRef idx="0">
+            <a:schemeClr val="accent1"/>
+          </a:fillRef>
+          <a:effectRef idx="1">
+            <a:schemeClr val="accent1"/>
+          </a:effectRef>
+          <a:fontRef idx="minor">
+            <a:schemeClr val="tx1"/>
+          </a:fontRef>
+        </p:style>
+      </p:cxnSp>
+      <p:sp>
+        <p:nvSpPr>
+          <p:cNvPr id="14" name="TextBox 13"/>
+          <p:cNvSpPr txBox="1"/>
+          <p:nvPr/>
+        </p:nvSpPr>
+        <p:spPr>
+          <a:xfrm>
+            <a:off x="6300216" y="8887968"/>
+            <a:ext cx="475488" cy="292608"/>
+          </a:xfrm>
+          <a:prstGeom prst="rect">
+            <a:avLst/>
+          </a:prstGeom>
+          <a:noFill/>
+        </p:spPr>
+        <p:txBody>
+          <a:bodyPr wrap="square" anchor="t" lIns="0" rIns="0" tIns="0" bIns="0">
             <a:spAutoFit/>
           </a:bodyPr>
           <a:lstStyle/>
@@ -34493,27 +34739,62 @@
               <a:buNone/>
             </a:pPr>
             <a:r>
-              <a:rPr sz="2000" b="0" i="0">
+              <a:rPr sz="1800" b="0" i="0">
                 <a:solidFill>
                   <a:srgbClr val="757575"/>
                 </a:solidFill>
                 <a:latin typeface="NVIDIA Sans"/>
               </a:rPr>
-              <a:t>Sources: vLLM-Omni v0.26 public deck, slide 23 · author evaluated workload envelope and eight-GPU execution path</a:t>
-            </a:r>
-          </a:p>
-        </p:txBody>
-      </p:sp>
-      <p:sp>
-        <p:nvSpPr>
-          <p:cNvPr id="8" name="TextBox 7"/>
+              <a:t>0</a:t>
+            </a:r>
+          </a:p>
+        </p:txBody>
+      </p:sp>
+      <p:cxnSp>
+        <p:nvCxnSpPr>
+          <p:cNvPr id="15" name="Connector 14"/>
+          <p:cNvCxnSpPr/>
+          <p:nvPr/>
+        </p:nvCxnSpPr>
+        <p:spPr>
+          <a:xfrm>
+            <a:off x="9350432" y="9272016"/>
+            <a:ext cx="0" cy="5742432"/>
+          </a:xfrm>
+          <a:prstGeom prst="line">
+            <a:avLst/>
+          </a:prstGeom>
+          <a:ln w="9525">
+            <a:solidFill>
+              <a:srgbClr val="D9D9D9"/>
+            </a:solidFill>
+          </a:ln>
+        </p:spPr>
+        <p:style>
+          <a:lnRef idx="2">
+            <a:schemeClr val="accent1"/>
+          </a:lnRef>
+          <a:fillRef idx="0">
+            <a:schemeClr val="accent1"/>
+          </a:fillRef>
+          <a:effectRef idx="1">
+            <a:schemeClr val="accent1"/>
+          </a:effectRef>
+          <a:fontRef idx="minor">
+            <a:schemeClr val="tx1"/>
+          </a:fontRef>
+        </p:style>
+      </p:cxnSp>
+      <p:sp>
+        <p:nvSpPr>
+          <p:cNvPr id="16" name="TextBox 15"/>
           <p:cNvSpPr txBox="1"/>
           <p:nvPr/>
         </p:nvSpPr>
         <p:spPr>
           <a:xfrm>
-            <a:off x="914400" y="19431000"/>
-            <a:ext cx="640080" cy="365760"/>
+            <a:off x="9112688" y="8887968"/>
+            <a:ext cx="475488" cy="292608"/>
           </a:xfrm>
           <a:prstGeom prst="rect">
             <a:avLst/>
@@ -34521,7 +34802,292 @@
           <a:noFill/>
         </p:spPr>
         <p:txBody>
-          <a:bodyPr wrap="square" anchor="ctr">
+          <a:bodyPr wrap="square" anchor="t" lIns="0" rIns="0" tIns="0" bIns="0">
+            <a:spAutoFit/>
+          </a:bodyPr>
+          <a:lstStyle/>
+          <a:p>
+            <a:pPr algn="ctr">
+              <a:spcBef>
+                <a:spcPts val="0"/>
+              </a:spcBef>
+              <a:spcAft>
+                <a:spcPts val="0"/>
+              </a:spcAft>
+              <a:buNone/>
+            </a:pPr>
+            <a:r>
+              <a:rPr sz="1800" b="0" i="0">
+                <a:solidFill>
+                  <a:srgbClr val="757575"/>
+                </a:solidFill>
+                <a:latin typeface="NVIDIA Sans"/>
+              </a:rPr>
+              <a:t>10</a:t>
+            </a:r>
+          </a:p>
+        </p:txBody>
+      </p:sp>
+      <p:cxnSp>
+        <p:nvCxnSpPr>
+          <p:cNvPr id="17" name="Connector 16"/>
+          <p:cNvCxnSpPr/>
+          <p:nvPr/>
+        </p:nvCxnSpPr>
+        <p:spPr>
+          <a:xfrm>
+            <a:off x="12162905" y="9272016"/>
+            <a:ext cx="0" cy="5742432"/>
+          </a:xfrm>
+          <a:prstGeom prst="line">
+            <a:avLst/>
+          </a:prstGeom>
+          <a:ln w="9525">
+            <a:solidFill>
+              <a:srgbClr val="D9D9D9"/>
+            </a:solidFill>
+          </a:ln>
+        </p:spPr>
+        <p:style>
+          <a:lnRef idx="2">
+            <a:schemeClr val="accent1"/>
+          </a:lnRef>
+          <a:fillRef idx="0">
+            <a:schemeClr val="accent1"/>
+          </a:fillRef>
+          <a:effectRef idx="1">
+            <a:schemeClr val="accent1"/>
+          </a:effectRef>
+          <a:fontRef idx="minor">
+            <a:schemeClr val="tx1"/>
+          </a:fontRef>
+        </p:style>
+      </p:cxnSp>
+      <p:sp>
+        <p:nvSpPr>
+          <p:cNvPr id="18" name="TextBox 17"/>
+          <p:cNvSpPr txBox="1"/>
+          <p:nvPr/>
+        </p:nvSpPr>
+        <p:spPr>
+          <a:xfrm>
+            <a:off x="11925161" y="8887968"/>
+            <a:ext cx="475488" cy="292608"/>
+          </a:xfrm>
+          <a:prstGeom prst="rect">
+            <a:avLst/>
+          </a:prstGeom>
+          <a:noFill/>
+        </p:spPr>
+        <p:txBody>
+          <a:bodyPr wrap="square" anchor="t" lIns="0" rIns="0" tIns="0" bIns="0">
+            <a:spAutoFit/>
+          </a:bodyPr>
+          <a:lstStyle/>
+          <a:p>
+            <a:pPr algn="ctr">
+              <a:spcBef>
+                <a:spcPts val="0"/>
+              </a:spcBef>
+              <a:spcAft>
+                <a:spcPts val="0"/>
+              </a:spcAft>
+              <a:buNone/>
+            </a:pPr>
+            <a:r>
+              <a:rPr sz="1800" b="0" i="0">
+                <a:solidFill>
+                  <a:srgbClr val="757575"/>
+                </a:solidFill>
+                <a:latin typeface="NVIDIA Sans"/>
+              </a:rPr>
+              <a:t>20</a:t>
+            </a:r>
+          </a:p>
+        </p:txBody>
+      </p:sp>
+      <p:cxnSp>
+        <p:nvCxnSpPr>
+          <p:cNvPr id="19" name="Connector 18"/>
+          <p:cNvCxnSpPr/>
+          <p:nvPr/>
+        </p:nvCxnSpPr>
+        <p:spPr>
+          <a:xfrm>
+            <a:off x="14975378" y="9272016"/>
+            <a:ext cx="0" cy="5742432"/>
+          </a:xfrm>
+          <a:prstGeom prst="line">
+            <a:avLst/>
+          </a:prstGeom>
+          <a:ln w="9525">
+            <a:solidFill>
+              <a:srgbClr val="D9D9D9"/>
+            </a:solidFill>
+          </a:ln>
+        </p:spPr>
+        <p:style>
+          <a:lnRef idx="2">
+            <a:schemeClr val="accent1"/>
+          </a:lnRef>
+          <a:fillRef idx="0">
+            <a:schemeClr val="accent1"/>
+          </a:fillRef>
+          <a:effectRef idx="1">
+            <a:schemeClr val="accent1"/>
+          </a:effectRef>
+          <a:fontRef idx="minor">
+            <a:schemeClr val="tx1"/>
+          </a:fontRef>
+        </p:style>
+      </p:cxnSp>
+      <p:sp>
+        <p:nvSpPr>
+          <p:cNvPr id="20" name="TextBox 19"/>
+          <p:cNvSpPr txBox="1"/>
+          <p:nvPr/>
+        </p:nvSpPr>
+        <p:spPr>
+          <a:xfrm>
+            <a:off x="14737634" y="8887968"/>
+            <a:ext cx="475488" cy="292608"/>
+          </a:xfrm>
+          <a:prstGeom prst="rect">
+            <a:avLst/>
+          </a:prstGeom>
+          <a:noFill/>
+        </p:spPr>
+        <p:txBody>
+          <a:bodyPr wrap="square" anchor="t" lIns="0" rIns="0" tIns="0" bIns="0">
+            <a:spAutoFit/>
+          </a:bodyPr>
+          <a:lstStyle/>
+          <a:p>
+            <a:pPr algn="ctr">
+              <a:spcBef>
+                <a:spcPts val="0"/>
+              </a:spcBef>
+              <a:spcAft>
+                <a:spcPts val="0"/>
+              </a:spcAft>
+              <a:buNone/>
+            </a:pPr>
+            <a:r>
+              <a:rPr sz="1800" b="0" i="0">
+                <a:solidFill>
+                  <a:srgbClr val="757575"/>
+                </a:solidFill>
+                <a:latin typeface="NVIDIA Sans"/>
+              </a:rPr>
+              <a:t>30</a:t>
+            </a:r>
+          </a:p>
+        </p:txBody>
+      </p:sp>
+      <p:sp>
+        <p:nvSpPr>
+          <p:cNvPr id="21" name="TextBox 20"/>
+          <p:cNvSpPr txBox="1"/>
+          <p:nvPr/>
+        </p:nvSpPr>
+        <p:spPr>
+          <a:xfrm>
+            <a:off x="1828800" y="9473184"/>
+            <a:ext cx="4434840" cy="475488"/>
+          </a:xfrm>
+          <a:prstGeom prst="rect">
+            <a:avLst/>
+          </a:prstGeom>
+          <a:noFill/>
+        </p:spPr>
+        <p:txBody>
+          <a:bodyPr wrap="square" anchor="ctr" lIns="0" rIns="0" tIns="0" bIns="0">
+            <a:spAutoFit/>
+          </a:bodyPr>
+          <a:lstStyle/>
+          <a:p>
+            <a:pPr algn="r">
+              <a:spcBef>
+                <a:spcPts val="0"/>
+              </a:spcBef>
+              <a:spcAft>
+                <a:spcPts val="0"/>
+              </a:spcAft>
+              <a:buNone/>
+            </a:pPr>
+            <a:r>
+              <a:rPr sz="2400" b="1" i="0">
+                <a:solidFill>
+                  <a:srgbClr val="313131"/>
+                </a:solidFill>
+                <a:latin typeface="NVIDIA Sans Medium"/>
+              </a:rPr>
+              <a:t>MiniMax H3</a:t>
+            </a:r>
+          </a:p>
+        </p:txBody>
+      </p:sp>
+      <p:sp>
+        <p:nvSpPr>
+          <p:cNvPr id="22" name="Rectangle 21"/>
+          <p:cNvSpPr/>
+          <p:nvPr/>
+        </p:nvSpPr>
+        <p:spPr>
+          <a:xfrm>
+            <a:off x="6537960" y="9491472"/>
+            <a:ext cx="9281160" cy="530352"/>
+          </a:xfrm>
+          <a:prstGeom prst="rect">
+            <a:avLst/>
+          </a:prstGeom>
+          <a:solidFill>
+            <a:srgbClr val="76B900"/>
+          </a:solidFill>
+          <a:ln>
+            <a:noFill/>
+          </a:ln>
+        </p:spPr>
+        <p:style>
+          <a:lnRef idx="1">
+            <a:schemeClr val="accent1"/>
+          </a:lnRef>
+          <a:fillRef idx="3">
+            <a:schemeClr val="accent1"/>
+          </a:fillRef>
+          <a:effectRef idx="2">
+            <a:schemeClr val="accent1"/>
+          </a:effectRef>
+          <a:fontRef idx="minor">
+            <a:schemeClr val="lt1"/>
+          </a:fontRef>
+        </p:style>
+        <p:txBody>
+          <a:bodyPr rtlCol="0" anchor="ctr"/>
+          <a:lstStyle/>
+          <a:p>
+            <a:pPr algn="ctr"/>
+          </a:p>
+        </p:txBody>
+      </p:sp>
+      <p:sp>
+        <p:nvSpPr>
+          <p:cNvPr id="23" name="TextBox 22"/>
+          <p:cNvSpPr txBox="1"/>
+          <p:nvPr/>
+        </p:nvSpPr>
+        <p:spPr>
+          <a:xfrm>
+            <a:off x="15956280" y="9464040"/>
+            <a:ext cx="1417320" cy="548640"/>
+          </a:xfrm>
+          <a:prstGeom prst="rect">
+            <a:avLst/>
+          </a:prstGeom>
+          <a:noFill/>
+        </p:spPr>
+        <p:txBody>
+          <a:bodyPr wrap="square" anchor="ctr" lIns="0" rIns="0" tIns="0" bIns="0">
             <a:spAutoFit/>
           </a:bodyPr>
           <a:lstStyle/>
@@ -34536,20 +35102,944 @@
               <a:buNone/>
             </a:pPr>
             <a:r>
-              <a:rPr sz="2000" b="0" i="0">
+              <a:rPr sz="2100" b="1" i="0">
+                <a:solidFill>
+                  <a:srgbClr val="76B900"/>
+                </a:solidFill>
+                <a:latin typeface="NVIDIA Sans Medium"/>
+              </a:rPr>
+              <a:t>33B dense</a:t>
+            </a:r>
+          </a:p>
+        </p:txBody>
+      </p:sp>
+      <p:sp>
+        <p:nvSpPr>
+          <p:cNvPr id="24" name="TextBox 23"/>
+          <p:cNvSpPr txBox="1"/>
+          <p:nvPr/>
+        </p:nvSpPr>
+        <p:spPr>
+          <a:xfrm>
+            <a:off x="1828800" y="10826496"/>
+            <a:ext cx="4434840" cy="475488"/>
+          </a:xfrm>
+          <a:prstGeom prst="rect">
+            <a:avLst/>
+          </a:prstGeom>
+          <a:noFill/>
+        </p:spPr>
+        <p:txBody>
+          <a:bodyPr wrap="square" anchor="ctr" lIns="0" rIns="0" tIns="0" bIns="0">
+            <a:spAutoFit/>
+          </a:bodyPr>
+          <a:lstStyle/>
+          <a:p>
+            <a:pPr algn="r">
+              <a:spcBef>
+                <a:spcPts val="0"/>
+              </a:spcBef>
+              <a:spcAft>
+                <a:spcPts val="0"/>
+              </a:spcAft>
+              <a:buNone/>
+            </a:pPr>
+            <a:r>
+              <a:rPr sz="2400" b="0" i="0">
+                <a:solidFill>
+                  <a:srgbClr val="313131"/>
+                </a:solidFill>
+                <a:latin typeface="NVIDIA Sans"/>
+              </a:rPr>
+              <a:t>Wan2.2 A14B</a:t>
+            </a:r>
+          </a:p>
+        </p:txBody>
+      </p:sp>
+      <p:sp>
+        <p:nvSpPr>
+          <p:cNvPr id="25" name="Rectangle 24"/>
+          <p:cNvSpPr/>
+          <p:nvPr/>
+        </p:nvSpPr>
+        <p:spPr>
+          <a:xfrm>
+            <a:off x="6537960" y="10844784"/>
+            <a:ext cx="7593676" cy="530352"/>
+          </a:xfrm>
+          <a:prstGeom prst="rect">
+            <a:avLst/>
+          </a:prstGeom>
+          <a:solidFill>
+            <a:srgbClr val="F3EBF8"/>
+          </a:solidFill>
+          <a:ln w="12700">
+            <a:solidFill>
+              <a:srgbClr val="952FC6"/>
+            </a:solidFill>
+          </a:ln>
+        </p:spPr>
+        <p:style>
+          <a:lnRef idx="1">
+            <a:schemeClr val="accent1"/>
+          </a:lnRef>
+          <a:fillRef idx="3">
+            <a:schemeClr val="accent1"/>
+          </a:fillRef>
+          <a:effectRef idx="2">
+            <a:schemeClr val="accent1"/>
+          </a:effectRef>
+          <a:fontRef idx="minor">
+            <a:schemeClr val="lt1"/>
+          </a:fontRef>
+        </p:style>
+        <p:txBody>
+          <a:bodyPr rtlCol="0" anchor="ctr"/>
+          <a:lstStyle/>
+          <a:p>
+            <a:pPr algn="ctr"/>
+          </a:p>
+        </p:txBody>
+      </p:sp>
+      <p:sp>
+        <p:nvSpPr>
+          <p:cNvPr id="26" name="Rectangle 25"/>
+          <p:cNvSpPr/>
+          <p:nvPr/>
+        </p:nvSpPr>
+        <p:spPr>
+          <a:xfrm>
+            <a:off x="6537960" y="10844784"/>
+            <a:ext cx="3937461" cy="530352"/>
+          </a:xfrm>
+          <a:prstGeom prst="rect">
+            <a:avLst/>
+          </a:prstGeom>
+          <a:solidFill>
+            <a:srgbClr val="952FC6"/>
+          </a:solidFill>
+          <a:ln>
+            <a:noFill/>
+          </a:ln>
+        </p:spPr>
+        <p:style>
+          <a:lnRef idx="1">
+            <a:schemeClr val="accent1"/>
+          </a:lnRef>
+          <a:fillRef idx="3">
+            <a:schemeClr val="accent1"/>
+          </a:fillRef>
+          <a:effectRef idx="2">
+            <a:schemeClr val="accent1"/>
+          </a:effectRef>
+          <a:fontRef idx="minor">
+            <a:schemeClr val="lt1"/>
+          </a:fontRef>
+        </p:style>
+        <p:txBody>
+          <a:bodyPr rtlCol="0" anchor="ctr"/>
+          <a:lstStyle/>
+          <a:p>
+            <a:pPr algn="ctr"/>
+          </a:p>
+        </p:txBody>
+      </p:sp>
+      <p:sp>
+        <p:nvSpPr>
+          <p:cNvPr id="27" name="TextBox 26"/>
+          <p:cNvSpPr txBox="1"/>
+          <p:nvPr/>
+        </p:nvSpPr>
+        <p:spPr>
+          <a:xfrm>
+            <a:off x="14296228" y="10817352"/>
+            <a:ext cx="1965960" cy="548640"/>
+          </a:xfrm>
+          <a:prstGeom prst="rect">
+            <a:avLst/>
+          </a:prstGeom>
+          <a:noFill/>
+        </p:spPr>
+        <p:txBody>
+          <a:bodyPr wrap="square" anchor="ctr" lIns="0" rIns="0" tIns="0" bIns="0">
+            <a:spAutoFit/>
+          </a:bodyPr>
+          <a:lstStyle/>
+          <a:p>
+            <a:pPr algn="l">
+              <a:spcBef>
+                <a:spcPts val="0"/>
+              </a:spcBef>
+              <a:spcAft>
+                <a:spcPts val="0"/>
+              </a:spcAft>
+              <a:buNone/>
+            </a:pPr>
+            <a:r>
+              <a:rPr sz="2100" b="1" i="0">
+                <a:solidFill>
+                  <a:srgbClr val="313131"/>
+                </a:solidFill>
+                <a:latin typeface="NVIDIA Sans Medium"/>
+              </a:rPr>
+              <a:t>27B total / 14B active</a:t>
+            </a:r>
+          </a:p>
+        </p:txBody>
+      </p:sp>
+      <p:sp>
+        <p:nvSpPr>
+          <p:cNvPr id="28" name="TextBox 27"/>
+          <p:cNvSpPr txBox="1"/>
+          <p:nvPr/>
+        </p:nvSpPr>
+        <p:spPr>
+          <a:xfrm>
+            <a:off x="1828800" y="12179808"/>
+            <a:ext cx="4434840" cy="475488"/>
+          </a:xfrm>
+          <a:prstGeom prst="rect">
+            <a:avLst/>
+          </a:prstGeom>
+          <a:noFill/>
+        </p:spPr>
+        <p:txBody>
+          <a:bodyPr wrap="square" anchor="ctr" lIns="0" rIns="0" tIns="0" bIns="0">
+            <a:spAutoFit/>
+          </a:bodyPr>
+          <a:lstStyle/>
+          <a:p>
+            <a:pPr algn="r">
+              <a:spcBef>
+                <a:spcPts val="0"/>
+              </a:spcBef>
+              <a:spcAft>
+                <a:spcPts val="0"/>
+              </a:spcAft>
+              <a:buNone/>
+            </a:pPr>
+            <a:r>
+              <a:rPr sz="2400" b="0" i="0">
+                <a:solidFill>
+                  <a:srgbClr val="313131"/>
+                </a:solidFill>
+                <a:latin typeface="NVIDIA Sans"/>
+              </a:rPr>
+              <a:t>LTX-2.5</a:t>
+            </a:r>
+          </a:p>
+        </p:txBody>
+      </p:sp>
+      <p:sp>
+        <p:nvSpPr>
+          <p:cNvPr id="29" name="Rectangle 28"/>
+          <p:cNvSpPr/>
+          <p:nvPr/>
+        </p:nvSpPr>
+        <p:spPr>
+          <a:xfrm>
+            <a:off x="6537960" y="12198096"/>
+            <a:ext cx="6187440" cy="530352"/>
+          </a:xfrm>
+          <a:prstGeom prst="rect">
+            <a:avLst/>
+          </a:prstGeom>
+          <a:solidFill>
+            <a:srgbClr val="0074DF"/>
+          </a:solidFill>
+          <a:ln>
+            <a:noFill/>
+          </a:ln>
+        </p:spPr>
+        <p:style>
+          <a:lnRef idx="1">
+            <a:schemeClr val="accent1"/>
+          </a:lnRef>
+          <a:fillRef idx="3">
+            <a:schemeClr val="accent1"/>
+          </a:fillRef>
+          <a:effectRef idx="2">
+            <a:schemeClr val="accent1"/>
+          </a:effectRef>
+          <a:fontRef idx="minor">
+            <a:schemeClr val="lt1"/>
+          </a:fontRef>
+        </p:style>
+        <p:txBody>
+          <a:bodyPr rtlCol="0" anchor="ctr"/>
+          <a:lstStyle/>
+          <a:p>
+            <a:pPr algn="ctr"/>
+          </a:p>
+        </p:txBody>
+      </p:sp>
+      <p:sp>
+        <p:nvSpPr>
+          <p:cNvPr id="30" name="TextBox 29"/>
+          <p:cNvSpPr txBox="1"/>
+          <p:nvPr/>
+        </p:nvSpPr>
+        <p:spPr>
+          <a:xfrm>
+            <a:off x="12889992" y="12170664"/>
+            <a:ext cx="1417320" cy="548640"/>
+          </a:xfrm>
+          <a:prstGeom prst="rect">
+            <a:avLst/>
+          </a:prstGeom>
+          <a:noFill/>
+        </p:spPr>
+        <p:txBody>
+          <a:bodyPr wrap="square" anchor="ctr" lIns="0" rIns="0" tIns="0" bIns="0">
+            <a:spAutoFit/>
+          </a:bodyPr>
+          <a:lstStyle/>
+          <a:p>
+            <a:pPr algn="l">
+              <a:spcBef>
+                <a:spcPts val="0"/>
+              </a:spcBef>
+              <a:spcAft>
+                <a:spcPts val="0"/>
+              </a:spcAft>
+              <a:buNone/>
+            </a:pPr>
+            <a:r>
+              <a:rPr sz="2100" b="1" i="0">
+                <a:solidFill>
+                  <a:srgbClr val="313131"/>
+                </a:solidFill>
+                <a:latin typeface="NVIDIA Sans Medium"/>
+              </a:rPr>
+              <a:t>22B*</a:t>
+            </a:r>
+          </a:p>
+        </p:txBody>
+      </p:sp>
+      <p:sp>
+        <p:nvSpPr>
+          <p:cNvPr id="31" name="TextBox 30"/>
+          <p:cNvSpPr txBox="1"/>
+          <p:nvPr/>
+        </p:nvSpPr>
+        <p:spPr>
+          <a:xfrm>
+            <a:off x="1828800" y="13533120"/>
+            <a:ext cx="4434840" cy="475488"/>
+          </a:xfrm>
+          <a:prstGeom prst="rect">
+            <a:avLst/>
+          </a:prstGeom>
+          <a:noFill/>
+        </p:spPr>
+        <p:txBody>
+          <a:bodyPr wrap="square" anchor="ctr" lIns="0" rIns="0" tIns="0" bIns="0">
+            <a:spAutoFit/>
+          </a:bodyPr>
+          <a:lstStyle/>
+          <a:p>
+            <a:pPr algn="r">
+              <a:spcBef>
+                <a:spcPts val="0"/>
+              </a:spcBef>
+              <a:spcAft>
+                <a:spcPts val="0"/>
+              </a:spcAft>
+              <a:buNone/>
+            </a:pPr>
+            <a:r>
+              <a:rPr sz="2400" b="0" i="0">
+                <a:solidFill>
+                  <a:srgbClr val="313131"/>
+                </a:solidFill>
+                <a:latin typeface="NVIDIA Sans"/>
+              </a:rPr>
+              <a:t>HunyuanVideo</a:t>
+            </a:r>
+          </a:p>
+        </p:txBody>
+      </p:sp>
+      <p:sp>
+        <p:nvSpPr>
+          <p:cNvPr id="32" name="Rectangle 31"/>
+          <p:cNvSpPr/>
+          <p:nvPr/>
+        </p:nvSpPr>
+        <p:spPr>
+          <a:xfrm>
+            <a:off x="6537960" y="13551408"/>
+            <a:ext cx="3656214" cy="530352"/>
+          </a:xfrm>
+          <a:prstGeom prst="rect">
+            <a:avLst/>
+          </a:prstGeom>
+          <a:solidFill>
+            <a:srgbClr val="757575"/>
+          </a:solidFill>
+          <a:ln>
+            <a:noFill/>
+          </a:ln>
+        </p:spPr>
+        <p:style>
+          <a:lnRef idx="1">
+            <a:schemeClr val="accent1"/>
+          </a:lnRef>
+          <a:fillRef idx="3">
+            <a:schemeClr val="accent1"/>
+          </a:fillRef>
+          <a:effectRef idx="2">
+            <a:schemeClr val="accent1"/>
+          </a:effectRef>
+          <a:fontRef idx="minor">
+            <a:schemeClr val="lt1"/>
+          </a:fontRef>
+        </p:style>
+        <p:txBody>
+          <a:bodyPr rtlCol="0" anchor="ctr"/>
+          <a:lstStyle/>
+          <a:p>
+            <a:pPr algn="ctr"/>
+          </a:p>
+        </p:txBody>
+      </p:sp>
+      <p:sp>
+        <p:nvSpPr>
+          <p:cNvPr id="33" name="TextBox 32"/>
+          <p:cNvSpPr txBox="1"/>
+          <p:nvPr/>
+        </p:nvSpPr>
+        <p:spPr>
+          <a:xfrm>
+            <a:off x="10358766" y="13523976"/>
+            <a:ext cx="1417320" cy="548640"/>
+          </a:xfrm>
+          <a:prstGeom prst="rect">
+            <a:avLst/>
+          </a:prstGeom>
+          <a:noFill/>
+        </p:spPr>
+        <p:txBody>
+          <a:bodyPr wrap="square" anchor="ctr" lIns="0" rIns="0" tIns="0" bIns="0">
+            <a:spAutoFit/>
+          </a:bodyPr>
+          <a:lstStyle/>
+          <a:p>
+            <a:pPr algn="l">
+              <a:spcBef>
+                <a:spcPts val="0"/>
+              </a:spcBef>
+              <a:spcAft>
+                <a:spcPts val="0"/>
+              </a:spcAft>
+              <a:buNone/>
+            </a:pPr>
+            <a:r>
+              <a:rPr sz="2100" b="1" i="0">
+                <a:solidFill>
+                  <a:srgbClr val="313131"/>
+                </a:solidFill>
+                <a:latin typeface="NVIDIA Sans Medium"/>
+              </a:rPr>
+              <a:t>13B</a:t>
+            </a:r>
+          </a:p>
+        </p:txBody>
+      </p:sp>
+      <p:sp>
+        <p:nvSpPr>
+          <p:cNvPr id="34" name="TextBox 33"/>
+          <p:cNvSpPr txBox="1"/>
+          <p:nvPr/>
+        </p:nvSpPr>
+        <p:spPr>
+          <a:xfrm>
+            <a:off x="1828800" y="15032736"/>
+            <a:ext cx="15316200" cy="804672"/>
+          </a:xfrm>
+          <a:prstGeom prst="rect">
+            <a:avLst/>
+          </a:prstGeom>
+          <a:noFill/>
+        </p:spPr>
+        <p:txBody>
+          <a:bodyPr wrap="square" anchor="t" lIns="0" rIns="0" tIns="0" bIns="0">
+            <a:spAutoFit/>
+          </a:bodyPr>
+          <a:lstStyle/>
+          <a:p>
+            <a:pPr algn="l">
+              <a:spcBef>
+                <a:spcPts val="0"/>
+              </a:spcBef>
+              <a:spcAft>
+                <a:spcPts val="0"/>
+              </a:spcAft>
+              <a:buNone/>
+            </a:pPr>
+            <a:r>
+              <a:rPr sz="1900" b="0" i="0">
                 <a:solidFill>
                   <a:srgbClr val="757575"/>
                 </a:solidFill>
                 <a:latin typeface="NVIDIA Sans"/>
               </a:rPr>
-              <a:t>2</a:t>
+              <a:t>*LTX-2.5 uses the official 22B checkpoint designation. Parameter count is a scale proxy; architecture, active paths, sequence length, and denoising steps determine actual FLOPs.</a:t>
+            </a:r>
+          </a:p>
+        </p:txBody>
+      </p:sp>
+      <p:cxnSp>
+        <p:nvCxnSpPr>
+          <p:cNvPr id="35" name="Connector 34"/>
+          <p:cNvCxnSpPr/>
+          <p:nvPr/>
+        </p:nvCxnSpPr>
+        <p:spPr>
+          <a:xfrm>
+            <a:off x="1874519" y="16203167"/>
+            <a:ext cx="0" cy="2103121"/>
+          </a:xfrm>
+          <a:prstGeom prst="line">
+            <a:avLst/>
+          </a:prstGeom>
+          <a:ln w="38100">
+            <a:solidFill>
+              <a:srgbClr val="76B900"/>
+            </a:solidFill>
+          </a:ln>
+        </p:spPr>
+        <p:style>
+          <a:lnRef idx="2">
+            <a:schemeClr val="accent1"/>
+          </a:lnRef>
+          <a:fillRef idx="0">
+            <a:schemeClr val="accent1"/>
+          </a:fillRef>
+          <a:effectRef idx="1">
+            <a:schemeClr val="accent1"/>
+          </a:effectRef>
+          <a:fontRef idx="minor">
+            <a:schemeClr val="tx1"/>
+          </a:fontRef>
+        </p:style>
+      </p:cxnSp>
+      <p:sp>
+        <p:nvSpPr>
+          <p:cNvPr id="36" name="TextBox 35"/>
+          <p:cNvSpPr txBox="1"/>
+          <p:nvPr/>
+        </p:nvSpPr>
+        <p:spPr>
+          <a:xfrm>
+            <a:off x="2240280" y="16148304"/>
+            <a:ext cx="14813280" cy="566928"/>
+          </a:xfrm>
+          <a:prstGeom prst="rect">
+            <a:avLst/>
+          </a:prstGeom>
+          <a:noFill/>
+        </p:spPr>
+        <p:txBody>
+          <a:bodyPr wrap="square" anchor="t" lIns="0" rIns="0" tIns="0" bIns="0">
+            <a:spAutoFit/>
+          </a:bodyPr>
+          <a:lstStyle/>
+          <a:p>
+            <a:pPr algn="l">
+              <a:spcBef>
+                <a:spcPts val="0"/>
+              </a:spcBef>
+              <a:spcAft>
+                <a:spcPts val="0"/>
+              </a:spcAft>
+              <a:buNone/>
+            </a:pPr>
+            <a:r>
+              <a:rPr sz="2700" b="1" i="0">
+                <a:solidFill>
+                  <a:srgbClr val="313131"/>
+                </a:solidFill>
+                <a:latin typeface="NVIDIA Sans Medium"/>
+              </a:rPr>
+              <a:t>Largest dense video transformer in this peer set: 33B</a:t>
+            </a:r>
+          </a:p>
+        </p:txBody>
+      </p:sp>
+      <p:sp>
+        <p:nvSpPr>
+          <p:cNvPr id="37" name="TextBox 36"/>
+          <p:cNvSpPr txBox="1"/>
+          <p:nvPr/>
+        </p:nvSpPr>
+        <p:spPr>
+          <a:xfrm>
+            <a:off x="2240280" y="16843248"/>
+            <a:ext cx="14813280" cy="1417320"/>
+          </a:xfrm>
+          <a:prstGeom prst="rect">
+            <a:avLst/>
+          </a:prstGeom>
+          <a:noFill/>
+        </p:spPr>
+        <p:txBody>
+          <a:bodyPr wrap="square" anchor="t" lIns="0" rIns="0" tIns="0" bIns="0">
+            <a:spAutoFit/>
+          </a:bodyPr>
+          <a:lstStyle/>
+          <a:p>
+            <a:pPr algn="l">
+              <a:spcBef>
+                <a:spcPts val="0"/>
+              </a:spcBef>
+              <a:spcAft>
+                <a:spcPts val="0"/>
+              </a:spcAft>
+              <a:buNone/>
+            </a:pPr>
+            <a:r>
+              <a:rPr sz="2300" b="0" i="0">
+                <a:solidFill>
+                  <a:srgbClr val="757575"/>
+                </a:solidFill>
+                <a:latin typeface="NVIDIA Sans"/>
+              </a:rPr>
+              <a:t>At native 768p, the dense generator operates over long audio-video sequences; the initial open release uses full attention, making tensor throughput and memory movement first-order serving constraints.</a:t>
+            </a:r>
+          </a:p>
+        </p:txBody>
+      </p:sp>
+      <p:sp>
+        <p:nvSpPr>
+          <p:cNvPr id="38" name="TextBox 37"/>
+          <p:cNvSpPr txBox="1"/>
+          <p:nvPr/>
+        </p:nvSpPr>
+        <p:spPr>
+          <a:xfrm>
+            <a:off x="19202400" y="5532120"/>
+            <a:ext cx="15361920" cy="475488"/>
+          </a:xfrm>
+          <a:prstGeom prst="rect">
+            <a:avLst/>
+          </a:prstGeom>
+          <a:noFill/>
+        </p:spPr>
+        <p:txBody>
+          <a:bodyPr wrap="square" anchor="t" lIns="0" rIns="0" tIns="0" bIns="0">
+            <a:spAutoFit/>
+          </a:bodyPr>
+          <a:lstStyle/>
+          <a:p>
+            <a:pPr algn="l">
+              <a:spcBef>
+                <a:spcPts val="0"/>
+              </a:spcBef>
+              <a:spcAft>
+                <a:spcPts val="0"/>
+              </a:spcAft>
+              <a:buNone/>
+            </a:pPr>
+            <a:r>
+              <a:rPr sz="2800" b="1" i="0">
+                <a:solidFill>
+                  <a:srgbClr val="76B900"/>
+                </a:solidFill>
+                <a:latin typeface="NVIDIA Sans Medium"/>
+              </a:rPr>
+              <a:t>MINIMAX H3-BASE · OFFICIAL ARCHITECTURE</a:t>
+            </a:r>
+          </a:p>
+        </p:txBody>
+      </p:sp>
+      <p:sp>
+        <p:nvSpPr>
+          <p:cNvPr id="39" name="TextBox 38"/>
+          <p:cNvSpPr txBox="1"/>
+          <p:nvPr/>
+        </p:nvSpPr>
+        <p:spPr>
+          <a:xfrm>
+            <a:off x="19202400" y="6053328"/>
+            <a:ext cx="3703320" cy="420624"/>
+          </a:xfrm>
+          <a:prstGeom prst="rect">
+            <a:avLst/>
+          </a:prstGeom>
+          <a:noFill/>
+        </p:spPr>
+        <p:txBody>
+          <a:bodyPr wrap="square" anchor="ctr" lIns="0" rIns="0" tIns="0" bIns="0">
+            <a:spAutoFit/>
+          </a:bodyPr>
+          <a:lstStyle/>
+          <a:p>
+            <a:pPr algn="ctr">
+              <a:spcBef>
+                <a:spcPts val="0"/>
+              </a:spcBef>
+              <a:spcAft>
+                <a:spcPts val="0"/>
+              </a:spcAft>
+              <a:buNone/>
+            </a:pPr>
+            <a:r>
+              <a:rPr sz="2300" b="1" i="0">
+                <a:solidFill>
+                  <a:srgbClr val="952FC6"/>
+                </a:solidFill>
+                <a:latin typeface="NVIDIA Sans Medium"/>
+              </a:rPr>
+              <a:t>32B ENCODER</a:t>
+            </a:r>
+          </a:p>
+        </p:txBody>
+      </p:sp>
+      <p:cxnSp>
+        <p:nvCxnSpPr>
+          <p:cNvPr id="40" name="Connector 39"/>
+          <p:cNvCxnSpPr/>
+          <p:nvPr/>
+        </p:nvCxnSpPr>
+        <p:spPr>
+          <a:xfrm>
+            <a:off x="22951440" y="6263640"/>
+            <a:ext cx="749808" cy="0"/>
+          </a:xfrm>
+          <a:prstGeom prst="line">
+            <a:avLst/>
+          </a:prstGeom>
+          <a:ln w="16510">
+            <a:solidFill>
+              <a:srgbClr val="757575"/>
+            </a:solidFill>
+          </a:ln>
+        </p:spPr>
+        <p:style>
+          <a:lnRef idx="2">
+            <a:schemeClr val="accent1"/>
+          </a:lnRef>
+          <a:fillRef idx="0">
+            <a:schemeClr val="accent1"/>
+          </a:fillRef>
+          <a:effectRef idx="1">
+            <a:schemeClr val="accent1"/>
+          </a:effectRef>
+          <a:fontRef idx="minor">
+            <a:schemeClr val="tx1"/>
+          </a:fontRef>
+        </p:style>
+      </p:cxnSp>
+      <p:sp>
+        <p:nvSpPr>
+          <p:cNvPr id="41" name="Isosceles Triangle 40"/>
+          <p:cNvSpPr/>
+          <p:nvPr/>
+        </p:nvSpPr>
+        <p:spPr>
+          <a:xfrm rot="5400000">
+            <a:off x="23609808" y="6172200"/>
+            <a:ext cx="182880" cy="182880"/>
+          </a:xfrm>
+          <a:prstGeom prst="triangle">
+            <a:avLst/>
+          </a:prstGeom>
+          <a:solidFill>
+            <a:srgbClr val="757575"/>
+          </a:solidFill>
+          <a:ln>
+            <a:noFill/>
+          </a:ln>
+        </p:spPr>
+        <p:style>
+          <a:lnRef idx="1">
+            <a:schemeClr val="accent1"/>
+          </a:lnRef>
+          <a:fillRef idx="3">
+            <a:schemeClr val="accent1"/>
+          </a:fillRef>
+          <a:effectRef idx="2">
+            <a:schemeClr val="accent1"/>
+          </a:effectRef>
+          <a:fontRef idx="minor">
+            <a:schemeClr val="lt1"/>
+          </a:fontRef>
+        </p:style>
+        <p:txBody>
+          <a:bodyPr rtlCol="0" anchor="ctr"/>
+          <a:lstStyle/>
+          <a:p>
+            <a:pPr algn="ctr"/>
+          </a:p>
+        </p:txBody>
+      </p:sp>
+      <p:sp>
+        <p:nvSpPr>
+          <p:cNvPr id="42" name="TextBox 41"/>
+          <p:cNvSpPr txBox="1"/>
+          <p:nvPr/>
+        </p:nvSpPr>
+        <p:spPr>
+          <a:xfrm>
+            <a:off x="23865840" y="6053328"/>
+            <a:ext cx="5230368" cy="420624"/>
+          </a:xfrm>
+          <a:prstGeom prst="rect">
+            <a:avLst/>
+          </a:prstGeom>
+          <a:noFill/>
+        </p:spPr>
+        <p:txBody>
+          <a:bodyPr wrap="square" anchor="ctr" lIns="0" rIns="0" tIns="0" bIns="0">
+            <a:spAutoFit/>
+          </a:bodyPr>
+          <a:lstStyle/>
+          <a:p>
+            <a:pPr algn="ctr">
+              <a:spcBef>
+                <a:spcPts val="0"/>
+              </a:spcBef>
+              <a:spcAft>
+                <a:spcPts val="0"/>
+              </a:spcAft>
+              <a:buNone/>
+            </a:pPr>
+            <a:r>
+              <a:rPr sz="2300" b="1" i="0">
+                <a:solidFill>
+                  <a:srgbClr val="313131"/>
+                </a:solidFill>
+                <a:latin typeface="NVIDIA Sans Medium"/>
+              </a:rPr>
+              <a:t>33B DENSE DiT × 50</a:t>
+            </a:r>
+          </a:p>
+        </p:txBody>
+      </p:sp>
+      <p:cxnSp>
+        <p:nvCxnSpPr>
+          <p:cNvPr id="43" name="Connector 42"/>
+          <p:cNvCxnSpPr/>
+          <p:nvPr/>
+        </p:nvCxnSpPr>
+        <p:spPr>
+          <a:xfrm>
+            <a:off x="29141928" y="6263640"/>
+            <a:ext cx="731520" cy="0"/>
+          </a:xfrm>
+          <a:prstGeom prst="line">
+            <a:avLst/>
+          </a:prstGeom>
+          <a:ln w="16510">
+            <a:solidFill>
+              <a:srgbClr val="757575"/>
+            </a:solidFill>
+          </a:ln>
+        </p:spPr>
+        <p:style>
+          <a:lnRef idx="2">
+            <a:schemeClr val="accent1"/>
+          </a:lnRef>
+          <a:fillRef idx="0">
+            <a:schemeClr val="accent1"/>
+          </a:fillRef>
+          <a:effectRef idx="1">
+            <a:schemeClr val="accent1"/>
+          </a:effectRef>
+          <a:fontRef idx="minor">
+            <a:schemeClr val="tx1"/>
+          </a:fontRef>
+        </p:style>
+      </p:cxnSp>
+      <p:sp>
+        <p:nvSpPr>
+          <p:cNvPr id="44" name="Isosceles Triangle 43"/>
+          <p:cNvSpPr/>
+          <p:nvPr/>
+        </p:nvSpPr>
+        <p:spPr>
+          <a:xfrm rot="5400000">
+            <a:off x="29782008" y="6172200"/>
+            <a:ext cx="182880" cy="182880"/>
+          </a:xfrm>
+          <a:prstGeom prst="triangle">
+            <a:avLst/>
+          </a:prstGeom>
+          <a:solidFill>
+            <a:srgbClr val="757575"/>
+          </a:solidFill>
+          <a:ln>
+            <a:noFill/>
+          </a:ln>
+        </p:spPr>
+        <p:style>
+          <a:lnRef idx="1">
+            <a:schemeClr val="accent1"/>
+          </a:lnRef>
+          <a:fillRef idx="3">
+            <a:schemeClr val="accent1"/>
+          </a:fillRef>
+          <a:effectRef idx="2">
+            <a:schemeClr val="accent1"/>
+          </a:effectRef>
+          <a:fontRef idx="minor">
+            <a:schemeClr val="lt1"/>
+          </a:fontRef>
+        </p:style>
+        <p:txBody>
+          <a:bodyPr rtlCol="0" anchor="ctr"/>
+          <a:lstStyle/>
+          <a:p>
+            <a:pPr algn="ctr"/>
+          </a:p>
+        </p:txBody>
+      </p:sp>
+      <p:sp>
+        <p:nvSpPr>
+          <p:cNvPr id="45" name="TextBox 44"/>
+          <p:cNvSpPr txBox="1"/>
+          <p:nvPr/>
+        </p:nvSpPr>
+        <p:spPr>
+          <a:xfrm>
+            <a:off x="30038040" y="6053328"/>
+            <a:ext cx="4709160" cy="420624"/>
+          </a:xfrm>
+          <a:prstGeom prst="rect">
+            <a:avLst/>
+          </a:prstGeom>
+          <a:noFill/>
+        </p:spPr>
+        <p:txBody>
+          <a:bodyPr wrap="square" anchor="ctr" lIns="0" rIns="0" tIns="0" bIns="0">
+            <a:spAutoFit/>
+          </a:bodyPr>
+          <a:lstStyle/>
+          <a:p>
+            <a:pPr algn="ctr">
+              <a:spcBef>
+                <a:spcPts val="0"/>
+              </a:spcBef>
+              <a:spcAft>
+                <a:spcPts val="0"/>
+              </a:spcAft>
+              <a:buNone/>
+            </a:pPr>
+            <a:r>
+              <a:rPr sz="2300" b="1" i="0">
+                <a:solidFill>
+                  <a:srgbClr val="1DBBA4"/>
+                </a:solidFill>
+                <a:latin typeface="NVIDIA Sans Medium"/>
+              </a:rPr>
+              <a:t>VISUAL + AUDIO VAE</a:t>
             </a:r>
           </a:p>
         </p:txBody>
       </p:sp>
       <p:pic>
         <p:nvPicPr>
-          <p:cNvPr id="9" name="Picture 8" descr="minimax-h3-system-overview-official.jpeg"/>
+          <p:cNvPr id="46" name="Picture 45" descr="minimax-h3-full-arch-official.png"/>
           <p:cNvPicPr>
             <a:picLocks noChangeAspect="1"/>
           </p:cNvPicPr>
@@ -34563,14 +36053,221 @@
         </p:blipFill>
         <p:spPr>
           <a:xfrm>
-            <a:off x="2393626" y="4709160"/>
-            <a:ext cx="31788747" cy="11750040"/>
+            <a:off x="18973800" y="6629739"/>
+            <a:ext cx="16002000" cy="8887289"/>
           </a:xfrm>
           <a:prstGeom prst="rect">
             <a:avLst/>
           </a:prstGeom>
         </p:spPr>
       </p:pic>
+      <p:cxnSp>
+        <p:nvCxnSpPr>
+          <p:cNvPr id="47" name="Connector 46"/>
+          <p:cNvCxnSpPr/>
+          <p:nvPr/>
+        </p:nvCxnSpPr>
+        <p:spPr>
+          <a:xfrm>
+            <a:off x="19202400" y="15782544"/>
+            <a:ext cx="15544800" cy="0"/>
+          </a:xfrm>
+          <a:prstGeom prst="line">
+            <a:avLst/>
+          </a:prstGeom>
+          <a:ln w="12700">
+            <a:solidFill>
+              <a:srgbClr val="D9D9D9"/>
+            </a:solidFill>
+          </a:ln>
+        </p:spPr>
+        <p:style>
+          <a:lnRef idx="2">
+            <a:schemeClr val="accent1"/>
+          </a:lnRef>
+          <a:fillRef idx="0">
+            <a:schemeClr val="accent1"/>
+          </a:fillRef>
+          <a:effectRef idx="1">
+            <a:schemeClr val="accent1"/>
+          </a:effectRef>
+          <a:fontRef idx="minor">
+            <a:schemeClr val="tx1"/>
+          </a:fontRef>
+        </p:style>
+      </p:cxnSp>
+      <p:sp>
+        <p:nvSpPr>
+          <p:cNvPr id="48" name="TextBox 47"/>
+          <p:cNvSpPr txBox="1"/>
+          <p:nvPr/>
+        </p:nvSpPr>
+        <p:spPr>
+          <a:xfrm>
+            <a:off x="19202400" y="16047720"/>
+            <a:ext cx="4937760" cy="475488"/>
+          </a:xfrm>
+          <a:prstGeom prst="rect">
+            <a:avLst/>
+          </a:prstGeom>
+          <a:noFill/>
+        </p:spPr>
+        <p:txBody>
+          <a:bodyPr wrap="square" anchor="t" lIns="0" rIns="0" tIns="0" bIns="0">
+            <a:spAutoFit/>
+          </a:bodyPr>
+          <a:lstStyle/>
+          <a:p>
+            <a:pPr algn="l">
+              <a:spcBef>
+                <a:spcPts val="0"/>
+              </a:spcBef>
+              <a:spcAft>
+                <a:spcPts val="0"/>
+              </a:spcAft>
+              <a:buNone/>
+            </a:pPr>
+            <a:r>
+              <a:rPr sz="2800" b="1" i="0">
+                <a:solidFill>
+                  <a:srgbClr val="EF9100"/>
+                </a:solidFill>
+                <a:latin typeface="NVIDIA Sans Medium"/>
+              </a:rPr>
+              <a:t>MODEL RESIDENCY</a:t>
+            </a:r>
+          </a:p>
+        </p:txBody>
+      </p:sp>
+      <p:sp>
+        <p:nvSpPr>
+          <p:cNvPr id="49" name="TextBox 48"/>
+          <p:cNvSpPr txBox="1"/>
+          <p:nvPr/>
+        </p:nvSpPr>
+        <p:spPr>
+          <a:xfrm>
+            <a:off x="19202400" y="16568928"/>
+            <a:ext cx="4754880" cy="950976"/>
+          </a:xfrm>
+          <a:prstGeom prst="rect">
+            <a:avLst/>
+          </a:prstGeom>
+          <a:noFill/>
+        </p:spPr>
+        <p:txBody>
+          <a:bodyPr wrap="square" anchor="ctr" lIns="0" rIns="0" tIns="0" bIns="0">
+            <a:spAutoFit/>
+          </a:bodyPr>
+          <a:lstStyle/>
+          <a:p>
+            <a:pPr algn="l">
+              <a:spcBef>
+                <a:spcPts val="0"/>
+              </a:spcBef>
+              <a:spcAft>
+                <a:spcPts val="0"/>
+              </a:spcAft>
+              <a:buNone/>
+            </a:pPr>
+            <a:r>
+              <a:rPr sz="4800" b="1" i="0">
+                <a:solidFill>
+                  <a:srgbClr val="EF9100"/>
+                </a:solidFill>
+                <a:latin typeface="NVIDIA Sans Medium"/>
+              </a:rPr>
+              <a:t>≈130 GB</a:t>
+            </a:r>
+          </a:p>
+        </p:txBody>
+      </p:sp>
+      <p:sp>
+        <p:nvSpPr>
+          <p:cNvPr id="50" name="TextBox 49"/>
+          <p:cNvSpPr txBox="1"/>
+          <p:nvPr/>
+        </p:nvSpPr>
+        <p:spPr>
+          <a:xfrm>
+            <a:off x="23911560" y="16559784"/>
+            <a:ext cx="10835640" cy="1078992"/>
+          </a:xfrm>
+          <a:prstGeom prst="rect">
+            <a:avLst/>
+          </a:prstGeom>
+          <a:noFill/>
+        </p:spPr>
+        <p:txBody>
+          <a:bodyPr wrap="square" anchor="ctr" lIns="0" rIns="0" tIns="0" bIns="0">
+            <a:spAutoFit/>
+          </a:bodyPr>
+          <a:lstStyle/>
+          <a:p>
+            <a:pPr algn="l">
+              <a:spcBef>
+                <a:spcPts val="0"/>
+              </a:spcBef>
+              <a:spcAft>
+                <a:spcPts val="0"/>
+              </a:spcAft>
+              <a:buNone/>
+            </a:pPr>
+            <a:r>
+              <a:rPr sz="2300" b="0" i="0">
+                <a:solidFill>
+                  <a:srgbClr val="313131"/>
+                </a:solidFill>
+                <a:latin typeface="NVIDIA Sans"/>
+              </a:rPr>
+              <a:t>raw BF16 weights for the 32B encoder + 33B generator—about 1.8× one 72 GB GPU—before Visual/Audio VAE, activations, attention workspace, and graph pools</a:t>
+            </a:r>
+          </a:p>
+        </p:txBody>
+      </p:sp>
+      <p:sp>
+        <p:nvSpPr>
+          <p:cNvPr id="51" name="TextBox 50"/>
+          <p:cNvSpPr txBox="1"/>
+          <p:nvPr/>
+        </p:nvSpPr>
+        <p:spPr>
+          <a:xfrm>
+            <a:off x="19202400" y="17785080"/>
+            <a:ext cx="15544800" cy="841248"/>
+          </a:xfrm>
+          <a:prstGeom prst="rect">
+            <a:avLst/>
+          </a:prstGeom>
+          <a:noFill/>
+        </p:spPr>
+        <p:txBody>
+          <a:bodyPr wrap="square" anchor="t" lIns="0" rIns="0" tIns="0" bIns="0">
+            <a:spAutoFit/>
+          </a:bodyPr>
+          <a:lstStyle/>
+          <a:p>
+            <a:pPr algn="l">
+              <a:spcBef>
+                <a:spcPts val="0"/>
+              </a:spcBef>
+              <a:spcAft>
+                <a:spcPts val="0"/>
+              </a:spcAft>
+              <a:buNone/>
+            </a:pPr>
+            <a:r>
+              <a:rPr sz="2000" b="0" i="0">
+                <a:solidFill>
+                  <a:srgbClr val="757575"/>
+                </a:solidFill>
+                <a:latin typeface="NVIDIA Sans"/>
+              </a:rPr>
+              <a:t>Stage placement, precision, offload, and workspace reuse are therefore part of performance. About 13B H3 AdaLN parameters can be precomputed and cached for inference-only deployment.</a:t>
+            </a:r>
+          </a:p>
+        </p:txBody>
+      </p:sp>
     </p:spTree>
   </p:cSld>
   <p:clrMapOvr>

</xml_diff>